<commit_message>
docs(submission): polish deck layout — vertically center card content (slides 2,7,8)
Visual audit via rendered PNGs: cards on the summary/levers/robustness slides had
empty bottom space (top-aligned text). Center card content vertically + tighten
heights for balanced padding. Typography (Calibri), 0.7in left margin, assertion
headlines, and Vietnamese rendering all verified clean at 1600x900.

Co-Authored-By: Claude Opus 4.8 (1M context) <noreply@anthropic.com>
</commit_message>
<xml_diff>
--- a/docs/Neko-Core-Thuyet-minh-phuong-phap.pptx
+++ b/docs/Neko-Core-Thuyet-minh-phuong-phap.pptx
@@ -5778,8 +5778,8 @@
         </p:nvSpPr>
         <p:spPr>
           <a:xfrm>
-            <a:off x="640080" y="2011680"/>
-            <a:ext cx="3520440" cy="3291840"/>
+            <a:off x="640080" y="2057400"/>
+            <a:ext cx="3520440" cy="2880360"/>
           </a:xfrm>
           <a:prstGeom prst="rect">
             <a:avLst/>
@@ -5824,7 +5824,7 @@
         </p:nvSpPr>
         <p:spPr>
           <a:xfrm>
-            <a:off x="640080" y="2011680"/>
+            <a:off x="640080" y="2057400"/>
             <a:ext cx="3520440" cy="146304"/>
           </a:xfrm>
           <a:prstGeom prst="rect">
@@ -5868,8 +5868,8 @@
         </p:nvSpPr>
         <p:spPr>
           <a:xfrm>
-            <a:off x="896112" y="2331720"/>
-            <a:ext cx="3063240" cy="640080"/>
+            <a:off x="932688" y="2240280"/>
+            <a:ext cx="2971800" cy="2560320"/>
           </a:xfrm>
           <a:prstGeom prst="rect">
             <a:avLst/>
@@ -5877,7 +5877,7 @@
           <a:noFill/>
         </p:spPr>
         <p:txBody>
-          <a:bodyPr wrap="square" anchor="t">
+          <a:bodyPr wrap="square" anchor="ctr">
             <a:spAutoFit/>
           </a:bodyPr>
           <a:lstStyle/>
@@ -5887,7 +5887,7 @@
                 <a:spcPts val="0"/>
               </a:spcBef>
               <a:spcAft>
-                <a:spcPts val="300"/>
+                <a:spcPts val="400"/>
               </a:spcAft>
             </a:pPr>
             <a:r>
@@ -5900,36 +5900,32 @@
               <a:t>Engine đo‑thật</a:t>
             </a:r>
           </a:p>
-        </p:txBody>
-      </p:sp>
-      <p:sp>
-        <p:nvSpPr>
-          <p:cNvPr id="9" name="TextBox 8"/>
-          <p:cNvSpPr txBox="1"/>
-          <p:nvPr/>
-        </p:nvSpPr>
-        <p:spPr>
-          <a:xfrm>
-            <a:off x="896112" y="3063240"/>
-            <a:ext cx="3063240" cy="2103120"/>
-          </a:xfrm>
-          <a:prstGeom prst="rect">
-            <a:avLst/>
-          </a:prstGeom>
-          <a:noFill/>
-        </p:spPr>
-        <p:txBody>
-          <a:bodyPr wrap="square" anchor="t">
-            <a:spAutoFit/>
-          </a:bodyPr>
-          <a:lstStyle/>
           <a:p>
             <a:pPr algn="l">
               <a:spcBef>
                 <a:spcPts val="0"/>
               </a:spcBef>
               <a:spcAft>
-                <a:spcPts val="300"/>
+                <a:spcPts val="400"/>
+              </a:spcAft>
+            </a:pPr>
+            <a:r>
+              <a:rPr sz="900" b="0" i="0">
+                <a:solidFill>
+                  <a:srgbClr val="1F2937"/>
+                </a:solidFill>
+                <a:latin typeface="Calibri"/>
+              </a:rPr>
+              <a:t/>
+            </a:r>
+          </a:p>
+          <a:p>
+            <a:pPr algn="l">
+              <a:spcBef>
+                <a:spcPts val="0"/>
+              </a:spcBef>
+              <a:spcAft>
+                <a:spcPts val="400"/>
               </a:spcAft>
             </a:pPr>
             <a:r>
@@ -5946,14 +5942,14 @@
       </p:sp>
       <p:sp>
         <p:nvSpPr>
-          <p:cNvPr id="10" name="Rectangle 9"/>
+          <p:cNvPr id="9" name="Rectangle 8"/>
           <p:cNvSpPr/>
           <p:nvPr/>
         </p:nvSpPr>
         <p:spPr>
           <a:xfrm>
-            <a:off x="4361688" y="2011680"/>
-            <a:ext cx="3520440" cy="3291840"/>
+            <a:off x="4361688" y="2057400"/>
+            <a:ext cx="3520440" cy="2880360"/>
           </a:xfrm>
           <a:prstGeom prst="rect">
             <a:avLst/>
@@ -5992,13 +5988,13 @@
       </p:sp>
       <p:sp>
         <p:nvSpPr>
-          <p:cNvPr id="11" name="Rectangle 10"/>
+          <p:cNvPr id="10" name="Rectangle 9"/>
           <p:cNvSpPr/>
           <p:nvPr/>
         </p:nvSpPr>
         <p:spPr>
           <a:xfrm>
-            <a:off x="4361688" y="2011680"/>
+            <a:off x="4361688" y="2057400"/>
             <a:ext cx="3520440" cy="146304"/>
           </a:xfrm>
           <a:prstGeom prst="rect">
@@ -6036,14 +6032,14 @@
       </p:sp>
       <p:sp>
         <p:nvSpPr>
-          <p:cNvPr id="12" name="TextBox 11"/>
+          <p:cNvPr id="11" name="TextBox 10"/>
           <p:cNvSpPr txBox="1"/>
           <p:nvPr/>
         </p:nvSpPr>
         <p:spPr>
           <a:xfrm>
-            <a:off x="4617720" y="2331720"/>
-            <a:ext cx="3063240" cy="640080"/>
+            <a:off x="4654296" y="2240280"/>
+            <a:ext cx="2971800" cy="2560320"/>
           </a:xfrm>
           <a:prstGeom prst="rect">
             <a:avLst/>
@@ -6051,7 +6047,7 @@
           <a:noFill/>
         </p:spPr>
         <p:txBody>
-          <a:bodyPr wrap="square" anchor="t">
+          <a:bodyPr wrap="square" anchor="ctr">
             <a:spAutoFit/>
           </a:bodyPr>
           <a:lstStyle/>
@@ -6061,7 +6057,7 @@
                 <a:spcPts val="0"/>
               </a:spcBef>
               <a:spcAft>
-                <a:spcPts val="300"/>
+                <a:spcPts val="400"/>
               </a:spcAft>
             </a:pPr>
             <a:r>
@@ -6074,36 +6070,32 @@
               <a:t>Bất khả xâm phạm</a:t>
             </a:r>
           </a:p>
-        </p:txBody>
-      </p:sp>
-      <p:sp>
-        <p:nvSpPr>
-          <p:cNvPr id="13" name="TextBox 12"/>
-          <p:cNvSpPr txBox="1"/>
-          <p:nvPr/>
-        </p:nvSpPr>
-        <p:spPr>
-          <a:xfrm>
-            <a:off x="4617720" y="3063240"/>
-            <a:ext cx="3063240" cy="2103120"/>
-          </a:xfrm>
-          <a:prstGeom prst="rect">
-            <a:avLst/>
-          </a:prstGeom>
-          <a:noFill/>
-        </p:spPr>
-        <p:txBody>
-          <a:bodyPr wrap="square" anchor="t">
-            <a:spAutoFit/>
-          </a:bodyPr>
-          <a:lstStyle/>
           <a:p>
             <a:pPr algn="l">
               <a:spcBef>
                 <a:spcPts val="0"/>
               </a:spcBef>
               <a:spcAft>
-                <a:spcPts val="300"/>
+                <a:spcPts val="400"/>
+              </a:spcAft>
+            </a:pPr>
+            <a:r>
+              <a:rPr sz="900" b="0" i="0">
+                <a:solidFill>
+                  <a:srgbClr val="1F2937"/>
+                </a:solidFill>
+                <a:latin typeface="Calibri"/>
+              </a:rPr>
+              <a:t/>
+            </a:r>
+          </a:p>
+          <a:p>
+            <a:pPr algn="l">
+              <a:spcBef>
+                <a:spcPts val="0"/>
+              </a:spcBef>
+              <a:spcAft>
+                <a:spcPts val="400"/>
               </a:spcAft>
             </a:pPr>
             <a:r>
@@ -6120,14 +6112,14 @@
       </p:sp>
       <p:sp>
         <p:nvSpPr>
-          <p:cNvPr id="14" name="Rectangle 13"/>
+          <p:cNvPr id="12" name="Rectangle 11"/>
           <p:cNvSpPr/>
           <p:nvPr/>
         </p:nvSpPr>
         <p:spPr>
           <a:xfrm>
-            <a:off x="8083296" y="2011680"/>
-            <a:ext cx="3520440" cy="3291840"/>
+            <a:off x="8083296" y="2057400"/>
+            <a:ext cx="3520440" cy="2880360"/>
           </a:xfrm>
           <a:prstGeom prst="rect">
             <a:avLst/>
@@ -6166,13 +6158,13 @@
       </p:sp>
       <p:sp>
         <p:nvSpPr>
-          <p:cNvPr id="15" name="Rectangle 14"/>
+          <p:cNvPr id="13" name="Rectangle 12"/>
           <p:cNvSpPr/>
           <p:nvPr/>
         </p:nvSpPr>
         <p:spPr>
           <a:xfrm>
-            <a:off x="8083296" y="2011680"/>
+            <a:off x="8083296" y="2057400"/>
             <a:ext cx="3520440" cy="146304"/>
           </a:xfrm>
           <a:prstGeom prst="rect">
@@ -6210,14 +6202,94 @@
       </p:sp>
       <p:sp>
         <p:nvSpPr>
-          <p:cNvPr id="16" name="TextBox 15"/>
+          <p:cNvPr id="14" name="TextBox 13"/>
           <p:cNvSpPr txBox="1"/>
           <p:nvPr/>
         </p:nvSpPr>
         <p:spPr>
           <a:xfrm>
-            <a:off x="8339327" y="2331720"/>
-            <a:ext cx="3063240" cy="640080"/>
+            <a:off x="8375904" y="2240280"/>
+            <a:ext cx="2971800" cy="2560320"/>
+          </a:xfrm>
+          <a:prstGeom prst="rect">
+            <a:avLst/>
+          </a:prstGeom>
+          <a:noFill/>
+        </p:spPr>
+        <p:txBody>
+          <a:bodyPr wrap="square" anchor="ctr">
+            <a:spAutoFit/>
+          </a:bodyPr>
+          <a:lstStyle/>
+          <a:p>
+            <a:pPr algn="l">
+              <a:spcBef>
+                <a:spcPts val="0"/>
+              </a:spcBef>
+              <a:spcAft>
+                <a:spcPts val="400"/>
+              </a:spcAft>
+            </a:pPr>
+            <a:r>
+              <a:rPr sz="1700" b="1" i="0">
+                <a:solidFill>
+                  <a:srgbClr val="C2550B"/>
+                </a:solidFill>
+                <a:latin typeface="Calibri"/>
+              </a:rPr>
+              <a:t>Nhanh &amp; khả thi</a:t>
+            </a:r>
+          </a:p>
+          <a:p>
+            <a:pPr algn="l">
+              <a:spcBef>
+                <a:spcPts val="0"/>
+              </a:spcBef>
+              <a:spcAft>
+                <a:spcPts val="400"/>
+              </a:spcAft>
+            </a:pPr>
+            <a:r>
+              <a:rPr sz="900" b="0" i="0">
+                <a:solidFill>
+                  <a:srgbClr val="1F2937"/>
+                </a:solidFill>
+                <a:latin typeface="Calibri"/>
+              </a:rPr>
+              <a:t/>
+            </a:r>
+          </a:p>
+          <a:p>
+            <a:pPr algn="l">
+              <a:spcBef>
+                <a:spcPts val="0"/>
+              </a:spcBef>
+              <a:spcAft>
+                <a:spcPts val="400"/>
+              </a:spcAft>
+            </a:pPr>
+            <a:r>
+              <a:rPr sz="1300" b="0" i="0">
+                <a:solidFill>
+                  <a:srgbClr val="1F2937"/>
+                </a:solidFill>
+                <a:latin typeface="Calibri"/>
+              </a:rPr>
+              <a:t>MoE ~4B active + núm token phẳng → 2000 câu ~1.5h, điểm Time an toàn. MTP lossless để dành tăng tốc 1.4–2.2×.</a:t>
+            </a:r>
+          </a:p>
+        </p:txBody>
+      </p:sp>
+      <p:sp>
+        <p:nvSpPr>
+          <p:cNvPr id="15" name="TextBox 14"/>
+          <p:cNvSpPr txBox="1"/>
+          <p:nvPr/>
+        </p:nvSpPr>
+        <p:spPr>
+          <a:xfrm>
+            <a:off x="640080" y="5532120"/>
+            <a:ext cx="10972800" cy="640080"/>
           </a:xfrm>
           <a:prstGeom prst="rect">
             <a:avLst/>
@@ -6239,90 +6311,6 @@
               </a:spcAft>
             </a:pPr>
             <a:r>
-              <a:rPr sz="1700" b="1" i="0">
-                <a:solidFill>
-                  <a:srgbClr val="C2550B"/>
-                </a:solidFill>
-                <a:latin typeface="Calibri"/>
-              </a:rPr>
-              <a:t>Nhanh &amp; khả thi</a:t>
-            </a:r>
-          </a:p>
-        </p:txBody>
-      </p:sp>
-      <p:sp>
-        <p:nvSpPr>
-          <p:cNvPr id="17" name="TextBox 16"/>
-          <p:cNvSpPr txBox="1"/>
-          <p:nvPr/>
-        </p:nvSpPr>
-        <p:spPr>
-          <a:xfrm>
-            <a:off x="8339327" y="3063240"/>
-            <a:ext cx="3063240" cy="2103120"/>
-          </a:xfrm>
-          <a:prstGeom prst="rect">
-            <a:avLst/>
-          </a:prstGeom>
-          <a:noFill/>
-        </p:spPr>
-        <p:txBody>
-          <a:bodyPr wrap="square" anchor="t">
-            <a:spAutoFit/>
-          </a:bodyPr>
-          <a:lstStyle/>
-          <a:p>
-            <a:pPr algn="l">
-              <a:spcBef>
-                <a:spcPts val="0"/>
-              </a:spcBef>
-              <a:spcAft>
-                <a:spcPts val="300"/>
-              </a:spcAft>
-            </a:pPr>
-            <a:r>
-              <a:rPr sz="1300" b="0" i="0">
-                <a:solidFill>
-                  <a:srgbClr val="1F2937"/>
-                </a:solidFill>
-                <a:latin typeface="Calibri"/>
-              </a:rPr>
-              <a:t>MoE ~4B active + núm token phẳng → 2000 câu ~1.5h, điểm Time an toàn. MTP lossless để dành tăng tốc 1.4–2.2×.</a:t>
-            </a:r>
-          </a:p>
-        </p:txBody>
-      </p:sp>
-      <p:sp>
-        <p:nvSpPr>
-          <p:cNvPr id="18" name="TextBox 17"/>
-          <p:cNvSpPr txBox="1"/>
-          <p:nvPr/>
-        </p:nvSpPr>
-        <p:spPr>
-          <a:xfrm>
-            <a:off x="640080" y="5577840"/>
-            <a:ext cx="10972800" cy="548640"/>
-          </a:xfrm>
-          <a:prstGeom prst="rect">
-            <a:avLst/>
-          </a:prstGeom>
-          <a:noFill/>
-        </p:spPr>
-        <p:txBody>
-          <a:bodyPr wrap="square" anchor="t">
-            <a:spAutoFit/>
-          </a:bodyPr>
-          <a:lstStyle/>
-          <a:p>
-            <a:pPr algn="l">
-              <a:spcBef>
-                <a:spcPts val="0"/>
-              </a:spcBef>
-              <a:spcAft>
-                <a:spcPts val="300"/>
-              </a:spcAft>
-            </a:pPr>
-            <a:r>
               <a:rPr sz="1250" b="0" i="1">
                 <a:solidFill>
                   <a:srgbClr val="6B7280"/>
@@ -6336,7 +6324,7 @@
       </p:sp>
       <p:sp>
         <p:nvSpPr>
-          <p:cNvPr id="19" name="TextBox 18"/>
+          <p:cNvPr id="16" name="TextBox 15"/>
           <p:cNvSpPr txBox="1"/>
           <p:nvPr/>
         </p:nvSpPr>
@@ -10164,8 +10152,8 @@
         </p:nvSpPr>
         <p:spPr>
           <a:xfrm>
-            <a:off x="640080" y="2057400"/>
-            <a:ext cx="3520440" cy="1691640"/>
+            <a:off x="640080" y="2148840"/>
+            <a:ext cx="3520440" cy="1645920"/>
           </a:xfrm>
           <a:prstGeom prst="rect">
             <a:avLst/>
@@ -10210,7 +10198,7 @@
         </p:nvSpPr>
         <p:spPr>
           <a:xfrm>
-            <a:off x="640080" y="2057400"/>
+            <a:off x="640080" y="2148840"/>
             <a:ext cx="3520440" cy="91440"/>
           </a:xfrm>
           <a:prstGeom prst="rect">
@@ -10254,8 +10242,8 @@
         </p:nvSpPr>
         <p:spPr>
           <a:xfrm>
-            <a:off x="868680" y="2286000"/>
-            <a:ext cx="3108960" cy="457200"/>
+            <a:off x="896112" y="2240280"/>
+            <a:ext cx="3035808" cy="1463040"/>
           </a:xfrm>
           <a:prstGeom prst="rect">
             <a:avLst/>
@@ -10263,7 +10251,7 @@
           <a:noFill/>
         </p:spPr>
         <p:txBody>
-          <a:bodyPr wrap="square" anchor="t">
+          <a:bodyPr wrap="square" anchor="ctr">
             <a:spAutoFit/>
           </a:bodyPr>
           <a:lstStyle/>
@@ -10273,7 +10261,7 @@
                 <a:spcPts val="0"/>
               </a:spcBef>
               <a:spcAft>
-                <a:spcPts val="300"/>
+                <a:spcPts val="400"/>
               </a:spcAft>
             </a:pPr>
             <a:r>
@@ -10286,36 +10274,32 @@
               <a:t>Chain‑of‑thought</a:t>
             </a:r>
           </a:p>
-        </p:txBody>
-      </p:sp>
-      <p:sp>
-        <p:nvSpPr>
-          <p:cNvPr id="9" name="TextBox 8"/>
-          <p:cNvSpPr txBox="1"/>
-          <p:nvPr/>
-        </p:nvSpPr>
-        <p:spPr>
-          <a:xfrm>
-            <a:off x="868680" y="2788920"/>
-            <a:ext cx="3108960" cy="914400"/>
-          </a:xfrm>
-          <a:prstGeom prst="rect">
-            <a:avLst/>
-          </a:prstGeom>
-          <a:noFill/>
-        </p:spPr>
-        <p:txBody>
-          <a:bodyPr wrap="square" anchor="t">
-            <a:spAutoFit/>
-          </a:bodyPr>
-          <a:lstStyle/>
           <a:p>
             <a:pPr algn="l">
               <a:spcBef>
                 <a:spcPts val="0"/>
               </a:spcBef>
               <a:spcAft>
-                <a:spcPts val="300"/>
+                <a:spcPts val="400"/>
+              </a:spcAft>
+            </a:pPr>
+            <a:r>
+              <a:rPr sz="600" b="0" i="0">
+                <a:solidFill>
+                  <a:srgbClr val="1F2937"/>
+                </a:solidFill>
+                <a:latin typeface="Calibri"/>
+              </a:rPr>
+              <a:t/>
+            </a:r>
+          </a:p>
+          <a:p>
+            <a:pPr algn="l">
+              <a:spcBef>
+                <a:spcPts val="0"/>
+              </a:spcBef>
+              <a:spcAft>
+                <a:spcPts val="400"/>
               </a:spcAft>
             </a:pPr>
             <a:r>
@@ -10332,14 +10316,14 @@
       </p:sp>
       <p:sp>
         <p:nvSpPr>
-          <p:cNvPr id="10" name="Rectangle 9"/>
+          <p:cNvPr id="9" name="Rectangle 8"/>
           <p:cNvSpPr/>
           <p:nvPr/>
         </p:nvSpPr>
         <p:spPr>
           <a:xfrm>
-            <a:off x="4361688" y="2057400"/>
-            <a:ext cx="3520440" cy="1691640"/>
+            <a:off x="4361688" y="2148840"/>
+            <a:ext cx="3520440" cy="1645920"/>
           </a:xfrm>
           <a:prstGeom prst="rect">
             <a:avLst/>
@@ -10378,13 +10362,13 @@
       </p:sp>
       <p:sp>
         <p:nvSpPr>
-          <p:cNvPr id="11" name="Rectangle 10"/>
+          <p:cNvPr id="10" name="Rectangle 9"/>
           <p:cNvSpPr/>
           <p:nvPr/>
         </p:nvSpPr>
         <p:spPr>
           <a:xfrm>
-            <a:off x="4361688" y="2057400"/>
+            <a:off x="4361688" y="2148840"/>
             <a:ext cx="3520440" cy="91440"/>
           </a:xfrm>
           <a:prstGeom prst="rect">
@@ -10422,14 +10406,14 @@
       </p:sp>
       <p:sp>
         <p:nvSpPr>
-          <p:cNvPr id="12" name="TextBox 11"/>
+          <p:cNvPr id="11" name="TextBox 10"/>
           <p:cNvSpPr txBox="1"/>
           <p:nvPr/>
         </p:nvSpPr>
         <p:spPr>
           <a:xfrm>
-            <a:off x="4590288" y="2286000"/>
-            <a:ext cx="3108960" cy="457200"/>
+            <a:off x="4617720" y="2240280"/>
+            <a:ext cx="3035808" cy="1463040"/>
           </a:xfrm>
           <a:prstGeom prst="rect">
             <a:avLst/>
@@ -10437,7 +10421,7 @@
           <a:noFill/>
         </p:spPr>
         <p:txBody>
-          <a:bodyPr wrap="square" anchor="t">
+          <a:bodyPr wrap="square" anchor="ctr">
             <a:spAutoFit/>
           </a:bodyPr>
           <a:lstStyle/>
@@ -10447,7 +10431,7 @@
                 <a:spcPts val="0"/>
               </a:spcBef>
               <a:spcAft>
-                <a:spcPts val="300"/>
+                <a:spcPts val="400"/>
               </a:spcAft>
             </a:pPr>
             <a:r>
@@ -10460,36 +10444,32 @@
               <a:t>Self‑consistency</a:t>
             </a:r>
           </a:p>
-        </p:txBody>
-      </p:sp>
-      <p:sp>
-        <p:nvSpPr>
-          <p:cNvPr id="13" name="TextBox 12"/>
-          <p:cNvSpPr txBox="1"/>
-          <p:nvPr/>
-        </p:nvSpPr>
-        <p:spPr>
-          <a:xfrm>
-            <a:off x="4590288" y="2788920"/>
-            <a:ext cx="3108960" cy="914400"/>
-          </a:xfrm>
-          <a:prstGeom prst="rect">
-            <a:avLst/>
-          </a:prstGeom>
-          <a:noFill/>
-        </p:spPr>
-        <p:txBody>
-          <a:bodyPr wrap="square" anchor="t">
-            <a:spAutoFit/>
-          </a:bodyPr>
-          <a:lstStyle/>
           <a:p>
             <a:pPr algn="l">
               <a:spcBef>
                 <a:spcPts val="0"/>
               </a:spcBef>
               <a:spcAft>
-                <a:spcPts val="300"/>
+                <a:spcPts val="400"/>
+              </a:spcAft>
+            </a:pPr>
+            <a:r>
+              <a:rPr sz="600" b="0" i="0">
+                <a:solidFill>
+                  <a:srgbClr val="1F2937"/>
+                </a:solidFill>
+                <a:latin typeface="Calibri"/>
+              </a:rPr>
+              <a:t/>
+            </a:r>
+          </a:p>
+          <a:p>
+            <a:pPr algn="l">
+              <a:spcBef>
+                <a:spcPts val="0"/>
+              </a:spcBef>
+              <a:spcAft>
+                <a:spcPts val="400"/>
               </a:spcAft>
             </a:pPr>
             <a:r>
@@ -10506,14 +10486,14 @@
       </p:sp>
       <p:sp>
         <p:nvSpPr>
-          <p:cNvPr id="14" name="Rectangle 13"/>
+          <p:cNvPr id="12" name="Rectangle 11"/>
           <p:cNvSpPr/>
           <p:nvPr/>
         </p:nvSpPr>
         <p:spPr>
           <a:xfrm>
-            <a:off x="8083296" y="2057400"/>
-            <a:ext cx="3520440" cy="1691640"/>
+            <a:off x="8083296" y="2148840"/>
+            <a:ext cx="3520440" cy="1645920"/>
           </a:xfrm>
           <a:prstGeom prst="rect">
             <a:avLst/>
@@ -10552,13 +10532,13 @@
       </p:sp>
       <p:sp>
         <p:nvSpPr>
-          <p:cNvPr id="15" name="Rectangle 14"/>
+          <p:cNvPr id="13" name="Rectangle 12"/>
           <p:cNvSpPr/>
           <p:nvPr/>
         </p:nvSpPr>
         <p:spPr>
           <a:xfrm>
-            <a:off x="8083296" y="2057400"/>
+            <a:off x="8083296" y="2148840"/>
             <a:ext cx="3520440" cy="91440"/>
           </a:xfrm>
           <a:prstGeom prst="rect">
@@ -10596,14 +10576,14 @@
       </p:sp>
       <p:sp>
         <p:nvSpPr>
-          <p:cNvPr id="16" name="TextBox 15"/>
+          <p:cNvPr id="14" name="TextBox 13"/>
           <p:cNvSpPr txBox="1"/>
           <p:nvPr/>
         </p:nvSpPr>
         <p:spPr>
           <a:xfrm>
-            <a:off x="8311896" y="2286000"/>
-            <a:ext cx="3108960" cy="457200"/>
+            <a:off x="8339327" y="2240280"/>
+            <a:ext cx="3035808" cy="1463040"/>
           </a:xfrm>
           <a:prstGeom prst="rect">
             <a:avLst/>
@@ -10611,7 +10591,7 @@
           <a:noFill/>
         </p:spPr>
         <p:txBody>
-          <a:bodyPr wrap="square" anchor="t">
+          <a:bodyPr wrap="square" anchor="ctr">
             <a:spAutoFit/>
           </a:bodyPr>
           <a:lstStyle/>
@@ -10621,7 +10601,7 @@
                 <a:spcPts val="0"/>
               </a:spcBef>
               <a:spcAft>
-                <a:spcPts val="300"/>
+                <a:spcPts val="400"/>
               </a:spcAft>
             </a:pPr>
             <a:r>
@@ -10634,36 +10614,32 @@
               <a:t>An‑toàn‑từ‑chối</a:t>
             </a:r>
           </a:p>
-        </p:txBody>
-      </p:sp>
-      <p:sp>
-        <p:nvSpPr>
-          <p:cNvPr id="17" name="TextBox 16"/>
-          <p:cNvSpPr txBox="1"/>
-          <p:nvPr/>
-        </p:nvSpPr>
-        <p:spPr>
-          <a:xfrm>
-            <a:off x="8311896" y="2788920"/>
-            <a:ext cx="3108960" cy="914400"/>
-          </a:xfrm>
-          <a:prstGeom prst="rect">
-            <a:avLst/>
-          </a:prstGeom>
-          <a:noFill/>
-        </p:spPr>
-        <p:txBody>
-          <a:bodyPr wrap="square" anchor="t">
-            <a:spAutoFit/>
-          </a:bodyPr>
-          <a:lstStyle/>
           <a:p>
             <a:pPr algn="l">
               <a:spcBef>
                 <a:spcPts val="0"/>
               </a:spcBef>
               <a:spcAft>
-                <a:spcPts val="300"/>
+                <a:spcPts val="400"/>
+              </a:spcAft>
+            </a:pPr>
+            <a:r>
+              <a:rPr sz="600" b="0" i="0">
+                <a:solidFill>
+                  <a:srgbClr val="1F2937"/>
+                </a:solidFill>
+                <a:latin typeface="Calibri"/>
+              </a:rPr>
+              <a:t/>
+            </a:r>
+          </a:p>
+          <a:p>
+            <a:pPr algn="l">
+              <a:spcBef>
+                <a:spcPts val="0"/>
+              </a:spcBef>
+              <a:spcAft>
+                <a:spcPts val="400"/>
               </a:spcAft>
             </a:pPr>
             <a:r>
@@ -10680,14 +10656,14 @@
       </p:sp>
       <p:sp>
         <p:nvSpPr>
-          <p:cNvPr id="18" name="Rectangle 17"/>
+          <p:cNvPr id="15" name="Rectangle 14"/>
           <p:cNvSpPr/>
           <p:nvPr/>
         </p:nvSpPr>
         <p:spPr>
           <a:xfrm>
             <a:off x="640080" y="4023360"/>
-            <a:ext cx="3520440" cy="1691640"/>
+            <a:ext cx="3520440" cy="1645920"/>
           </a:xfrm>
           <a:prstGeom prst="rect">
             <a:avLst/>
@@ -10726,7 +10702,7 @@
       </p:sp>
       <p:sp>
         <p:nvSpPr>
-          <p:cNvPr id="19" name="Rectangle 18"/>
+          <p:cNvPr id="16" name="Rectangle 15"/>
           <p:cNvSpPr/>
           <p:nvPr/>
         </p:nvSpPr>
@@ -10770,14 +10746,14 @@
       </p:sp>
       <p:sp>
         <p:nvSpPr>
-          <p:cNvPr id="20" name="TextBox 19"/>
+          <p:cNvPr id="17" name="TextBox 16"/>
           <p:cNvSpPr txBox="1"/>
           <p:nvPr/>
         </p:nvSpPr>
         <p:spPr>
           <a:xfrm>
-            <a:off x="868680" y="4251960"/>
-            <a:ext cx="3108960" cy="457200"/>
+            <a:off x="896112" y="4114800"/>
+            <a:ext cx="3035808" cy="1463040"/>
           </a:xfrm>
           <a:prstGeom prst="rect">
             <a:avLst/>
@@ -10785,7 +10761,7 @@
           <a:noFill/>
         </p:spPr>
         <p:txBody>
-          <a:bodyPr wrap="square" anchor="t">
+          <a:bodyPr wrap="square" anchor="ctr">
             <a:spAutoFit/>
           </a:bodyPr>
           <a:lstStyle/>
@@ -10795,7 +10771,7 @@
                 <a:spcPts val="0"/>
               </a:spcBef>
               <a:spcAft>
-                <a:spcPts val="300"/>
+                <a:spcPts val="400"/>
               </a:spcAft>
             </a:pPr>
             <a:r>
@@ -10808,36 +10784,32 @@
               <a:t>TIR — chạy Python</a:t>
             </a:r>
           </a:p>
-        </p:txBody>
-      </p:sp>
-      <p:sp>
-        <p:nvSpPr>
-          <p:cNvPr id="21" name="TextBox 20"/>
-          <p:cNvSpPr txBox="1"/>
-          <p:nvPr/>
-        </p:nvSpPr>
-        <p:spPr>
-          <a:xfrm>
-            <a:off x="868680" y="4754880"/>
-            <a:ext cx="3108960" cy="914400"/>
-          </a:xfrm>
-          <a:prstGeom prst="rect">
-            <a:avLst/>
-          </a:prstGeom>
-          <a:noFill/>
-        </p:spPr>
-        <p:txBody>
-          <a:bodyPr wrap="square" anchor="t">
-            <a:spAutoFit/>
-          </a:bodyPr>
-          <a:lstStyle/>
           <a:p>
             <a:pPr algn="l">
               <a:spcBef>
                 <a:spcPts val="0"/>
               </a:spcBef>
               <a:spcAft>
-                <a:spcPts val="300"/>
+                <a:spcPts val="400"/>
+              </a:spcAft>
+            </a:pPr>
+            <a:r>
+              <a:rPr sz="600" b="0" i="0">
+                <a:solidFill>
+                  <a:srgbClr val="1F2937"/>
+                </a:solidFill>
+                <a:latin typeface="Calibri"/>
+              </a:rPr>
+              <a:t/>
+            </a:r>
+          </a:p>
+          <a:p>
+            <a:pPr algn="l">
+              <a:spcBef>
+                <a:spcPts val="0"/>
+              </a:spcBef>
+              <a:spcAft>
+                <a:spcPts val="400"/>
               </a:spcAft>
             </a:pPr>
             <a:r>
@@ -10854,14 +10826,14 @@
       </p:sp>
       <p:sp>
         <p:nvSpPr>
-          <p:cNvPr id="22" name="Rectangle 21"/>
+          <p:cNvPr id="18" name="Rectangle 17"/>
           <p:cNvSpPr/>
           <p:nvPr/>
         </p:nvSpPr>
         <p:spPr>
           <a:xfrm>
             <a:off x="4361688" y="4023360"/>
-            <a:ext cx="3520440" cy="1691640"/>
+            <a:ext cx="3520440" cy="1645920"/>
           </a:xfrm>
           <a:prstGeom prst="rect">
             <a:avLst/>
@@ -10900,7 +10872,7 @@
       </p:sp>
       <p:sp>
         <p:nvSpPr>
-          <p:cNvPr id="23" name="Rectangle 22"/>
+          <p:cNvPr id="19" name="Rectangle 18"/>
           <p:cNvSpPr/>
           <p:nvPr/>
         </p:nvSpPr>
@@ -10944,14 +10916,14 @@
       </p:sp>
       <p:sp>
         <p:nvSpPr>
-          <p:cNvPr id="24" name="TextBox 23"/>
+          <p:cNvPr id="20" name="TextBox 19"/>
           <p:cNvSpPr txBox="1"/>
           <p:nvPr/>
         </p:nvSpPr>
         <p:spPr>
           <a:xfrm>
-            <a:off x="4590288" y="4251960"/>
-            <a:ext cx="3108960" cy="457200"/>
+            <a:off x="4617720" y="4114800"/>
+            <a:ext cx="3035808" cy="1463040"/>
           </a:xfrm>
           <a:prstGeom prst="rect">
             <a:avLst/>
@@ -10959,7 +10931,7 @@
           <a:noFill/>
         </p:spPr>
         <p:txBody>
-          <a:bodyPr wrap="square" anchor="t">
+          <a:bodyPr wrap="square" anchor="ctr">
             <a:spAutoFit/>
           </a:bodyPr>
           <a:lstStyle/>
@@ -10969,7 +10941,7 @@
                 <a:spcPts val="0"/>
               </a:spcBef>
               <a:spcAft>
-                <a:spcPts val="300"/>
+                <a:spcPts val="400"/>
               </a:spcAft>
             </a:pPr>
             <a:r>
@@ -10982,36 +10954,32 @@
               <a:t>Constrained decoding</a:t>
             </a:r>
           </a:p>
-        </p:txBody>
-      </p:sp>
-      <p:sp>
-        <p:nvSpPr>
-          <p:cNvPr id="25" name="TextBox 24"/>
-          <p:cNvSpPr txBox="1"/>
-          <p:nvPr/>
-        </p:nvSpPr>
-        <p:spPr>
-          <a:xfrm>
-            <a:off x="4590288" y="4754880"/>
-            <a:ext cx="3108960" cy="914400"/>
-          </a:xfrm>
-          <a:prstGeom prst="rect">
-            <a:avLst/>
-          </a:prstGeom>
-          <a:noFill/>
-        </p:spPr>
-        <p:txBody>
-          <a:bodyPr wrap="square" anchor="t">
-            <a:spAutoFit/>
-          </a:bodyPr>
-          <a:lstStyle/>
           <a:p>
             <a:pPr algn="l">
               <a:spcBef>
                 <a:spcPts val="0"/>
               </a:spcBef>
               <a:spcAft>
-                <a:spcPts val="300"/>
+                <a:spcPts val="400"/>
+              </a:spcAft>
+            </a:pPr>
+            <a:r>
+              <a:rPr sz="600" b="0" i="0">
+                <a:solidFill>
+                  <a:srgbClr val="1F2937"/>
+                </a:solidFill>
+                <a:latin typeface="Calibri"/>
+              </a:rPr>
+              <a:t/>
+            </a:r>
+          </a:p>
+          <a:p>
+            <a:pPr algn="l">
+              <a:spcBef>
+                <a:spcPts val="0"/>
+              </a:spcBef>
+              <a:spcAft>
+                <a:spcPts val="400"/>
               </a:spcAft>
             </a:pPr>
             <a:r>
@@ -11028,14 +10996,14 @@
       </p:sp>
       <p:sp>
         <p:nvSpPr>
-          <p:cNvPr id="26" name="Rectangle 25"/>
+          <p:cNvPr id="21" name="Rectangle 20"/>
           <p:cNvSpPr/>
           <p:nvPr/>
         </p:nvSpPr>
         <p:spPr>
           <a:xfrm>
             <a:off x="8083296" y="4023360"/>
-            <a:ext cx="3520440" cy="1691640"/>
+            <a:ext cx="3520440" cy="1645920"/>
           </a:xfrm>
           <a:prstGeom prst="rect">
             <a:avLst/>
@@ -11074,7 +11042,7 @@
       </p:sp>
       <p:sp>
         <p:nvSpPr>
-          <p:cNvPr id="27" name="Rectangle 26"/>
+          <p:cNvPr id="22" name="Rectangle 21"/>
           <p:cNvSpPr/>
           <p:nvPr/>
         </p:nvSpPr>
@@ -11118,14 +11086,14 @@
       </p:sp>
       <p:sp>
         <p:nvSpPr>
-          <p:cNvPr id="28" name="TextBox 27"/>
+          <p:cNvPr id="23" name="TextBox 22"/>
           <p:cNvSpPr txBox="1"/>
           <p:nvPr/>
         </p:nvSpPr>
         <p:spPr>
           <a:xfrm>
-            <a:off x="8311896" y="4251960"/>
-            <a:ext cx="3108960" cy="457200"/>
+            <a:off x="8339327" y="4114800"/>
+            <a:ext cx="3035808" cy="1463040"/>
           </a:xfrm>
           <a:prstGeom prst="rect">
             <a:avLst/>
@@ -11133,7 +11101,7 @@
           <a:noFill/>
         </p:spPr>
         <p:txBody>
-          <a:bodyPr wrap="square" anchor="t">
+          <a:bodyPr wrap="square" anchor="ctr">
             <a:spAutoFit/>
           </a:bodyPr>
           <a:lstStyle/>
@@ -11143,7 +11111,7 @@
                 <a:spcPts val="0"/>
               </a:spcBef>
               <a:spcAft>
-                <a:spcPts val="300"/>
+                <a:spcPts val="400"/>
               </a:spcAft>
             </a:pPr>
             <a:r>
@@ -11156,36 +11124,32 @@
               <a:t>Khử thiên lệch vị trí</a:t>
             </a:r>
           </a:p>
-        </p:txBody>
-      </p:sp>
-      <p:sp>
-        <p:nvSpPr>
-          <p:cNvPr id="29" name="TextBox 28"/>
-          <p:cNvSpPr txBox="1"/>
-          <p:nvPr/>
-        </p:nvSpPr>
-        <p:spPr>
-          <a:xfrm>
-            <a:off x="8311896" y="4754880"/>
-            <a:ext cx="3108960" cy="914400"/>
-          </a:xfrm>
-          <a:prstGeom prst="rect">
-            <a:avLst/>
-          </a:prstGeom>
-          <a:noFill/>
-        </p:spPr>
-        <p:txBody>
-          <a:bodyPr wrap="square" anchor="t">
-            <a:spAutoFit/>
-          </a:bodyPr>
-          <a:lstStyle/>
           <a:p>
             <a:pPr algn="l">
               <a:spcBef>
                 <a:spcPts val="0"/>
               </a:spcBef>
               <a:spcAft>
-                <a:spcPts val="300"/>
+                <a:spcPts val="400"/>
+              </a:spcAft>
+            </a:pPr>
+            <a:r>
+              <a:rPr sz="600" b="0" i="0">
+                <a:solidFill>
+                  <a:srgbClr val="1F2937"/>
+                </a:solidFill>
+                <a:latin typeface="Calibri"/>
+              </a:rPr>
+              <a:t/>
+            </a:r>
+          </a:p>
+          <a:p>
+            <a:pPr algn="l">
+              <a:spcBef>
+                <a:spcPts val="0"/>
+              </a:spcBef>
+              <a:spcAft>
+                <a:spcPts val="400"/>
               </a:spcAft>
             </a:pPr>
             <a:r>
@@ -11202,7 +11166,7 @@
       </p:sp>
       <p:sp>
         <p:nvSpPr>
-          <p:cNvPr id="30" name="TextBox 29"/>
+          <p:cNvPr id="24" name="TextBox 23"/>
           <p:cNvSpPr txBox="1"/>
           <p:nvPr/>
         </p:nvSpPr>
@@ -11440,8 +11404,8 @@
         </p:nvSpPr>
         <p:spPr>
           <a:xfrm>
-            <a:off x="640080" y="2057400"/>
-            <a:ext cx="5349240" cy="1828800"/>
+            <a:off x="640080" y="2103120"/>
+            <a:ext cx="5349240" cy="1554480"/>
           </a:xfrm>
           <a:prstGeom prst="rect">
             <a:avLst/>
@@ -11486,8 +11450,8 @@
         </p:nvSpPr>
         <p:spPr>
           <a:xfrm>
-            <a:off x="914400" y="2267712"/>
-            <a:ext cx="4846320" cy="548640"/>
+            <a:off x="932688" y="2194560"/>
+            <a:ext cx="4800600" cy="1371600"/>
           </a:xfrm>
           <a:prstGeom prst="rect">
             <a:avLst/>
@@ -11495,7 +11459,7 @@
           <a:noFill/>
         </p:spPr>
         <p:txBody>
-          <a:bodyPr wrap="square" anchor="t">
+          <a:bodyPr wrap="square" anchor="ctr">
             <a:spAutoFit/>
           </a:bodyPr>
           <a:lstStyle/>
@@ -11505,7 +11469,7 @@
                 <a:spcPts val="0"/>
               </a:spcBef>
               <a:spcAft>
-                <a:spcPts val="300"/>
+                <a:spcPts val="400"/>
               </a:spcAft>
             </a:pPr>
             <a:r>
@@ -11518,36 +11482,32 @@
               <a:t>✓ Mọi câu đều có đáp án</a:t>
             </a:r>
           </a:p>
-        </p:txBody>
-      </p:sp>
-      <p:sp>
-        <p:nvSpPr>
-          <p:cNvPr id="8" name="TextBox 7"/>
-          <p:cNvSpPr txBox="1"/>
-          <p:nvPr/>
-        </p:nvSpPr>
-        <p:spPr>
-          <a:xfrm>
-            <a:off x="914400" y="2926080"/>
-            <a:ext cx="4846320" cy="914400"/>
-          </a:xfrm>
-          <a:prstGeom prst="rect">
-            <a:avLst/>
-          </a:prstGeom>
-          <a:noFill/>
-        </p:spPr>
-        <p:txBody>
-          <a:bodyPr wrap="square" anchor="t">
-            <a:spAutoFit/>
-          </a:bodyPr>
-          <a:lstStyle/>
           <a:p>
             <a:pPr algn="l">
               <a:spcBef>
                 <a:spcPts val="0"/>
               </a:spcBef>
               <a:spcAft>
-                <a:spcPts val="300"/>
+                <a:spcPts val="400"/>
+              </a:spcAft>
+            </a:pPr>
+            <a:r>
+              <a:rPr sz="600" b="0" i="0">
+                <a:solidFill>
+                  <a:srgbClr val="1F2937"/>
+                </a:solidFill>
+                <a:latin typeface="Calibri"/>
+              </a:rPr>
+              <a:t/>
+            </a:r>
+          </a:p>
+          <a:p>
+            <a:pPr algn="l">
+              <a:spcBef>
+                <a:spcPts val="0"/>
+              </a:spcBef>
+              <a:spcAft>
+                <a:spcPts val="400"/>
               </a:spcAft>
             </a:pPr>
             <a:r>
@@ -11564,14 +11524,14 @@
       </p:sp>
       <p:sp>
         <p:nvSpPr>
-          <p:cNvPr id="9" name="Rectangle 8"/>
+          <p:cNvPr id="8" name="Rectangle 7"/>
           <p:cNvSpPr/>
           <p:nvPr/>
         </p:nvSpPr>
         <p:spPr>
           <a:xfrm>
-            <a:off x="6263640" y="2057400"/>
-            <a:ext cx="5349240" cy="1828800"/>
+            <a:off x="6263640" y="2103120"/>
+            <a:ext cx="5349240" cy="1554480"/>
           </a:xfrm>
           <a:prstGeom prst="rect">
             <a:avLst/>
@@ -11610,14 +11570,94 @@
       </p:sp>
       <p:sp>
         <p:nvSpPr>
+          <p:cNvPr id="9" name="TextBox 8"/>
+          <p:cNvSpPr txBox="1"/>
+          <p:nvPr/>
+        </p:nvSpPr>
+        <p:spPr>
+          <a:xfrm>
+            <a:off x="6556248" y="2194560"/>
+            <a:ext cx="4800600" cy="1371600"/>
+          </a:xfrm>
+          <a:prstGeom prst="rect">
+            <a:avLst/>
+          </a:prstGeom>
+          <a:noFill/>
+        </p:spPr>
+        <p:txBody>
+          <a:bodyPr wrap="square" anchor="ctr">
+            <a:spAutoFit/>
+          </a:bodyPr>
+          <a:lstStyle/>
+          <a:p>
+            <a:pPr algn="l">
+              <a:spcBef>
+                <a:spcPts val="0"/>
+              </a:spcBef>
+              <a:spcAft>
+                <a:spcPts val="400"/>
+              </a:spcAft>
+            </a:pPr>
+            <a:r>
+              <a:rPr sz="1500" b="1" i="0">
+                <a:solidFill>
+                  <a:srgbClr val="15803D"/>
+                </a:solidFill>
+                <a:latin typeface="Calibri"/>
+              </a:rPr>
+              <a:t>✓ Ghi pred.csv TRƯỚC mọi thứ có thể lỗi</a:t>
+            </a:r>
+          </a:p>
+          <a:p>
+            <a:pPr algn="l">
+              <a:spcBef>
+                <a:spcPts val="0"/>
+              </a:spcBef>
+              <a:spcAft>
+                <a:spcPts val="400"/>
+              </a:spcAft>
+            </a:pPr>
+            <a:r>
+              <a:rPr sz="600" b="0" i="0">
+                <a:solidFill>
+                  <a:srgbClr val="1F2937"/>
+                </a:solidFill>
+                <a:latin typeface="Calibri"/>
+              </a:rPr>
+              <a:t/>
+            </a:r>
+          </a:p>
+          <a:p>
+            <a:pPr algn="l">
+              <a:spcBef>
+                <a:spcPts val="0"/>
+              </a:spcBef>
+              <a:spcAft>
+                <a:spcPts val="400"/>
+              </a:spcAft>
+            </a:pPr>
+            <a:r>
+              <a:rPr sz="1250" b="0" i="0">
+                <a:solidFill>
+                  <a:srgbClr val="1F2937"/>
+                </a:solidFill>
+                <a:latin typeface="Calibri"/>
+              </a:rPr>
+              <a:t>contract‑repair phủ đúng mọi qid với chữ cái hợp lệ (giữ nguyên dự đoán tốt); ghi trước, validate chỉ cảnh báo.</a:t>
+            </a:r>
+          </a:p>
+        </p:txBody>
+      </p:sp>
+      <p:sp>
+        <p:nvSpPr>
           <p:cNvPr id="10" name="TextBox 9"/>
           <p:cNvSpPr txBox="1"/>
           <p:nvPr/>
         </p:nvSpPr>
         <p:spPr>
           <a:xfrm>
-            <a:off x="6537960" y="2267712"/>
-            <a:ext cx="4846320" cy="548640"/>
+            <a:off x="640080" y="4160520"/>
+            <a:ext cx="10972800" cy="365760"/>
           </a:xfrm>
           <a:prstGeom prst="rect">
             <a:avLst/>
@@ -11639,13 +11679,13 @@
               </a:spcAft>
             </a:pPr>
             <a:r>
-              <a:rPr sz="1500" b="1" i="0">
-                <a:solidFill>
-                  <a:srgbClr val="15803D"/>
-                </a:solidFill>
-                <a:latin typeface="Calibri"/>
-              </a:rPr>
-              <a:t>✓ Ghi pred.csv TRƯỚC mọi thứ có thể lỗi</a:t>
+              <a:rPr sz="1400" b="1" i="0">
+                <a:solidFill>
+                  <a:srgbClr val="1F2937"/>
+                </a:solidFill>
+                <a:latin typeface="Calibri"/>
+              </a:rPr>
+              <a:t>Tự động tiếp tục khi gặp sự cố — ba lớp:</a:t>
             </a:r>
           </a:p>
         </p:txBody>
@@ -11658,8 +11698,8 @@
         </p:nvSpPr>
         <p:spPr>
           <a:xfrm>
-            <a:off x="6537960" y="2926080"/>
-            <a:ext cx="4846320" cy="914400"/>
+            <a:off x="822960" y="4572000"/>
+            <a:ext cx="10972800" cy="1280160"/>
           </a:xfrm>
           <a:prstGeom prst="rect">
             <a:avLst/>
@@ -11681,13 +11721,78 @@
               </a:spcAft>
             </a:pPr>
             <a:r>
+              <a:rPr sz="1300" b="1" i="0">
+                <a:solidFill>
+                  <a:srgbClr val="C2550B"/>
+                </a:solidFill>
+                <a:latin typeface="Calibri"/>
+              </a:rPr>
+              <a:t>①  Retry từng câu</a:t>
+            </a:r>
+            <a:r>
               <a:rPr sz="1250" b="0" i="0">
                 <a:solidFill>
                   <a:srgbClr val="1F2937"/>
                 </a:solidFill>
                 <a:latin typeface="Calibri"/>
               </a:rPr>
-              <a:t>contract‑repair phủ đúng mọi qid với chữ cái hợp lệ (giữ nguyên dự đoán tốt); ghi trước, validate chỉ cảnh báo.</a:t>
+              <a:t>  — lỗi tạm thời (timeout/connection) thử lại với backoff lũy thừa.</a:t>
+            </a:r>
+          </a:p>
+          <a:p>
+            <a:pPr algn="l">
+              <a:spcBef>
+                <a:spcPts val="0"/>
+              </a:spcBef>
+              <a:spcAft>
+                <a:spcPts val="300"/>
+              </a:spcAft>
+            </a:pPr>
+            <a:r>
+              <a:rPr sz="1300" b="1" i="0">
+                <a:solidFill>
+                  <a:srgbClr val="C2550B"/>
+                </a:solidFill>
+                <a:latin typeface="Calibri"/>
+              </a:rPr>
+              <a:t>②  Fallback từng câu</a:t>
+            </a:r>
+            <a:r>
+              <a:rPr sz="1250" b="0" i="0">
+                <a:solidFill>
+                  <a:srgbClr val="1F2937"/>
+                </a:solidFill>
+                <a:latin typeface="Calibri"/>
+              </a:rPr>
+              <a:t>  — lỗi bất kỳ → đáp án heuristic tất định, không crash.</a:t>
+            </a:r>
+          </a:p>
+          <a:p>
+            <a:pPr algn="l">
+              <a:spcBef>
+                <a:spcPts val="0"/>
+              </a:spcBef>
+              <a:spcAft>
+                <a:spcPts val="300"/>
+              </a:spcAft>
+            </a:pPr>
+            <a:r>
+              <a:rPr sz="1300" b="1" i="0">
+                <a:solidFill>
+                  <a:srgbClr val="C2550B"/>
+                </a:solidFill>
+                <a:latin typeface="Calibri"/>
+              </a:rPr>
+              <a:t>③  Checkpoint + auto‑resume</a:t>
+            </a:r>
+            <a:r>
+              <a:rPr sz="1250" b="0" i="0">
+                <a:solidFill>
+                  <a:srgbClr val="1F2937"/>
+                </a:solidFill>
+                <a:latin typeface="Calibri"/>
+              </a:rPr>
+              <a:t>  — container restart → tiếp tục từ câu cuối, không tính lại (cứu cả Time).</a:t>
             </a:r>
           </a:p>
         </p:txBody>
@@ -11700,7 +11805,7 @@
         </p:nvSpPr>
         <p:spPr>
           <a:xfrm>
-            <a:off x="640080" y="4160520"/>
+            <a:off x="640080" y="5989320"/>
             <a:ext cx="10972800" cy="365760"/>
           </a:xfrm>
           <a:prstGeom prst="rect">
@@ -11723,13 +11828,13 @@
               </a:spcAft>
             </a:pPr>
             <a:r>
-              <a:rPr sz="1400" b="1" i="0">
-                <a:solidFill>
-                  <a:srgbClr val="1F2937"/>
-                </a:solidFill>
-                <a:latin typeface="Calibri"/>
-              </a:rPr>
-              <a:t>Tự động tiếp tục khi gặp sự cố — ba lớp:</a:t>
+              <a:rPr sz="1150" b="0" i="1">
+                <a:solidFill>
+                  <a:srgbClr val="6B7280"/>
+                </a:solidFill>
+                <a:latin typeface="Calibri"/>
+              </a:rPr>
+              <a:t>Đã smoke đúng entrypoint Docker trên GPU thật: pred.csv hợp lệ, contract 40/40 · 211 test đơn vị xanh.</a:t>
             </a:r>
           </a:p>
         </p:txBody>
@@ -11737,155 +11842,6 @@
       <p:sp>
         <p:nvSpPr>
           <p:cNvPr id="13" name="TextBox 12"/>
-          <p:cNvSpPr txBox="1"/>
-          <p:nvPr/>
-        </p:nvSpPr>
-        <p:spPr>
-          <a:xfrm>
-            <a:off x="822960" y="4572000"/>
-            <a:ext cx="10972800" cy="1280160"/>
-          </a:xfrm>
-          <a:prstGeom prst="rect">
-            <a:avLst/>
-          </a:prstGeom>
-          <a:noFill/>
-        </p:spPr>
-        <p:txBody>
-          <a:bodyPr wrap="square" anchor="t">
-            <a:spAutoFit/>
-          </a:bodyPr>
-          <a:lstStyle/>
-          <a:p>
-            <a:pPr algn="l">
-              <a:spcBef>
-                <a:spcPts val="0"/>
-              </a:spcBef>
-              <a:spcAft>
-                <a:spcPts val="300"/>
-              </a:spcAft>
-            </a:pPr>
-            <a:r>
-              <a:rPr sz="1300" b="1" i="0">
-                <a:solidFill>
-                  <a:srgbClr val="C2550B"/>
-                </a:solidFill>
-                <a:latin typeface="Calibri"/>
-              </a:rPr>
-              <a:t>①  Retry từng câu</a:t>
-            </a:r>
-            <a:r>
-              <a:rPr sz="1250" b="0" i="0">
-                <a:solidFill>
-                  <a:srgbClr val="1F2937"/>
-                </a:solidFill>
-                <a:latin typeface="Calibri"/>
-              </a:rPr>
-              <a:t>  — lỗi tạm thời (timeout/connection) thử lại với backoff lũy thừa.</a:t>
-            </a:r>
-          </a:p>
-          <a:p>
-            <a:pPr algn="l">
-              <a:spcBef>
-                <a:spcPts val="0"/>
-              </a:spcBef>
-              <a:spcAft>
-                <a:spcPts val="300"/>
-              </a:spcAft>
-            </a:pPr>
-            <a:r>
-              <a:rPr sz="1300" b="1" i="0">
-                <a:solidFill>
-                  <a:srgbClr val="C2550B"/>
-                </a:solidFill>
-                <a:latin typeface="Calibri"/>
-              </a:rPr>
-              <a:t>②  Fallback từng câu</a:t>
-            </a:r>
-            <a:r>
-              <a:rPr sz="1250" b="0" i="0">
-                <a:solidFill>
-                  <a:srgbClr val="1F2937"/>
-                </a:solidFill>
-                <a:latin typeface="Calibri"/>
-              </a:rPr>
-              <a:t>  — lỗi bất kỳ → đáp án heuristic tất định, không crash.</a:t>
-            </a:r>
-          </a:p>
-          <a:p>
-            <a:pPr algn="l">
-              <a:spcBef>
-                <a:spcPts val="0"/>
-              </a:spcBef>
-              <a:spcAft>
-                <a:spcPts val="300"/>
-              </a:spcAft>
-            </a:pPr>
-            <a:r>
-              <a:rPr sz="1300" b="1" i="0">
-                <a:solidFill>
-                  <a:srgbClr val="C2550B"/>
-                </a:solidFill>
-                <a:latin typeface="Calibri"/>
-              </a:rPr>
-              <a:t>③  Checkpoint + auto‑resume</a:t>
-            </a:r>
-            <a:r>
-              <a:rPr sz="1250" b="0" i="0">
-                <a:solidFill>
-                  <a:srgbClr val="1F2937"/>
-                </a:solidFill>
-                <a:latin typeface="Calibri"/>
-              </a:rPr>
-              <a:t>  — container restart → tiếp tục từ câu cuối, không tính lại (cứu cả Time).</a:t>
-            </a:r>
-          </a:p>
-        </p:txBody>
-      </p:sp>
-      <p:sp>
-        <p:nvSpPr>
-          <p:cNvPr id="14" name="TextBox 13"/>
-          <p:cNvSpPr txBox="1"/>
-          <p:nvPr/>
-        </p:nvSpPr>
-        <p:spPr>
-          <a:xfrm>
-            <a:off x="640080" y="5989320"/>
-            <a:ext cx="10972800" cy="365760"/>
-          </a:xfrm>
-          <a:prstGeom prst="rect">
-            <a:avLst/>
-          </a:prstGeom>
-          <a:noFill/>
-        </p:spPr>
-        <p:txBody>
-          <a:bodyPr wrap="square" anchor="t">
-            <a:spAutoFit/>
-          </a:bodyPr>
-          <a:lstStyle/>
-          <a:p>
-            <a:pPr algn="l">
-              <a:spcBef>
-                <a:spcPts val="0"/>
-              </a:spcBef>
-              <a:spcAft>
-                <a:spcPts val="300"/>
-              </a:spcAft>
-            </a:pPr>
-            <a:r>
-              <a:rPr sz="1150" b="0" i="1">
-                <a:solidFill>
-                  <a:srgbClr val="6B7280"/>
-                </a:solidFill>
-                <a:latin typeface="Calibri"/>
-              </a:rPr>
-              <a:t>Đã smoke đúng entrypoint Docker trên GPU thật: pred.csv hợp lệ, contract 40/40 · 211 test đơn vị xanh.</a:t>
-            </a:r>
-          </a:p>
-        </p:txBody>
-      </p:sp>
-      <p:sp>
-        <p:nvSpPr>
-          <p:cNvPr id="15" name="TextBox 14"/>
           <p:cNvSpPr txBox="1"/>
           <p:nvPr/>
         </p:nvSpPr>

</xml_diff>

<commit_message>
docs(submission): rewrite deck copy in academic Vietnamese register
Shift from pitch/marketing tone to scholarly technical Vietnamese: full measured
sentences, precise terminology, Vietnamese decimal commas (10,15 / 1,29 / 6,7%);
remove emphasis caps, in-prose arrows, and superlatives ('bat kha xam pham' ->
'bao dam tinh toan ven'). Academic card titles, objective table register, and a
proper concluding sentence. Layout unchanged; verified clean via rendered PNGs.

Co-Authored-By: Claude Opus 4.8 (1M context) <noreply@anthropic.com>
</commit_message>
<xml_diff>
--- a/docs/Neko-Core-Thuyet-minh-phuong-phap.pptx
+++ b/docs/Neko-Core-Thuyet-minh-phuong-phap.pptx
@@ -3305,13 +3305,13 @@
               </a:spcAft>
             </a:pPr>
             <a:r>
-              <a:rPr sz="1800" b="0" i="0">
+              <a:rPr sz="1700" b="0" i="0">
                 <a:solidFill>
                   <a:srgbClr val="FAF5EE"/>
                 </a:solidFill>
                 <a:latin typeface="Calibri"/>
               </a:rPr>
-              <a:t>AI Agent trắc nghiệm offline — thắng bằng kỷ luật đo‑thật, không bằng mô hình to hơn</a:t>
+              <a:t>Hệ thống suy luận trắc nghiệm vận hành ngoại tuyến, tối ưu theo phương pháp luận đo lường thực nghiệm</a:t>
             </a:r>
           </a:p>
         </p:txBody>
@@ -3324,7 +3324,7 @@
         </p:nvSpPr>
         <p:spPr>
           <a:xfrm>
-            <a:off x="822960" y="3886200"/>
+            <a:off x="822960" y="3931920"/>
             <a:ext cx="10515600" cy="548640"/>
           </a:xfrm>
           <a:prstGeom prst="rect">
@@ -3347,7 +3347,7 @@
               </a:spcAft>
             </a:pPr>
             <a:r>
-              <a:rPr sz="1700" b="1" i="0">
+              <a:rPr sz="1600" b="1" i="0">
                 <a:solidFill>
                   <a:srgbClr val="F97316"/>
                 </a:solidFill>
@@ -3366,7 +3366,7 @@
         </p:nvSpPr>
         <p:spPr>
           <a:xfrm>
-            <a:off x="822960" y="4754880"/>
+            <a:off x="822960" y="4800600"/>
             <a:ext cx="10515600" cy="1005840"/>
           </a:xfrm>
           <a:prstGeom prst="rect">
@@ -3395,10 +3395,10 @@
                 </a:solidFill>
                 <a:latin typeface="Calibri"/>
               </a:rPr>
-              <a:t>Leaderboard: </a:t>
-            </a:r>
-            <a:r>
-              <a:rPr sz="1900" b="1" i="0">
+              <a:t>Kết quả leaderboard: </a:t>
+            </a:r>
+            <a:r>
+              <a:rPr sz="1800" b="1" i="0">
                 <a:solidFill>
                   <a:srgbClr val="FFFFFF"/>
                 </a:solidFill>
@@ -3407,13 +3407,13 @@
               <a:t>88.55</a:t>
             </a:r>
             <a:r>
-              <a:rPr sz="1500" b="0" i="0">
+              <a:rPr sz="1400" b="0" i="0">
                 <a:solidFill>
                   <a:srgbClr val="FAF5EE"/>
                 </a:solidFill>
                 <a:latin typeface="Calibri"/>
               </a:rPr>
-              <a:t>   ·   Mô hình: Gemma‑4‑26B‑A4B QAT‑Q4_0 (MoE ~15GB, offline)</a:t>
+              <a:t>   ·   Mô hình: Gemma‑4‑26B‑A4B QAT‑Q4_0 (kiến trúc MoE, ~15GB, ngoại tuyến)</a:t>
             </a:r>
           </a:p>
           <a:p>
@@ -3580,7 +3580,7 @@
                 </a:solidFill>
                 <a:latin typeface="Calibri"/>
               </a:rPr>
-              <a:t>08 · ĐIỂM TIME</a:t>
+              <a:t>08 · Điểm thời gian</a:t>
             </a:r>
           </a:p>
         </p:txBody>
@@ -3616,13 +3616,13 @@
               </a:spcAft>
             </a:pPr>
             <a:r>
-              <a:rPr sz="2300" b="1" i="0">
+              <a:rPr sz="2200" b="1" i="0">
                 <a:solidFill>
                   <a:srgbClr val="1F2937"/>
                 </a:solidFill>
                 <a:latin typeface="Calibri"/>
               </a:rPr>
-              <a:t>Điểm Time an toàn ở độ sâu suy luận tối đa: núm token gần như PHẲNG.</a:t>
+              <a:t>Điểm thời gian được bảo đảm ở độ sâu suy luận tối đa do tham số token gần như không ảnh hưởng thời gian.</a:t>
             </a:r>
           </a:p>
         </p:txBody>
@@ -3636,7 +3636,7 @@
           <p:nvPr/>
         </p:nvGraphicFramePr>
         <p:xfrm>
-          <a:off x="640080" y="2103120"/>
+          <a:off x="640080" y="2194560"/>
           <a:ext cx="5852160" cy="2011680"/>
         </p:xfrm>
         <a:graphic>
@@ -3684,7 +3684,7 @@
                           </a:solidFill>
                           <a:latin typeface="Calibri"/>
                         </a:rPr>
-                        <a:t>Thời gian 463 câu</a:t>
+                        <a:t>Thời gian (463 câu)</a:t>
                       </a:r>
                     </a:p>
                   </a:txBody>
@@ -3730,7 +3730,7 @@
                           </a:solidFill>
                           <a:latin typeface="Calibri"/>
                         </a:rPr>
-                        <a:t>21.2 phút</a:t>
+                        <a:t>21,2 phút</a:t>
                       </a:r>
                     </a:p>
                   </a:txBody>
@@ -3776,7 +3776,7 @@
                           </a:solidFill>
                           <a:latin typeface="Calibri"/>
                         </a:rPr>
-                        <a:t>22.1 phút</a:t>
+                        <a:t>22,1 phút</a:t>
                       </a:r>
                     </a:p>
                   </a:txBody>
@@ -3800,7 +3800,7 @@
                           </a:solidFill>
                           <a:latin typeface="Calibri"/>
                         </a:rPr>
-                        <a:t>2048  (ship)</a:t>
+                        <a:t>2048  (triển khai)</a:t>
                       </a:r>
                     </a:p>
                   </a:txBody>
@@ -3822,7 +3822,7 @@
                           </a:solidFill>
                           <a:latin typeface="Calibri"/>
                         </a:rPr>
-                        <a:t>22.6 phút</a:t>
+                        <a:t>22,6 phút</a:t>
                       </a:r>
                     </a:p>
                   </a:txBody>
@@ -3845,7 +3845,7 @@
         </p:nvSpPr>
         <p:spPr>
           <a:xfrm>
-            <a:off x="640080" y="4480560"/>
+            <a:off x="640080" y="4526280"/>
             <a:ext cx="6035040" cy="1371600"/>
           </a:xfrm>
           <a:prstGeom prst="rect">
@@ -3868,50 +3868,13 @@
               </a:spcAft>
             </a:pPr>
             <a:r>
-              <a:rPr sz="1250" b="0" i="0">
+              <a:rPr sz="1300" b="0" i="0">
                 <a:solidFill>
                   <a:srgbClr val="1F2937"/>
                 </a:solidFill>
                 <a:latin typeface="Calibri"/>
               </a:rPr>
-              <a:t>2048 chỉ chậm hơn 768 </a:t>
-            </a:r>
-            <a:r>
-              <a:rPr sz="1300" b="1" i="0">
-                <a:solidFill>
-                  <a:srgbClr val="C2550B"/>
-                </a:solidFill>
-                <a:latin typeface="Calibri"/>
-              </a:rPr>
-              <a:t>+6.7%</a:t>
-            </a:r>
-            <a:r>
-              <a:rPr sz="1250" b="0" i="0">
-                <a:solidFill>
-                  <a:srgbClr val="1F2937"/>
-                </a:solidFill>
-                <a:latin typeface="Calibri"/>
-              </a:rPr>
-              <a:t> (MoE tự dừng sớm) → trần token gần như miễn phí.</a:t>
-            </a:r>
-          </a:p>
-          <a:p>
-            <a:pPr algn="l">
-              <a:spcBef>
-                <a:spcPts val="0"/>
-              </a:spcBef>
-              <a:spcAft>
-                <a:spcPts val="300"/>
-              </a:spcAft>
-            </a:pPr>
-            <a:r>
-              <a:rPr sz="1250" b="1" i="0">
-                <a:solidFill>
-                  <a:srgbClr val="1F2937"/>
-                </a:solidFill>
-                <a:latin typeface="Calibri"/>
-              </a:rPr>
-              <a:t>2000 câu private chạy ~1.5–1.6h ở mọi mức.</a:t>
+              <a:t>Mức 2048 chỉ chậm hơn mức 768 khoảng 6,7% do mô hình MoE thường dừng sớm. Tập 2000 câu hoàn tất trong khoảng 1,5–1,6 giờ ở mọi mức.</a:t>
             </a:r>
           </a:p>
         </p:txBody>
@@ -3924,8 +3887,8 @@
         </p:nvSpPr>
         <p:spPr>
           <a:xfrm>
-            <a:off x="6858000" y="2103120"/>
-            <a:ext cx="4754880" cy="3657600"/>
+            <a:off x="6858000" y="2194560"/>
+            <a:ext cx="4754880" cy="3566160"/>
           </a:xfrm>
           <a:prstGeom prst="rect">
             <a:avLst/>
@@ -3970,8 +3933,8 @@
         </p:nvSpPr>
         <p:spPr>
           <a:xfrm>
-            <a:off x="7114032" y="2331720"/>
-            <a:ext cx="4297680" cy="3383280"/>
+            <a:off x="7114032" y="2395728"/>
+            <a:ext cx="4297680" cy="3291840"/>
           </a:xfrm>
           <a:prstGeom prst="rect">
             <a:avLst/>
@@ -4018,7 +3981,7 @@
                 </a:solidFill>
                 <a:latin typeface="Calibri"/>
               </a:rPr>
-              <a:t>Mô hình phác thảo token, mô hình gốc verify → output GIỐNG HỆT.</a:t>
+              <a:t>Mô hình phác thảo nhiều token và mô hình gốc kiểm chứng, nên đầu ra không thay đổi.</a:t>
             </a:r>
           </a:p>
           <a:p>
@@ -4031,13 +3994,13 @@
               </a:spcAft>
             </a:pPr>
             <a:r>
-              <a:rPr sz="1350" b="1" i="0">
+              <a:rPr sz="1300" b="1" i="0">
                 <a:solidFill>
                   <a:srgbClr val="15803D"/>
                 </a:solidFill>
                 <a:latin typeface="Calibri"/>
               </a:rPr>
-              <a:t>→ 0 mất accuracy.</a:t>
+              <a:t>Không suy giảm độ chính xác.</a:t>
             </a:r>
           </a:p>
           <a:p>
@@ -4050,13 +4013,13 @@
               </a:spcAft>
             </a:pPr>
             <a:r>
-              <a:rPr sz="1350" b="1" i="0">
+              <a:rPr sz="1300" b="1" i="0">
                 <a:solidFill>
                   <a:srgbClr val="15803D"/>
                 </a:solidFill>
                 <a:latin typeface="Calibri"/>
               </a:rPr>
-              <a:t>→ Nhanh 1.4–2.2× (thuần tốc độ).</a:t>
+              <a:t>Tăng tốc 1,4–2,2 lần.</a:t>
             </a:r>
           </a:p>
           <a:p>
@@ -4075,7 +4038,7 @@
                 </a:solidFill>
                 <a:latin typeface="Calibri"/>
               </a:rPr>
-              <a:t>Trực giao với quant → ship cả hai; đường Docker = provider local_server.</a:t>
+              <a:t>Trực giao với lượng tử hóa nên triển khai đồng thời; tích hợp qua provider local_server.</a:t>
             </a:r>
           </a:p>
         </p:txBody>
@@ -4265,7 +4228,7 @@
                 </a:solidFill>
                 <a:latin typeface="Calibri"/>
               </a:rPr>
-              <a:t>09 · ĐỊNH VỊ</a:t>
+              <a:t>09 · Định vị kết quả</a:t>
             </a:r>
           </a:p>
         </p:txBody>
@@ -4301,13 +4264,13 @@
               </a:spcAft>
             </a:pPr>
             <a:r>
-              <a:rPr sz="2300" b="1" i="0">
+              <a:rPr sz="2200" b="1" i="0">
                 <a:solidFill>
                   <a:srgbClr val="1F2937"/>
                 </a:solidFill>
                 <a:latin typeface="Calibri"/>
               </a:rPr>
-              <a:t>88.55 là gần trần thật của Gemma offline — phần gỡ được là TOÁN (TIR), không phải kiến thức.</a:t>
+              <a:t>88.55 tiệm cận giới hạn thực tế của mô hình Gemma ngoại tuyến; phần khắc phục được thuộc về suy luận định lượng.</a:t>
             </a:r>
           </a:p>
         </p:txBody>
@@ -4320,7 +4283,7 @@
         </p:nvSpPr>
         <p:spPr>
           <a:xfrm>
-            <a:off x="822960" y="2194560"/>
+            <a:off x="822960" y="2240280"/>
             <a:ext cx="3291840" cy="1554480"/>
           </a:xfrm>
           <a:prstGeom prst="rect">
@@ -4366,8 +4329,8 @@
         </p:nvSpPr>
         <p:spPr>
           <a:xfrm>
-            <a:off x="822960" y="2331720"/>
-            <a:ext cx="3291840" cy="640080"/>
+            <a:off x="822960" y="2240280"/>
+            <a:ext cx="3291840" cy="1554480"/>
           </a:xfrm>
           <a:prstGeom prst="rect">
             <a:avLst/>
@@ -4375,7 +4338,7 @@
           <a:noFill/>
         </p:spPr>
         <p:txBody>
-          <a:bodyPr wrap="square" anchor="t">
+          <a:bodyPr wrap="square" anchor="ctr">
             <a:spAutoFit/>
           </a:bodyPr>
           <a:lstStyle/>
@@ -4385,7 +4348,7 @@
                 <a:spcPts val="0"/>
               </a:spcBef>
               <a:spcAft>
-                <a:spcPts val="300"/>
+                <a:spcPts val="400"/>
               </a:spcAft>
             </a:pPr>
             <a:r>
@@ -4398,36 +4361,13 @@
               <a:t>27/31</a:t>
             </a:r>
           </a:p>
-        </p:txBody>
-      </p:sp>
-      <p:sp>
-        <p:nvSpPr>
-          <p:cNvPr id="8" name="TextBox 7"/>
-          <p:cNvSpPr txBox="1"/>
-          <p:nvPr/>
-        </p:nvSpPr>
-        <p:spPr>
-          <a:xfrm>
-            <a:off x="822960" y="3017520"/>
-            <a:ext cx="3291840" cy="640080"/>
-          </a:xfrm>
-          <a:prstGeom prst="rect">
-            <a:avLst/>
-          </a:prstGeom>
-          <a:noFill/>
-        </p:spPr>
-        <p:txBody>
-          <a:bodyPr wrap="square" anchor="t">
-            <a:spAutoFit/>
-          </a:bodyPr>
-          <a:lstStyle/>
           <a:p>
             <a:pPr algn="ctr">
               <a:spcBef>
                 <a:spcPts val="0"/>
               </a:spcBef>
               <a:spcAft>
-                <a:spcPts val="300"/>
+                <a:spcPts val="400"/>
               </a:spcAft>
             </a:pPr>
             <a:r>
@@ -4437,21 +4377,21 @@
                 </a:solidFill>
                 <a:latin typeface="Calibri"/>
               </a:rPr>
-              <a:t>frontier đúng
-(Gemma sai thật)</a:t>
-            </a:r>
-          </a:p>
-        </p:txBody>
-      </p:sp>
-      <p:sp>
-        <p:nvSpPr>
-          <p:cNvPr id="9" name="Rectangle 8"/>
+              <a:t>mô hình tham chiếu đúng
+(Gemma sai thực sự)</a:t>
+            </a:r>
+          </a:p>
+        </p:txBody>
+      </p:sp>
+      <p:sp>
+        <p:nvSpPr>
+          <p:cNvPr id="8" name="Rectangle 7"/>
           <p:cNvSpPr/>
           <p:nvPr/>
         </p:nvSpPr>
         <p:spPr>
           <a:xfrm>
-            <a:off x="4480560" y="2194560"/>
+            <a:off x="4480560" y="2240280"/>
             <a:ext cx="3291840" cy="1554480"/>
           </a:xfrm>
           <a:prstGeom prst="rect">
@@ -4491,14 +4431,14 @@
       </p:sp>
       <p:sp>
         <p:nvSpPr>
-          <p:cNvPr id="10" name="TextBox 9"/>
+          <p:cNvPr id="9" name="TextBox 8"/>
           <p:cNvSpPr txBox="1"/>
           <p:nvPr/>
         </p:nvSpPr>
         <p:spPr>
           <a:xfrm>
-            <a:off x="4480560" y="2331720"/>
-            <a:ext cx="3291840" cy="640080"/>
+            <a:off x="4480560" y="2240280"/>
+            <a:ext cx="3291840" cy="1554480"/>
           </a:xfrm>
           <a:prstGeom prst="rect">
             <a:avLst/>
@@ -4506,7 +4446,7 @@
           <a:noFill/>
         </p:spPr>
         <p:txBody>
-          <a:bodyPr wrap="square" anchor="t">
+          <a:bodyPr wrap="square" anchor="ctr">
             <a:spAutoFit/>
           </a:bodyPr>
           <a:lstStyle/>
@@ -4516,7 +4456,7 @@
                 <a:spcPts val="0"/>
               </a:spcBef>
               <a:spcAft>
-                <a:spcPts val="300"/>
+                <a:spcPts val="400"/>
               </a:spcAft>
             </a:pPr>
             <a:r>
@@ -4529,36 +4469,13 @@
               <a:t>16/463</a:t>
             </a:r>
           </a:p>
-        </p:txBody>
-      </p:sp>
-      <p:sp>
-        <p:nvSpPr>
-          <p:cNvPr id="11" name="TextBox 10"/>
-          <p:cNvSpPr txBox="1"/>
-          <p:nvPr/>
-        </p:nvSpPr>
-        <p:spPr>
-          <a:xfrm>
-            <a:off x="4480560" y="3017520"/>
-            <a:ext cx="3291840" cy="640080"/>
-          </a:xfrm>
-          <a:prstGeom prst="rect">
-            <a:avLst/>
-          </a:prstGeom>
-          <a:noFill/>
-        </p:spPr>
-        <p:txBody>
-          <a:bodyPr wrap="square" anchor="t">
-            <a:spAutoFit/>
-          </a:bodyPr>
-          <a:lstStyle/>
           <a:p>
             <a:pPr algn="ctr">
               <a:spcBef>
                 <a:spcPts val="0"/>
               </a:spcBef>
               <a:spcAft>
-                <a:spcPts val="300"/>
+                <a:spcPts val="400"/>
               </a:spcAft>
             </a:pPr>
             <a:r>
@@ -4568,21 +4485,21 @@
                 </a:solidFill>
                 <a:latin typeface="Calibri"/>
               </a:rPr>
-              <a:t>xác nhận gỡ được
-(toán + suy luận)</a:t>
-            </a:r>
-          </a:p>
-        </p:txBody>
-      </p:sp>
-      <p:sp>
-        <p:nvSpPr>
-          <p:cNvPr id="12" name="Rectangle 11"/>
+              <a:t>xác nhận khắc phục được
+(định lượng + suy luận)</a:t>
+            </a:r>
+          </a:p>
+        </p:txBody>
+      </p:sp>
+      <p:sp>
+        <p:nvSpPr>
+          <p:cNvPr id="10" name="Rectangle 9"/>
           <p:cNvSpPr/>
           <p:nvPr/>
         </p:nvSpPr>
         <p:spPr>
           <a:xfrm>
-            <a:off x="8138160" y="2194560"/>
+            <a:off x="8138160" y="2240280"/>
             <a:ext cx="3291840" cy="1554480"/>
           </a:xfrm>
           <a:prstGeom prst="rect">
@@ -4622,14 +4539,76 @@
       </p:sp>
       <p:sp>
         <p:nvSpPr>
-          <p:cNvPr id="13" name="TextBox 12"/>
+          <p:cNvPr id="11" name="TextBox 10"/>
           <p:cNvSpPr txBox="1"/>
           <p:nvPr/>
         </p:nvSpPr>
         <p:spPr>
           <a:xfrm>
-            <a:off x="8138160" y="2331720"/>
-            <a:ext cx="3291840" cy="640080"/>
+            <a:off x="8138160" y="2240280"/>
+            <a:ext cx="3291840" cy="1554480"/>
+          </a:xfrm>
+          <a:prstGeom prst="rect">
+            <a:avLst/>
+          </a:prstGeom>
+          <a:noFill/>
+        </p:spPr>
+        <p:txBody>
+          <a:bodyPr wrap="square" anchor="ctr">
+            <a:spAutoFit/>
+          </a:bodyPr>
+          <a:lstStyle/>
+          <a:p>
+            <a:pPr algn="ctr">
+              <a:spcBef>
+                <a:spcPts val="0"/>
+              </a:spcBef>
+              <a:spcAft>
+                <a:spcPts val="400"/>
+              </a:spcAft>
+            </a:pPr>
+            <a:r>
+              <a:rPr sz="2700" b="1" i="0">
+                <a:solidFill>
+                  <a:srgbClr val="B91C1C"/>
+                </a:solidFill>
+                <a:latin typeface="Calibri"/>
+              </a:rPr>
+              <a:t>13</a:t>
+            </a:r>
+          </a:p>
+          <a:p>
+            <a:pPr algn="ctr">
+              <a:spcBef>
+                <a:spcPts val="0"/>
+              </a:spcBef>
+              <a:spcAft>
+                <a:spcPts val="400"/>
+              </a:spcAft>
+            </a:pPr>
+            <a:r>
+              <a:rPr sz="1150" b="0" i="0">
+                <a:solidFill>
+                  <a:srgbClr val="1F2937"/>
+                </a:solidFill>
+                <a:latin typeface="Calibri"/>
+              </a:rPr>
+              <a:t>thiếu hụt tri thức
+không khắc phục được</a:t>
+            </a:r>
+          </a:p>
+        </p:txBody>
+      </p:sp>
+      <p:sp>
+        <p:nvSpPr>
+          <p:cNvPr id="12" name="TextBox 11"/>
+          <p:cNvSpPr txBox="1"/>
+          <p:nvPr/>
+        </p:nvSpPr>
+        <p:spPr>
+          <a:xfrm>
+            <a:off x="640080" y="4160520"/>
+            <a:ext cx="10972800" cy="1737360"/>
           </a:xfrm>
           <a:prstGeom prst="rect">
             <a:avLst/>
@@ -4642,7 +4621,7 @@
           </a:bodyPr>
           <a:lstStyle/>
           <a:p>
-            <a:pPr algn="ctr">
+            <a:pPr algn="l">
               <a:spcBef>
                 <a:spcPts val="0"/>
               </a:spcBef>
@@ -4651,40 +4630,26 @@
               </a:spcAft>
             </a:pPr>
             <a:r>
-              <a:rPr sz="2700" b="1" i="0">
-                <a:solidFill>
-                  <a:srgbClr val="B91C1C"/>
-                </a:solidFill>
-                <a:latin typeface="Calibri"/>
-              </a:rPr>
-              <a:t>13</a:t>
-            </a:r>
-          </a:p>
-        </p:txBody>
-      </p:sp>
-      <p:sp>
-        <p:nvSpPr>
-          <p:cNvPr id="14" name="TextBox 13"/>
-          <p:cNvSpPr txBox="1"/>
-          <p:nvPr/>
-        </p:nvSpPr>
-        <p:spPr>
-          <a:xfrm>
-            <a:off x="8138160" y="3017520"/>
-            <a:ext cx="3291840" cy="640080"/>
-          </a:xfrm>
-          <a:prstGeom prst="rect">
-            <a:avLst/>
-          </a:prstGeom>
-          <a:noFill/>
-        </p:spPr>
-        <p:txBody>
-          <a:bodyPr wrap="square" anchor="t">
-            <a:spAutoFit/>
-          </a:bodyPr>
-          <a:lstStyle/>
-          <a:p>
-            <a:pPr algn="ctr">
+              <a:rPr sz="1400" b="1" i="0">
+                <a:solidFill>
+                  <a:srgbClr val="C2550B"/>
+                </a:solidFill>
+                <a:latin typeface="Calibri"/>
+              </a:rPr>
+              <a:t>Phần khắc phục được là các bài toán định lượng xác định</a:t>
+            </a:r>
+            <a:r>
+              <a:rPr sz="1300" b="0" i="0">
+                <a:solidFill>
+                  <a:srgbClr val="1F2937"/>
+                </a:solidFill>
+                <a:latin typeface="Calibri"/>
+              </a:rPr>
+              <a:t> (Henderson–Hasselbalch, tốc độ động cơ, trị riêng, kinh tế – địa lý),</a:t>
+            </a:r>
+          </a:p>
+          <a:p>
+            <a:pPr algn="l">
               <a:spcBef>
                 <a:spcPts val="0"/>
               </a:spcBef>
@@ -4693,39 +4658,15 @@
               </a:spcAft>
             </a:pPr>
             <a:r>
-              <a:rPr sz="1150" b="0" i="0">
+              <a:rPr sz="1300" b="0" i="0">
                 <a:solidFill>
                   <a:srgbClr val="1F2937"/>
                 </a:solidFill>
                 <a:latin typeface="Calibri"/>
               </a:rPr>
-              <a:t>knowledge‑gap
-không gỡ được</a:t>
-            </a:r>
-          </a:p>
-        </p:txBody>
-      </p:sp>
-      <p:sp>
-        <p:nvSpPr>
-          <p:cNvPr id="15" name="TextBox 14"/>
-          <p:cNvSpPr txBox="1"/>
-          <p:nvPr/>
-        </p:nvSpPr>
-        <p:spPr>
-          <a:xfrm>
-            <a:off x="640080" y="4114800"/>
-            <a:ext cx="10972800" cy="1737360"/>
-          </a:xfrm>
-          <a:prstGeom prst="rect">
-            <a:avLst/>
-          </a:prstGeom>
-          <a:noFill/>
-        </p:spPr>
-        <p:txBody>
-          <a:bodyPr wrap="square" anchor="t">
-            <a:spAutoFit/>
-          </a:bodyPr>
-          <a:lstStyle/>
+              <a:t>đúng phạm vi mà kỹ thuật TIR và CoT (đã xây dựng) hướng tới, không phải phần một mô hình thẩm định Qwen có thể bổ sung.</a:t>
+            </a:r>
+          </a:p>
           <a:p>
             <a:pPr algn="l">
               <a:spcBef>
@@ -4736,22 +4677,13 @@
               </a:spcAft>
             </a:pPr>
             <a:r>
-              <a:rPr sz="1400" b="1" i="0">
-                <a:solidFill>
-                  <a:srgbClr val="C2550B"/>
-                </a:solidFill>
-                <a:latin typeface="Calibri"/>
-              </a:rPr>
-              <a:t>Phần gỡ được là TOÁN/LÝ xác định + suy luận</a:t>
-            </a:r>
-            <a:r>
               <a:rPr sz="1300" b="0" i="0">
                 <a:solidFill>
-                  <a:srgbClr val="1F2937"/>
-                </a:solidFill>
-                <a:latin typeface="Calibri"/>
-              </a:rPr>
-              <a:t> (Henderson‑Hasselbalch, RPM động cơ, eigenvalue, kinh tế‑địa lý)…</a:t>
+                  <a:srgbClr val="6B7280"/>
+                </a:solidFill>
+                <a:latin typeface="Calibri"/>
+              </a:rPr>
+              <a:t>13 câu còn lại thuộc tri thức hành chính 2025 và dữ kiện địa phương, không mô hình hợp lệ nào khắc phục được với chi phí thấp.</a:t>
             </a:r>
           </a:p>
           <a:p>
@@ -4764,58 +4696,20 @@
               </a:spcAft>
             </a:pPr>
             <a:r>
-              <a:rPr sz="1350" b="1" i="0">
-                <a:solidFill>
-                  <a:srgbClr val="1F2937"/>
-                </a:solidFill>
-                <a:latin typeface="Calibri"/>
-              </a:rPr>
-              <a:t>→ đúng thứ đòn bẩy TIR + CoT (đã xây) nhắm tới — KHÔNG phải thứ một adjudicator Qwen mở khoá.</a:t>
-            </a:r>
-          </a:p>
-          <a:p>
-            <a:pPr algn="l">
-              <a:spcBef>
-                <a:spcPts val="0"/>
-              </a:spcBef>
-              <a:spcAft>
-                <a:spcPts val="300"/>
-              </a:spcAft>
-            </a:pPr>
-            <a:r>
-              <a:rPr sz="1300" b="0" i="0">
-                <a:solidFill>
-                  <a:srgbClr val="6B7280"/>
-                </a:solidFill>
-                <a:latin typeface="Calibri"/>
-              </a:rPr>
-              <a:t>13 câu là fact hành chính VN‑2025 / trivia địa phương → không mô hình hợp lệ nào phá được rẻ.</a:t>
-            </a:r>
-          </a:p>
-          <a:p>
-            <a:pPr algn="l">
-              <a:spcBef>
-                <a:spcPts val="0"/>
-              </a:spcBef>
-              <a:spcAft>
-                <a:spcPts val="300"/>
-              </a:spcAft>
-            </a:pPr>
-            <a:r>
-              <a:rPr sz="1400" b="1" i="0">
+              <a:rPr sz="1300" b="0" i="1">
                 <a:solidFill>
                   <a:srgbClr val="15803D"/>
                 </a:solidFill>
                 <a:latin typeface="Calibri"/>
               </a:rPr>
-              <a:t>Chúng tôi báo SỐ ĐO THẬT, không hứa số.</a:t>
-            </a:r>
-          </a:p>
-        </p:txBody>
-      </p:sp>
-      <p:sp>
-        <p:nvSpPr>
-          <p:cNvPr id="16" name="TextBox 15"/>
+              <a:t>Tài liệu trình bày số liệu đo được, không cam kết số liệu chưa kiểm chứng.</a:t>
+            </a:r>
+          </a:p>
+        </p:txBody>
+      </p:sp>
+      <p:sp>
+        <p:nvSpPr>
+          <p:cNvPr id="13" name="TextBox 12"/>
           <p:cNvSpPr txBox="1"/>
           <p:nvPr/>
         </p:nvSpPr>
@@ -4998,7 +4892,7 @@
                 </a:solidFill>
                 <a:latin typeface="Calibri"/>
               </a:rPr>
-              <a:t>10 · BÀI NỘP</a:t>
+              <a:t>10 · Bài nộp</a:t>
             </a:r>
           </a:p>
         </p:txBody>
@@ -5034,13 +4928,13 @@
               </a:spcAft>
             </a:pPr>
             <a:r>
-              <a:rPr sz="2300" b="1" i="0">
+              <a:rPr sz="2200" b="1" i="0">
                 <a:solidFill>
                   <a:srgbClr val="1F2937"/>
                 </a:solidFill>
                 <a:latin typeface="Calibri"/>
               </a:rPr>
-              <a:t>Tái lập kết quả trong container chỉ với HAI lệnh.</a:t>
+              <a:t>Tái lập kết quả trong container bằng hai câu lệnh.</a:t>
             </a:r>
           </a:p>
         </p:txBody>
@@ -5053,7 +4947,7 @@
         </p:nvSpPr>
         <p:spPr>
           <a:xfrm>
-            <a:off x="640080" y="2011680"/>
+            <a:off x="640080" y="2148840"/>
             <a:ext cx="10972800" cy="1783080"/>
           </a:xfrm>
           <a:prstGeom prst="rect">
@@ -5097,7 +4991,7 @@
         </p:nvSpPr>
         <p:spPr>
           <a:xfrm>
-            <a:off x="868680" y="2194560"/>
+            <a:off x="868680" y="2331720"/>
             <a:ext cx="10607040" cy="1600200"/>
           </a:xfrm>
           <a:prstGeom prst="rect">
@@ -5126,7 +5020,7 @@
                 </a:solidFill>
                 <a:latin typeface="Calibri"/>
               </a:rPr>
-              <a:t># 1 · kéo image tự chứa (model nướng sẵn bên trong)</a:t>
+              <a:t># 1. Tải ảnh tự chứa (mô hình đã đóng gói sẵn bên trong)</a:t>
             </a:r>
           </a:p>
           <a:p>
@@ -5164,7 +5058,7 @@
                 </a:solidFill>
                 <a:latin typeface="Calibri"/>
               </a:rPr>
-              <a:t># 2 · chạy trên thư mục chứa public_test.csv / private_test.csv</a:t>
+              <a:t># 2. Chạy trên thư mục chứa public_test.csv hoặc private_test.csv</a:t>
             </a:r>
           </a:p>
           <a:p>
@@ -5202,7 +5096,7 @@
                 </a:solidFill>
                 <a:latin typeface="Calibri"/>
               </a:rPr>
-              <a:t>    hacamy12345/neko-core:gemma26b-q4   →  ./out/pred.csv</a:t>
+              <a:t>    hacamy12345/neko-core:gemma26b-q4       (kết quả: ./out/pred.csv)</a:t>
             </a:r>
           </a:p>
         </p:txBody>
@@ -5215,7 +5109,7 @@
         </p:nvSpPr>
         <p:spPr>
           <a:xfrm>
-            <a:off x="640080" y="4069080"/>
+            <a:off x="640080" y="4206240"/>
             <a:ext cx="10972800" cy="1737360"/>
           </a:xfrm>
           <a:prstGeom prst="rect">
@@ -5238,13 +5132,13 @@
               </a:spcAft>
             </a:pPr>
             <a:r>
-              <a:rPr sz="1350" b="1" i="0">
+              <a:rPr sz="1350" b="0" i="0">
                 <a:solidFill>
                   <a:srgbClr val="1F2937"/>
                 </a:solidFill>
                 <a:latin typeface="Calibri"/>
               </a:rPr>
-              <a:t>Mô hình ship: Gemma‑4‑26B‑A4B QAT‑Q4_0 (MoE ~15GB) — chạy mọi GPU, 0 rủi ro OOM.</a:t>
+              <a:t>Mô hình triển khai: Gemma‑4‑26B‑A4B QAT‑Q4_0 (kiến trúc MoE, ~15GB), chạy được trên mọi GPU, không rủi ro tràn bộ nhớ.</a:t>
             </a:r>
           </a:p>
           <a:p>
@@ -5263,7 +5157,7 @@
                 </a:solidFill>
                 <a:latin typeface="Calibri"/>
               </a:rPr>
-              <a:t>Đường chạy: self‑consistency CoT (k=1, 2048) + an‑toàn‑từ‑chối + constrained‑repair + contract‑repair, gated TIR.</a:t>
+              <a:t>Quy trình suy luận: chain‑of‑thought tự nhất quán (k=1, 2048 token), an‑toàn‑từ‑chối, hiệu chỉnh ràng buộc và hiệu chỉnh hợp đồng, kèm TIR có điều kiện.</a:t>
             </a:r>
           </a:p>
           <a:p>
@@ -5282,7 +5176,7 @@
                 </a:solidFill>
                 <a:latin typeface="Calibri"/>
               </a:rPr>
-              <a:t>Code + reproduce: README.md · Tài liệu đầy đủ: docs/method-writeup-vi.md · 211 test xanh.</a:t>
+              <a:t>Mã nguồn và hướng dẫn tái lập: README.md. Tài liệu đầy đủ: docs/method-writeup-vi.md. 211 ca kiểm thử đạt.</a:t>
             </a:r>
           </a:p>
         </p:txBody>
@@ -5443,8 +5337,8 @@
         </p:nvSpPr>
         <p:spPr>
           <a:xfrm>
-            <a:off x="822960" y="1828800"/>
-            <a:ext cx="10515600" cy="914400"/>
+            <a:off x="822960" y="1783080"/>
+            <a:ext cx="10515600" cy="1005840"/>
           </a:xfrm>
           <a:prstGeom prst="rect">
             <a:avLst/>
@@ -5466,13 +5360,13 @@
               </a:spcAft>
             </a:pPr>
             <a:r>
-              <a:rPr sz="2700" b="1" i="0">
+              <a:rPr sz="2500" b="1" i="0">
                 <a:solidFill>
                   <a:srgbClr val="FFFFFF"/>
                 </a:solidFill>
                 <a:latin typeface="Calibri"/>
               </a:rPr>
-              <a:t>Mô hình suy luận. Harness đo lường. Số liệu quyết định.</a:t>
+              <a:t>Phương pháp luận: mô hình suy luận, hệ thống đo lường, quyết định dựa trên số liệu thực nghiệm.</a:t>
             </a:r>
           </a:p>
         </p:txBody>
@@ -5485,7 +5379,7 @@
         </p:nvSpPr>
         <p:spPr>
           <a:xfrm>
-            <a:off x="822960" y="3108960"/>
+            <a:off x="822960" y="3154680"/>
             <a:ext cx="10515600" cy="1463040"/>
           </a:xfrm>
           <a:prstGeom prst="rect">
@@ -5514,7 +5408,7 @@
                 </a:solidFill>
                 <a:latin typeface="Calibri"/>
               </a:rPr>
-              <a:t>88.55 trên leaderboard · hợp đồng pred.csv bất khả xâm phạm · điểm Time bảo vệ bằng MoE + MTP</a:t>
+              <a:t>Kết quả 88.55 trên leaderboard, cơ chế bảo đảm tính toàn vẹn của pred.csv, điểm thời gian được bảo vệ bằng kiến trúc MoE và MTP,</a:t>
             </a:r>
           </a:p>
           <a:p>
@@ -5533,7 +5427,7 @@
                 </a:solidFill>
                 <a:latin typeface="Calibri"/>
               </a:rPr>
-              <a:t>· và một kỷ luật chống overfit đo‑thật cho 2000 câu private.</a:t>
+              <a:t>cùng kỷ luật chống quá khớp dựa trên đo lường cho tập 2000 câu hỏi riêng.</a:t>
             </a:r>
           </a:p>
         </p:txBody>
@@ -5723,7 +5617,7 @@
                 </a:solidFill>
                 <a:latin typeface="Calibri"/>
               </a:rPr>
-              <a:t>TÓM TẮT</a:t>
+              <a:t>Tóm tắt</a:t>
             </a:r>
           </a:p>
         </p:txBody>
@@ -5759,13 +5653,13 @@
               </a:spcAft>
             </a:pPr>
             <a:r>
-              <a:rPr sz="2300" b="1" i="0">
+              <a:rPr sz="2200" b="1" i="0">
                 <a:solidFill>
                   <a:srgbClr val="1F2937"/>
                 </a:solidFill>
                 <a:latin typeface="Calibri"/>
               </a:rPr>
-              <a:t>Một Gemma offline 15GB đạt 88.55 nhờ ba thế mạnh — không phải nhờ mô hình lớn hơn.</a:t>
+              <a:t>Mô hình Gemma‑4 ngoại tuyến (~15GB) đạt 88.55 nhờ ba trụ cột phương pháp.</a:t>
             </a:r>
           </a:p>
         </p:txBody>
@@ -5891,13 +5785,13 @@
               </a:spcAft>
             </a:pPr>
             <a:r>
-              <a:rPr sz="1700" b="1" i="0">
+              <a:rPr sz="1600" b="1" i="0">
                 <a:solidFill>
                   <a:srgbClr val="F97316"/>
                 </a:solidFill>
                 <a:latin typeface="Calibri"/>
               </a:rPr>
-              <a:t>Engine đo‑thật</a:t>
+              <a:t>Suy luận tự nhất quán</a:t>
             </a:r>
           </a:p>
           <a:p>
@@ -5929,13 +5823,13 @@
               </a:spcAft>
             </a:pPr>
             <a:r>
-              <a:rPr sz="1300" b="0" i="0">
+              <a:rPr sz="1250" b="0" i="0">
                 <a:solidFill>
                   <a:srgbClr val="1F2937"/>
                 </a:solidFill>
                 <a:latin typeface="Calibri"/>
               </a:rPr>
-              <a:t>Self‑consistency CoT đưa accuracy 77.11 → 88.55 trên leaderboard. Mỗi đòn bẩy chỉ giữ khi đo được nó sinh lời.</a:t>
+              <a:t>Cơ chế chain‑of‑thought tự nhất quán nâng độ chính xác từ 77.11 lên 88.55 (đo trên leaderboard). Mỗi cải tiến chỉ được giữ lại sau khi đo lường xác nhận hiệu quả.</a:t>
             </a:r>
           </a:p>
         </p:txBody>
@@ -6061,13 +5955,13 @@
               </a:spcAft>
             </a:pPr>
             <a:r>
-              <a:rPr sz="1700" b="1" i="0">
+              <a:rPr sz="1600" b="1" i="0">
                 <a:solidFill>
                   <a:srgbClr val="15803D"/>
                 </a:solidFill>
                 <a:latin typeface="Calibri"/>
               </a:rPr>
-              <a:t>Bất khả xâm phạm</a:t>
+              <a:t>Bảo đảm tính toàn vẹn</a:t>
             </a:r>
           </a:p>
           <a:p>
@@ -6099,13 +5993,13 @@
               </a:spcAft>
             </a:pPr>
             <a:r>
-              <a:rPr sz="1300" b="0" i="0">
+              <a:rPr sz="1250" b="0" i="0">
                 <a:solidFill>
                   <a:srgbClr val="1F2937"/>
                 </a:solidFill>
                 <a:latin typeface="Calibri"/>
               </a:rPr>
-              <a:t>Hợp đồng pred.csv: một câu lỗi không thể làm mất trắng 2000 câu. Retry → fallback → checkpoint‑resume ba lớp.</a:t>
+              <a:t>Hợp đồng đầu ra bảo đảm tệp pred.csv luôn hợp lệ; một lỗi cục bộ không làm mất toàn bộ kết quả. Ba lớp phục hồi: thử lại, dự phòng và khôi phục theo checkpoint.</a:t>
             </a:r>
           </a:p>
         </p:txBody>
@@ -6231,13 +6125,13 @@
               </a:spcAft>
             </a:pPr>
             <a:r>
-              <a:rPr sz="1700" b="1" i="0">
+              <a:rPr sz="1600" b="1" i="0">
                 <a:solidFill>
                   <a:srgbClr val="C2550B"/>
                 </a:solidFill>
                 <a:latin typeface="Calibri"/>
               </a:rPr>
-              <a:t>Nhanh &amp; khả thi</a:t>
+              <a:t>Hiệu năng và khả thi</a:t>
             </a:r>
           </a:p>
           <a:p>
@@ -6269,13 +6163,13 @@
               </a:spcAft>
             </a:pPr>
             <a:r>
-              <a:rPr sz="1300" b="0" i="0">
+              <a:rPr sz="1250" b="0" i="0">
                 <a:solidFill>
                   <a:srgbClr val="1F2937"/>
                 </a:solidFill>
                 <a:latin typeface="Calibri"/>
               </a:rPr>
-              <a:t>MoE ~4B active + núm token phẳng → 2000 câu ~1.5h, điểm Time an toàn. MTP lossless để dành tăng tốc 1.4–2.2×.</a:t>
+              <a:t>Kiến trúc MoE (~4B tham số kích hoạt) hoàn tất 2000 câu trong khoảng 1,5 giờ, bảo đảm điểm thời gian. Kỹ thuật MTP tăng tốc 1,4–2,2 lần mà không suy giảm độ chính xác.</a:t>
             </a:r>
           </a:p>
         </p:txBody>
@@ -6311,13 +6205,13 @@
               </a:spcAft>
             </a:pPr>
             <a:r>
-              <a:rPr sz="1250" b="0" i="1">
+              <a:rPr sz="1200" b="0" i="1">
                 <a:solidFill>
                   <a:srgbClr val="6B7280"/>
                 </a:solidFill>
                 <a:latin typeface="Calibri"/>
               </a:rPr>
-              <a:t>Định vị trung thực: 88.55 là gần trần thật của một Gemma offline; phần còn lại là kiến‑thức‑VN không retrieval được. Chúng tôi báo số đo thật, không hứa số.</a:t>
+              <a:t>Định vị khách quan: 88.55 tiệm cận giới hạn thực tế của một mô hình Gemma ngoại tuyến; phần sai số còn lại chủ yếu thuộc tri thức đặc thù không truy hồi được. Tài liệu trình bày số liệu đo được, không cam kết số liệu chưa kiểm chứng.</a:t>
             </a:r>
           </a:p>
         </p:txBody>
@@ -6507,7 +6401,7 @@
                 </a:solidFill>
                 <a:latin typeface="Calibri"/>
               </a:rPr>
-              <a:t>01 · BÀI TOÁN</a:t>
+              <a:t>01 · Bài toán</a:t>
             </a:r>
           </a:p>
         </p:txBody>
@@ -6543,13 +6437,13 @@
               </a:spcAft>
             </a:pPr>
             <a:r>
-              <a:rPr sz="2300" b="1" i="0">
+              <a:rPr sz="2200" b="1" i="0">
                 <a:solidFill>
                   <a:srgbClr val="1F2937"/>
                 </a:solidFill>
                 <a:latin typeface="Calibri"/>
               </a:rPr>
-              <a:t>Chấm 2000 câu private theo Accuracy 80 / Time 10 / Ý tưởng 10 — nên mọi đòn bẩy phải TỔNG QUÁT HOÁ.</a:t>
+              <a:t>Bài toán yêu cầu tổng quát hóa trên 2000 câu hỏi đa lĩnh vực; chấm theo Độ chính xác 80, Thời gian 10, Ý tưởng 10.</a:t>
             </a:r>
           </a:p>
         </p:txBody>
@@ -6562,7 +6456,7 @@
         </p:nvSpPr>
         <p:spPr>
           <a:xfrm>
-            <a:off x="640080" y="1920240"/>
+            <a:off x="640080" y="2057400"/>
             <a:ext cx="6675120" cy="2743200"/>
           </a:xfrm>
           <a:prstGeom prst="rect">
@@ -6591,7 +6485,7 @@
                 </a:solidFill>
                 <a:latin typeface="Calibri"/>
               </a:rPr>
-              <a:t>Container </a:t>
+              <a:t>Hệ thống được đóng gói trong một container </a:t>
             </a:r>
             <a:r>
               <a:rPr sz="1400" b="1" i="0">
@@ -6600,7 +6494,7 @@
                 </a:solidFill>
                 <a:latin typeface="Calibri"/>
               </a:rPr>
-              <a:t>offline, tự chứa</a:t>
+              <a:t>ngoại tuyến, tự chứa</a:t>
             </a:r>
             <a:r>
               <a:rPr sz="1400" b="0" i="0">
@@ -6609,7 +6503,7 @@
                 </a:solidFill>
                 <a:latin typeface="Calibri"/>
               </a:rPr>
-              <a:t> (không web, không API key) đọc </a:t>
+              <a:t> (không truy cập mạng, không cần khóa API), đọc tệp </a:t>
             </a:r>
             <a:r>
               <a:rPr sz="1400" b="1" i="0">
@@ -6627,7 +6521,7 @@
                 </a:solidFill>
                 <a:latin typeface="Calibri"/>
               </a:rPr>
-              <a:t> → ghi </a:t>
+              <a:t> và ghi kết quả ra </a:t>
             </a:r>
             <a:r>
               <a:rPr sz="1400" b="1" i="0">
@@ -6645,7 +6539,7 @@
                 </a:solidFill>
                 <a:latin typeface="Calibri"/>
               </a:rPr>
-              <a:t> (qid,answer).</a:t>
+              <a:t> với hai cột qid, answer.</a:t>
             </a:r>
           </a:p>
           <a:p>
@@ -6683,7 +6577,7 @@
                 </a:solidFill>
                 <a:latin typeface="Calibri"/>
               </a:rPr>
-              <a:t>Bộ private đa lĩnh vực / đa ngôn ngữ → bất cứ thứ gì gắn cứng vào một câu hay một ngôn ngữ là gánh nặng, sẽ bị loại bỏ hoặc tổng quát hoá qua config.</a:t>
+              <a:t>Do tập kiểm thử đa lĩnh vực và đa ngôn ngữ, mọi kỹ thuật gắn cứng với một câu hỏi hay một ngôn ngữ cụ thể đều bị loại bỏ hoặc tổng quát hóa thông qua cấu hình.</a:t>
             </a:r>
           </a:p>
         </p:txBody>
@@ -6697,7 +6591,7 @@
           <p:nvPr/>
         </p:nvGraphicFramePr>
         <p:xfrm>
-          <a:off x="7589520" y="2011680"/>
+          <a:off x="7589520" y="2148840"/>
           <a:ext cx="4023360" cy="2194560"/>
         </p:xfrm>
         <a:graphic>
@@ -6723,7 +6617,7 @@
                           </a:solidFill>
                           <a:latin typeface="Calibri"/>
                         </a:rPr>
-                        <a:t>Tiêu chí Vòng‑2</a:t>
+                        <a:t>Tiêu chí Vòng 2</a:t>
                       </a:r>
                     </a:p>
                   </a:txBody>
@@ -6769,7 +6663,7 @@
                           </a:solidFill>
                           <a:latin typeface="Calibri"/>
                         </a:rPr>
-                        <a:t>Accuracy</a:t>
+                        <a:t>Độ chính xác</a:t>
                       </a:r>
                     </a:p>
                   </a:txBody>
@@ -6791,7 +6685,7 @@
                           </a:solidFill>
                           <a:latin typeface="Calibri"/>
                         </a:rPr>
-                        <a:t>80đ</a:t>
+                        <a:t>80</a:t>
                       </a:r>
                     </a:p>
                   </a:txBody>
@@ -6837,7 +6731,7 @@
                           </a:solidFill>
                           <a:latin typeface="Calibri"/>
                         </a:rPr>
-                        <a:t>10đ</a:t>
+                        <a:t>10</a:t>
                       </a:r>
                     </a:p>
                   </a:txBody>
@@ -6883,7 +6777,7 @@
                           </a:solidFill>
                           <a:latin typeface="Calibri"/>
                         </a:rPr>
-                        <a:t>10đ ←</a:t>
+                        <a:t>10</a:t>
                       </a:r>
                     </a:p>
                   </a:txBody>
@@ -6906,7 +6800,7 @@
         </p:nvSpPr>
         <p:spPr>
           <a:xfrm>
-            <a:off x="7589520" y="4572000"/>
+            <a:off x="7589520" y="4709160"/>
             <a:ext cx="4023360" cy="365760"/>
           </a:xfrm>
           <a:prstGeom prst="rect">
@@ -6929,13 +6823,13 @@
               </a:spcAft>
             </a:pPr>
             <a:r>
-              <a:rPr sz="1150" b="1" i="1">
+              <a:rPr sz="1150" b="0" i="1">
                 <a:solidFill>
                   <a:srgbClr val="C2550B"/>
                 </a:solidFill>
                 <a:latin typeface="Calibri"/>
               </a:rPr>
-              <a:t>Tài liệu này ăn điểm Ý tưởng.</a:t>
+              <a:t>Tài liệu này tương ứng với tiêu chí Ý tưởng.</a:t>
             </a:r>
           </a:p>
         </p:txBody>
@@ -7125,7 +7019,7 @@
                 </a:solidFill>
                 <a:latin typeface="Calibri"/>
               </a:rPr>
-              <a:t>02 · TRIẾT LÝ</a:t>
+              <a:t>02 · Nguyên tắc thiết kế</a:t>
             </a:r>
           </a:p>
         </p:txBody>
@@ -7161,13 +7055,13 @@
               </a:spcAft>
             </a:pPr>
             <a:r>
-              <a:rPr sz="2300" b="1" i="0">
+              <a:rPr sz="2200" b="1" i="0">
                 <a:solidFill>
                   <a:srgbClr val="1F2937"/>
                 </a:solidFill>
                 <a:latin typeface="Calibri"/>
               </a:rPr>
-              <a:t>Để mô hình SUY LUẬN; harness chỉ điều phối và ĐO LƯỜNG.</a:t>
+              <a:t>Mô hình đảm nhận suy luận; hệ thống điều phối và đo lường.</a:t>
             </a:r>
           </a:p>
         </p:txBody>
@@ -7268,8 +7162,8 @@
         </p:nvSpPr>
         <p:spPr>
           <a:xfrm>
-            <a:off x="960119" y="2286000"/>
-            <a:ext cx="4846320" cy="502920"/>
+            <a:off x="960119" y="2240280"/>
+            <a:ext cx="4846320" cy="1463040"/>
           </a:xfrm>
           <a:prstGeom prst="rect">
             <a:avLst/>
@@ -7277,7 +7171,7 @@
           <a:noFill/>
         </p:spPr>
         <p:txBody>
-          <a:bodyPr wrap="square" anchor="t">
+          <a:bodyPr wrap="square" anchor="ctr">
             <a:spAutoFit/>
           </a:bodyPr>
           <a:lstStyle/>
@@ -7287,7 +7181,7 @@
                 <a:spcPts val="0"/>
               </a:spcBef>
               <a:spcAft>
-                <a:spcPts val="300"/>
+                <a:spcPts val="400"/>
               </a:spcAft>
             </a:pPr>
             <a:r>
@@ -7297,39 +7191,35 @@
                 </a:solidFill>
                 <a:latin typeface="Calibri"/>
               </a:rPr>
-              <a:t>1 · Mô hình suy luận, harness đo</a:t>
-            </a:r>
-          </a:p>
-        </p:txBody>
-      </p:sp>
-      <p:sp>
-        <p:nvSpPr>
-          <p:cNvPr id="9" name="TextBox 8"/>
-          <p:cNvSpPr txBox="1"/>
-          <p:nvPr/>
-        </p:nvSpPr>
-        <p:spPr>
-          <a:xfrm>
-            <a:off x="960119" y="2807208"/>
-            <a:ext cx="4846320" cy="914400"/>
-          </a:xfrm>
-          <a:prstGeom prst="rect">
-            <a:avLst/>
-          </a:prstGeom>
-          <a:noFill/>
-        </p:spPr>
-        <p:txBody>
-          <a:bodyPr wrap="square" anchor="t">
-            <a:spAutoFit/>
-          </a:bodyPr>
-          <a:lstStyle/>
+              <a:t>1. Phân tách vai trò</a:t>
+            </a:r>
+          </a:p>
           <a:p>
             <a:pPr algn="l">
               <a:spcBef>
                 <a:spcPts val="0"/>
               </a:spcBef>
               <a:spcAft>
-                <a:spcPts val="300"/>
+                <a:spcPts val="400"/>
+              </a:spcAft>
+            </a:pPr>
+            <a:r>
+              <a:rPr sz="600" b="0" i="0">
+                <a:solidFill>
+                  <a:srgbClr val="1F2937"/>
+                </a:solidFill>
+                <a:latin typeface="Calibri"/>
+              </a:rPr>
+              <a:t/>
+            </a:r>
+          </a:p>
+          <a:p>
+            <a:pPr algn="l">
+              <a:spcBef>
+                <a:spcPts val="0"/>
+              </a:spcBef>
+              <a:spcAft>
+                <a:spcPts val="400"/>
               </a:spcAft>
             </a:pPr>
             <a:r>
@@ -7339,14 +7229,14 @@
                 </a:solidFill>
                 <a:latin typeface="Calibri"/>
               </a:rPr>
-              <a:t>Không nhồi đáp án/công thức viết tay — cho mô hình không gian lập luận rồi đo độ tin cậy.</a:t>
-            </a:r>
-          </a:p>
-        </p:txBody>
-      </p:sp>
-      <p:sp>
-        <p:nvSpPr>
-          <p:cNvPr id="10" name="Rectangle 9"/>
+              <a:t>Không mã hóa cứng đáp án hay công thức; mô hình thực hiện suy luận, hệ thống đo lường độ tin cậy của kết quả.</a:t>
+            </a:r>
+          </a:p>
+        </p:txBody>
+      </p:sp>
+      <p:sp>
+        <p:nvSpPr>
+          <p:cNvPr id="9" name="Rectangle 8"/>
           <p:cNvSpPr/>
           <p:nvPr/>
         </p:nvSpPr>
@@ -7390,7 +7280,7 @@
       </p:sp>
       <p:sp>
         <p:nvSpPr>
-          <p:cNvPr id="11" name="Rectangle 10"/>
+          <p:cNvPr id="10" name="Rectangle 9"/>
           <p:cNvSpPr/>
           <p:nvPr/>
         </p:nvSpPr>
@@ -7434,14 +7324,14 @@
       </p:sp>
       <p:sp>
         <p:nvSpPr>
-          <p:cNvPr id="12" name="TextBox 11"/>
+          <p:cNvPr id="11" name="TextBox 10"/>
           <p:cNvSpPr txBox="1"/>
           <p:nvPr/>
         </p:nvSpPr>
         <p:spPr>
           <a:xfrm>
-            <a:off x="6583680" y="2286000"/>
-            <a:ext cx="4846320" cy="502920"/>
+            <a:off x="6583680" y="2240280"/>
+            <a:ext cx="4846320" cy="1463040"/>
           </a:xfrm>
           <a:prstGeom prst="rect">
             <a:avLst/>
@@ -7449,7 +7339,7 @@
           <a:noFill/>
         </p:spPr>
         <p:txBody>
-          <a:bodyPr wrap="square" anchor="t">
+          <a:bodyPr wrap="square" anchor="ctr">
             <a:spAutoFit/>
           </a:bodyPr>
           <a:lstStyle/>
@@ -7459,7 +7349,7 @@
                 <a:spcPts val="0"/>
               </a:spcBef>
               <a:spcAft>
-                <a:spcPts val="300"/>
+                <a:spcPts val="400"/>
               </a:spcAft>
             </a:pPr>
             <a:r>
@@ -7469,39 +7359,35 @@
                 </a:solidFill>
                 <a:latin typeface="Calibri"/>
               </a:rPr>
-              <a:t>2 · Chống overfit bằng thước đo</a:t>
-            </a:r>
-          </a:p>
-        </p:txBody>
-      </p:sp>
-      <p:sp>
-        <p:nvSpPr>
-          <p:cNvPr id="13" name="TextBox 12"/>
-          <p:cNvSpPr txBox="1"/>
-          <p:nvPr/>
-        </p:nvSpPr>
-        <p:spPr>
-          <a:xfrm>
-            <a:off x="6583680" y="2807208"/>
-            <a:ext cx="4846320" cy="914400"/>
-          </a:xfrm>
-          <a:prstGeom prst="rect">
-            <a:avLst/>
-          </a:prstGeom>
-          <a:noFill/>
-        </p:spPr>
-        <p:txBody>
-          <a:bodyPr wrap="square" anchor="t">
-            <a:spAutoFit/>
-          </a:bodyPr>
-          <a:lstStyle/>
+              <a:t>2. Chống quá khớp bằng đo lường</a:t>
+            </a:r>
+          </a:p>
           <a:p>
             <a:pPr algn="l">
               <a:spcBef>
                 <a:spcPts val="0"/>
               </a:spcBef>
               <a:spcAft>
-                <a:spcPts val="300"/>
+                <a:spcPts val="400"/>
+              </a:spcAft>
+            </a:pPr>
+            <a:r>
+              <a:rPr sz="600" b="0" i="0">
+                <a:solidFill>
+                  <a:srgbClr val="1F2937"/>
+                </a:solidFill>
+                <a:latin typeface="Calibri"/>
+              </a:rPr>
+              <a:t/>
+            </a:r>
+          </a:p>
+          <a:p>
+            <a:pPr algn="l">
+              <a:spcBef>
+                <a:spcPts val="0"/>
+              </a:spcBef>
+              <a:spcAft>
+                <a:spcPts val="400"/>
               </a:spcAft>
             </a:pPr>
             <a:r>
@@ -7511,14 +7397,14 @@
                 </a:solidFill>
                 <a:latin typeface="Calibri"/>
               </a:rPr>
-              <a:t>Một đòn bẩy chỉ ship khi tổng quát hoá, chứng minh bằng đo thật — không phải bằng một câu chuyện hợp lý.</a:t>
-            </a:r>
-          </a:p>
-        </p:txBody>
-      </p:sp>
-      <p:sp>
-        <p:nvSpPr>
-          <p:cNvPr id="14" name="Rectangle 13"/>
+              <a:t>Một kỹ thuật chỉ được triển khai khi chứng minh được khả năng tổng quát hóa bằng kết quả thực nghiệm, không dựa trên giả định.</a:t>
+            </a:r>
+          </a:p>
+        </p:txBody>
+      </p:sp>
+      <p:sp>
+        <p:nvSpPr>
+          <p:cNvPr id="12" name="Rectangle 11"/>
           <p:cNvSpPr/>
           <p:nvPr/>
         </p:nvSpPr>
@@ -7562,7 +7448,7 @@
       </p:sp>
       <p:sp>
         <p:nvSpPr>
-          <p:cNvPr id="15" name="Rectangle 14"/>
+          <p:cNvPr id="13" name="Rectangle 12"/>
           <p:cNvSpPr/>
           <p:nvPr/>
         </p:nvSpPr>
@@ -7606,14 +7492,14 @@
       </p:sp>
       <p:sp>
         <p:nvSpPr>
-          <p:cNvPr id="16" name="TextBox 15"/>
+          <p:cNvPr id="14" name="TextBox 13"/>
           <p:cNvSpPr txBox="1"/>
           <p:nvPr/>
         </p:nvSpPr>
         <p:spPr>
           <a:xfrm>
-            <a:off x="960119" y="4297680"/>
-            <a:ext cx="4846320" cy="502920"/>
+            <a:off x="960119" y="4251960"/>
+            <a:ext cx="4846320" cy="1463040"/>
           </a:xfrm>
           <a:prstGeom prst="rect">
             <a:avLst/>
@@ -7621,7 +7507,7 @@
           <a:noFill/>
         </p:spPr>
         <p:txBody>
-          <a:bodyPr wrap="square" anchor="t">
+          <a:bodyPr wrap="square" anchor="ctr">
             <a:spAutoFit/>
           </a:bodyPr>
           <a:lstStyle/>
@@ -7631,7 +7517,7 @@
                 <a:spcPts val="0"/>
               </a:spcBef>
               <a:spcAft>
-                <a:spcPts val="300"/>
+                <a:spcPts val="400"/>
               </a:spcAft>
             </a:pPr>
             <a:r>
@@ -7641,39 +7527,35 @@
                 </a:solidFill>
                 <a:latin typeface="Calibri"/>
               </a:rPr>
-              <a:t>3 · Đo độ bất định thật</a:t>
-            </a:r>
-          </a:p>
-        </p:txBody>
-      </p:sp>
-      <p:sp>
-        <p:nvSpPr>
-          <p:cNvPr id="17" name="TextBox 16"/>
-          <p:cNvSpPr txBox="1"/>
-          <p:nvPr/>
-        </p:nvSpPr>
-        <p:spPr>
-          <a:xfrm>
-            <a:off x="960119" y="4818888"/>
-            <a:ext cx="4846320" cy="914400"/>
-          </a:xfrm>
-          <a:prstGeom prst="rect">
-            <a:avLst/>
-          </a:prstGeom>
-          <a:noFill/>
-        </p:spPr>
-        <p:txBody>
-          <a:bodyPr wrap="square" anchor="t">
-            <a:spAutoFit/>
-          </a:bodyPr>
-          <a:lstStyle/>
+              <a:t>3. Hiệu chỉnh độ bất định</a:t>
+            </a:r>
+          </a:p>
           <a:p>
             <a:pPr algn="l">
               <a:spcBef>
                 <a:spcPts val="0"/>
               </a:spcBef>
               <a:spcAft>
-                <a:spcPts val="300"/>
+                <a:spcPts val="400"/>
+              </a:spcAft>
+            </a:pPr>
+            <a:r>
+              <a:rPr sz="600" b="0" i="0">
+                <a:solidFill>
+                  <a:srgbClr val="1F2937"/>
+                </a:solidFill>
+                <a:latin typeface="Calibri"/>
+              </a:rPr>
+              <a:t/>
+            </a:r>
+          </a:p>
+          <a:p>
+            <a:pPr algn="l">
+              <a:spcBef>
+                <a:spcPts val="0"/>
+              </a:spcBef>
+              <a:spcAft>
+                <a:spcPts val="400"/>
               </a:spcAft>
             </a:pPr>
             <a:r>
@@ -7683,14 +7565,14 @@
                 </a:solidFill>
                 <a:latin typeface="Calibri"/>
               </a:rPr>
-              <a:t>Confidence = mức đồng thuận khi lấy mẫu → harness 'nhìn thấy' chỗ dễ sai, chỉ tốn compute ở đó.</a:t>
-            </a:r>
-          </a:p>
-        </p:txBody>
-      </p:sp>
-      <p:sp>
-        <p:nvSpPr>
-          <p:cNvPr id="18" name="Rectangle 17"/>
+              <a:t>Độ tin cậy được ước lượng từ mức đồng thuận giữa các mẫu suy luận, cho phép tập trung tài nguyên tính toán vào câu hỏi khó.</a:t>
+            </a:r>
+          </a:p>
+        </p:txBody>
+      </p:sp>
+      <p:sp>
+        <p:nvSpPr>
+          <p:cNvPr id="15" name="Rectangle 14"/>
           <p:cNvSpPr/>
           <p:nvPr/>
         </p:nvSpPr>
@@ -7734,7 +7616,7 @@
       </p:sp>
       <p:sp>
         <p:nvSpPr>
-          <p:cNvPr id="19" name="Rectangle 18"/>
+          <p:cNvPr id="16" name="Rectangle 15"/>
           <p:cNvSpPr/>
           <p:nvPr/>
         </p:nvSpPr>
@@ -7778,14 +7660,14 @@
       </p:sp>
       <p:sp>
         <p:nvSpPr>
-          <p:cNvPr id="20" name="TextBox 19"/>
+          <p:cNvPr id="17" name="TextBox 16"/>
           <p:cNvSpPr txBox="1"/>
           <p:nvPr/>
         </p:nvSpPr>
         <p:spPr>
           <a:xfrm>
-            <a:off x="6583680" y="4297680"/>
-            <a:ext cx="4846320" cy="502920"/>
+            <a:off x="6583680" y="4251960"/>
+            <a:ext cx="4846320" cy="1463040"/>
           </a:xfrm>
           <a:prstGeom prst="rect">
             <a:avLst/>
@@ -7793,7 +7675,7 @@
           <a:noFill/>
         </p:spPr>
         <p:txBody>
-          <a:bodyPr wrap="square" anchor="t">
+          <a:bodyPr wrap="square" anchor="ctr">
             <a:spAutoFit/>
           </a:bodyPr>
           <a:lstStyle/>
@@ -7803,7 +7685,7 @@
                 <a:spcPts val="0"/>
               </a:spcBef>
               <a:spcAft>
-                <a:spcPts val="300"/>
+                <a:spcPts val="400"/>
               </a:spcAft>
             </a:pPr>
             <a:r>
@@ -7813,39 +7695,35 @@
                 </a:solidFill>
                 <a:latin typeface="Calibri"/>
               </a:rPr>
-              <a:t>4 · Ranh giới runtime/dev cứng</a:t>
-            </a:r>
-          </a:p>
-        </p:txBody>
-      </p:sp>
-      <p:sp>
-        <p:nvSpPr>
-          <p:cNvPr id="21" name="TextBox 20"/>
-          <p:cNvSpPr txBox="1"/>
-          <p:nvPr/>
-        </p:nvSpPr>
-        <p:spPr>
-          <a:xfrm>
-            <a:off x="6583680" y="4818888"/>
-            <a:ext cx="4846320" cy="914400"/>
-          </a:xfrm>
-          <a:prstGeom prst="rect">
-            <a:avLst/>
-          </a:prstGeom>
-          <a:noFill/>
-        </p:spPr>
-        <p:txBody>
-          <a:bodyPr wrap="square" anchor="t">
-            <a:spAutoFit/>
-          </a:bodyPr>
-          <a:lstStyle/>
+              <a:t>4. Ranh giới triển khai</a:t>
+            </a:r>
+          </a:p>
           <a:p>
             <a:pPr algn="l">
               <a:spcBef>
                 <a:spcPts val="0"/>
               </a:spcBef>
               <a:spcAft>
-                <a:spcPts val="300"/>
+                <a:spcPts val="400"/>
+              </a:spcAft>
+            </a:pPr>
+            <a:r>
+              <a:rPr sz="600" b="0" i="0">
+                <a:solidFill>
+                  <a:srgbClr val="1F2937"/>
+                </a:solidFill>
+                <a:latin typeface="Calibri"/>
+              </a:rPr>
+              <a:t/>
+            </a:r>
+          </a:p>
+          <a:p>
+            <a:pPr algn="l">
+              <a:spcBef>
+                <a:spcPts val="0"/>
+              </a:spcBef>
+              <a:spcAft>
+                <a:spcPts val="400"/>
               </a:spcAft>
             </a:pPr>
             <a:r>
@@ -7855,14 +7733,14 @@
                 </a:solidFill>
                 <a:latin typeface="Calibri"/>
               </a:rPr>
-              <a:t>Container offline tự chứa; trace/review/phân tích chỉ ở dev, không bao giờ ship.</a:t>
-            </a:r>
-          </a:p>
-        </p:txBody>
-      </p:sp>
-      <p:sp>
-        <p:nvSpPr>
-          <p:cNvPr id="22" name="TextBox 21"/>
+              <a:t>Container ngoại tuyến và tự chứa; các công cụ truy vết, đánh giá, phân tích chỉ tồn tại trong môi trường phát triển.</a:t>
+            </a:r>
+          </a:p>
+        </p:txBody>
+      </p:sp>
+      <p:sp>
+        <p:nvSpPr>
+          <p:cNvPr id="18" name="TextBox 17"/>
           <p:cNvSpPr txBox="1"/>
           <p:nvPr/>
         </p:nvSpPr>
@@ -8045,7 +7923,7 @@
                 </a:solidFill>
                 <a:latin typeface="Calibri"/>
               </a:rPr>
-              <a:t>03 · KIẾN TRÚC</a:t>
+              <a:t>03 · Kiến trúc</a:t>
             </a:r>
           </a:p>
         </p:txBody>
@@ -8081,13 +7959,13 @@
               </a:spcAft>
             </a:pPr>
             <a:r>
-              <a:rPr sz="2300" b="1" i="0">
+              <a:rPr sz="2200" b="1" i="0">
                 <a:solidFill>
                   <a:srgbClr val="1F2937"/>
                 </a:solidFill>
                 <a:latin typeface="Calibri"/>
               </a:rPr>
-              <a:t>Một đường ống config‑first: thêm ngôn ngữ hay loại câu chỉ tốn MỘT dòng config.</a:t>
+              <a:t>Đường ống cấu hình hóa: bổ sung ngôn ngữ hoặc dạng câu hỏi chỉ yêu cầu thay đổi cấu hình.</a:t>
             </a:r>
           </a:p>
         </p:txBody>
@@ -8955,7 +8833,7 @@
         <p:spPr>
           <a:xfrm>
             <a:off x="6858000" y="2011680"/>
-            <a:ext cx="4754880" cy="3566160"/>
+            <a:ext cx="4754880" cy="3611880"/>
           </a:xfrm>
           <a:prstGeom prst="rect">
             <a:avLst/>
@@ -9071,7 +8949,7 @@
                 </a:solidFill>
                 <a:latin typeface="Calibri"/>
               </a:rPr>
-              <a:t>Vì sao thiết kế này thắng:</a:t>
+              <a:t>Đặc điểm thiết kế</a:t>
             </a:r>
           </a:p>
           <a:p>
@@ -9084,13 +8962,13 @@
               </a:spcAft>
             </a:pPr>
             <a:r>
-              <a:rPr sz="1250" b="0" i="0">
+              <a:rPr sz="1200" b="0" i="0">
                 <a:solidFill>
                   <a:srgbClr val="1F2937"/>
                 </a:solidFill>
                 <a:latin typeface="Calibri"/>
               </a:rPr>
-              <a:t>Một hợp đồng complete() duy nhất → Gemma/Qwen hoán đổi, không sửa solver.</a:t>
+              <a:t>Tầng giao tiếp mô hình được trừu tượng hóa qua một giao diện complete() thống nhất, cho phép thay thế Gemma hoặc Qwen mà không sửa logic suy luận.</a:t>
             </a:r>
           </a:p>
           <a:p>
@@ -9103,13 +8981,13 @@
               </a:spcAft>
             </a:pPr>
             <a:r>
-              <a:rPr sz="1250" b="0" i="0">
+              <a:rPr sz="1200" b="0" i="0">
                 <a:solidFill>
                   <a:srgbClr val="1F2937"/>
                 </a:solidFill>
                 <a:latin typeface="Calibri"/>
               </a:rPr>
-              <a:t>Policy gate + registry → không khả năng 'chỉ‑dev' nào lọt vào container thi.</a:t>
+              <a:t>Cổng kiểm soát chính sách và các registry ngăn mọi thành phần chỉ phục vụ phát triển lọt vào container thi đấu.</a:t>
             </a:r>
           </a:p>
           <a:p>
@@ -9122,13 +9000,13 @@
               </a:spcAft>
             </a:pPr>
             <a:r>
-              <a:rPr sz="1250" b="0" i="0">
+              <a:rPr sz="1200" b="0" i="0">
                 <a:solidFill>
                   <a:srgbClr val="1F2937"/>
                 </a:solidFill>
                 <a:latin typeface="Calibri"/>
               </a:rPr>
-              <a:t>Trace/review/checkpoint chỉ ở dev → image nộp luôn nhỏ gọn, tái lập.</a:t>
+              <a:t>Các thành phần truy vết và checkpoint chỉ hoạt động ở môi trường phát triển, giữ kích thước ảnh nộp tối thiểu.</a:t>
             </a:r>
           </a:p>
         </p:txBody>
@@ -9318,7 +9196,7 @@
                 </a:solidFill>
                 <a:latin typeface="Calibri"/>
               </a:rPr>
-              <a:t>04 · KẾT QUẢ</a:t>
+              <a:t>04 · Kết quả</a:t>
             </a:r>
           </a:p>
         </p:txBody>
@@ -9354,13 +9232,13 @@
               </a:spcAft>
             </a:pPr>
             <a:r>
-              <a:rPr sz="2300" b="1" i="0">
+              <a:rPr sz="2200" b="1" i="0">
                 <a:solidFill>
                   <a:srgbClr val="1F2937"/>
                 </a:solidFill>
                 <a:latin typeface="Calibri"/>
               </a:rPr>
-              <a:t>Cho mô hình lập luận đưa accuracy 77.11 → 88.55 — đo thật trên leaderboard.</a:t>
+              <a:t>Việc cho phép mô hình suy luận nâng độ chính xác từ 77.11 lên 88.55, đo trực tiếp trên leaderboard.</a:t>
             </a:r>
           </a:p>
         </p:txBody>
@@ -9760,8 +9638,8 @@
         </p:nvSpPr>
         <p:spPr>
           <a:xfrm>
-            <a:off x="9418320" y="2148840"/>
-            <a:ext cx="2560320" cy="2743200"/>
+            <a:off x="9418320" y="2194560"/>
+            <a:ext cx="2606040" cy="2743200"/>
           </a:xfrm>
           <a:prstGeom prst="rect">
             <a:avLst/>
@@ -9783,13 +9661,13 @@
               </a:spcAft>
             </a:pPr>
             <a:r>
-              <a:rPr sz="1900" b="1" i="0">
+              <a:rPr sz="1800" b="1" i="0">
                 <a:solidFill>
                   <a:srgbClr val="F97316"/>
                 </a:solidFill>
                 <a:latin typeface="Calibri"/>
               </a:rPr>
-              <a:t>+10.15pp</a:t>
+              <a:t>+10,15 điểm</a:t>
             </a:r>
           </a:p>
           <a:p>
@@ -9808,7 +9686,7 @@
                 </a:solidFill>
                 <a:latin typeface="Calibri"/>
               </a:rPr>
-              <a:t>cho mô hình lập luận (CoT)</a:t>
+              <a:t>nhờ cơ chế suy luận</a:t>
             </a:r>
           </a:p>
           <a:p>
@@ -9840,13 +9718,13 @@
               </a:spcAft>
             </a:pPr>
             <a:r>
-              <a:rPr sz="1900" b="1" i="0">
+              <a:rPr sz="1800" b="1" i="0">
                 <a:solidFill>
                   <a:srgbClr val="15803D"/>
                 </a:solidFill>
                 <a:latin typeface="Calibri"/>
               </a:rPr>
-              <a:t>+1.29pp</a:t>
+              <a:t>+1,29 điểm</a:t>
             </a:r>
           </a:p>
           <a:p>
@@ -9865,7 +9743,7 @@
                 </a:solidFill>
                 <a:latin typeface="Calibri"/>
               </a:rPr>
-              <a:t>đòn bẩy an‑toàn‑từ‑chối</a:t>
+              <a:t>nhờ an‑toàn‑từ‑chối</a:t>
             </a:r>
           </a:p>
         </p:txBody>
@@ -9907,7 +9785,7 @@
                 </a:solidFill>
                 <a:latin typeface="Calibri"/>
               </a:rPr>
-              <a:t>Mốc trần frontier (giải tay, chỉ làm tham chiếu — không ship): 91.79. Phần còn lại = kiến‑thức‑VN + defective gold.</a:t>
+              <a:t>Giới hạn tham chiếu (giải thủ công, chỉ dùng định mốc, không nộp): 91.79. Phần sai số còn lại thuộc tri thức đặc thù và một số đáp án chuẩn bị lỗi.</a:t>
             </a:r>
           </a:p>
         </p:txBody>
@@ -10097,7 +9975,7 @@
                 </a:solidFill>
                 <a:latin typeface="Calibri"/>
               </a:rPr>
-              <a:t>05 · PHƯƠNG PHÁP</a:t>
+              <a:t>05 · Phương pháp</a:t>
             </a:r>
           </a:p>
         </p:txBody>
@@ -10133,13 +10011,13 @@
               </a:spcAft>
             </a:pPr>
             <a:r>
-              <a:rPr sz="2300" b="1" i="0">
+              <a:rPr sz="2200" b="1" i="0">
                 <a:solidFill>
                   <a:srgbClr val="1F2937"/>
                 </a:solidFill>
                 <a:latin typeface="Calibri"/>
               </a:rPr>
-              <a:t>Sáu đòn bẩy — mỗi cái được giữ lại vì ĐO ĐƯỢC nó sinh lời.</a:t>
+              <a:t>Sáu kỹ thuật được áp dụng; mỗi kỹ thuật được giữ lại sau khi đo lường xác nhận hiệu quả.</a:t>
             </a:r>
           </a:p>
         </p:txBody>
@@ -10309,7 +10187,7 @@
                 </a:solidFill>
                 <a:latin typeface="Calibri"/>
               </a:rPr>
-              <a:t>+10pp. Token lập luận chính là phép tính tạo ra đáp án.</a:t>
+              <a:t>Tăng 10,15 điểm. Các token lập luận chính là quá trình tính toán dẫn tới đáp án.</a:t>
             </a:r>
           </a:p>
         </p:txBody>
@@ -10479,7 +10357,7 @@
                 </a:solidFill>
                 <a:latin typeface="Calibri"/>
               </a:rPr>
-              <a:t>Bỏ phiếu đa số + confidence = tỉ lệ đồng thuận (thật).</a:t>
+              <a:t>Lấy mẫu nhiều lần và bỏ phiếu đa số; độ tin cậy được tính từ tỉ lệ đồng thuận.</a:t>
             </a:r>
           </a:p>
         </p:txBody>
@@ -10649,7 +10527,7 @@
                 </a:solidFill>
                 <a:latin typeface="Calibri"/>
               </a:rPr>
-              <a:t>+1.29pp. Phán đoán theo nghĩa, không từ khoá → tổng quát.</a:t>
+              <a:t>Tăng 1,29 điểm. Phán đoán theo ngữ nghĩa thay vì từ khóa nên tổng quát hóa được.</a:t>
             </a:r>
           </a:p>
         </p:txBody>
@@ -10781,7 +10659,7 @@
                 </a:solidFill>
                 <a:latin typeface="Calibri"/>
               </a:rPr>
-              <a:t>TIR — chạy Python</a:t>
+              <a:t>TIR — thực thi Python</a:t>
             </a:r>
           </a:p>
           <a:p>
@@ -10819,7 +10697,7 @@
                 </a:solidFill>
                 <a:latin typeface="Calibri"/>
               </a:rPr>
-              <a:t>Lát toán ~25‑30%: sandbox offline, vote trên thiết lập bài.</a:t>
+              <a:t>Cho nhóm câu định lượng (~25–30%): chạy mã trong môi trường cô lập, bỏ phiếu trên bước thiết lập bài toán.</a:t>
             </a:r>
           </a:p>
         </p:txBody>
@@ -10989,7 +10867,7 @@
                 </a:solidFill>
                 <a:latin typeface="Calibri"/>
               </a:rPr>
-              <a:t>GBNF grammar ép chữ cái hợp lệ ở lượt sửa → 0 đoán mò.</a:t>
+              <a:t>Văn phạm GBNF ràng buộc đầu ra về một chữ cái hợp lệ ở bước hiệu chỉnh, loại bỏ phỏng đoán.</a:t>
             </a:r>
           </a:p>
         </p:txBody>
@@ -11159,7 +11037,7 @@
                 </a:solidFill>
                 <a:latin typeface="Calibri"/>
               </a:rPr>
-              <a:t>Hoán vị xoay vòng lựa chọn (29% câu là 10‑lựa‑chọn).</a:t>
+              <a:t>Hoán vị tuần hoàn thứ tự lựa chọn; 29% câu hỏi có tới mười phương án.</a:t>
             </a:r>
           </a:p>
         </p:txBody>
@@ -11349,7 +11227,7 @@
                 </a:solidFill>
                 <a:latin typeface="Calibri"/>
               </a:rPr>
-              <a:t>06 · ROBUSTNESS</a:t>
+              <a:t>06 · Tính bền vững</a:t>
             </a:r>
           </a:p>
         </p:txBody>
@@ -11385,13 +11263,13 @@
               </a:spcAft>
             </a:pPr>
             <a:r>
-              <a:rPr sz="2300" b="1" i="0">
+              <a:rPr sz="2200" b="1" i="0">
                 <a:solidFill>
                   <a:srgbClr val="1F2937"/>
                 </a:solidFill>
                 <a:latin typeface="Calibri"/>
               </a:rPr>
-              <a:t>pred.csv không bao giờ trống: một câu lỗi không thể làm mất trắng 2000 câu.</a:t>
+              <a:t>Cơ chế bảo đảm tính toàn vẹn của pred.csv: một lỗi cục bộ không làm mất toàn bộ kết quả.</a:t>
             </a:r>
           </a:p>
         </p:txBody>
@@ -11479,7 +11357,7 @@
                 </a:solidFill>
                 <a:latin typeface="Calibri"/>
               </a:rPr>
-              <a:t>✓ Mọi câu đều có đáp án</a:t>
+              <a:t>Mọi câu đều có đáp án</a:t>
             </a:r>
           </a:p>
           <a:p>
@@ -11517,7 +11395,7 @@
                 </a:solidFill>
                 <a:latin typeface="Calibri"/>
               </a:rPr>
-              <a:t>Exception khi giải được bắt từng‑câu → thay bằng fallback tất định. Một câu lỗi không thể làm sập cả lần chạy.</a:t>
+              <a:t>Ngoại lệ phát sinh khi giải được bắt ở cấp từng câu và thay bằng đáp án dự phòng tất định, nên một câu lỗi không làm dừng toàn bộ tiến trình.</a:t>
             </a:r>
           </a:p>
         </p:txBody>
@@ -11605,7 +11483,7 @@
                 </a:solidFill>
                 <a:latin typeface="Calibri"/>
               </a:rPr>
-              <a:t>✓ Ghi pred.csv TRƯỚC mọi thứ có thể lỗi</a:t>
+              <a:t>Ghi kết quả trước khâu kiểm tra</a:t>
             </a:r>
           </a:p>
           <a:p>
@@ -11643,7 +11521,7 @@
                 </a:solidFill>
                 <a:latin typeface="Calibri"/>
               </a:rPr>
-              <a:t>contract‑repair phủ đúng mọi qid với chữ cái hợp lệ (giữ nguyên dự đoán tốt); ghi trước, validate chỉ cảnh báo.</a:t>
+              <a:t>Bước hiệu chỉnh hợp đồng bảo đảm pred.csv phủ đúng toàn bộ qid với chữ cái hợp lệ; tệp được ghi trước, khâu kiểm tra chỉ phát cảnh báo.</a:t>
             </a:r>
           </a:p>
         </p:txBody>
@@ -11656,7 +11534,7 @@
         </p:nvSpPr>
         <p:spPr>
           <a:xfrm>
-            <a:off x="640080" y="4160520"/>
+            <a:off x="640080" y="4114800"/>
             <a:ext cx="10972800" cy="365760"/>
           </a:xfrm>
           <a:prstGeom prst="rect">
@@ -11685,7 +11563,7 @@
                 </a:solidFill>
                 <a:latin typeface="Calibri"/>
               </a:rPr>
-              <a:t>Tự động tiếp tục khi gặp sự cố — ba lớp:</a:t>
+              <a:t>Khả năng tự khôi phục khi gặp sự cố gồm ba lớp:</a:t>
             </a:r>
           </a:p>
         </p:txBody>
@@ -11698,8 +11576,8 @@
         </p:nvSpPr>
         <p:spPr>
           <a:xfrm>
-            <a:off x="822960" y="4572000"/>
-            <a:ext cx="10972800" cy="1280160"/>
+            <a:off x="822960" y="4526280"/>
+            <a:ext cx="10972800" cy="1371600"/>
           </a:xfrm>
           <a:prstGeom prst="rect">
             <a:avLst/>
@@ -11727,7 +11605,7 @@
                 </a:solidFill>
                 <a:latin typeface="Calibri"/>
               </a:rPr>
-              <a:t>①  Retry từng câu</a:t>
+              <a:t>1.  Thử lại từng câu</a:t>
             </a:r>
             <a:r>
               <a:rPr sz="1250" b="0" i="0">
@@ -11736,7 +11614,7 @@
                 </a:solidFill>
                 <a:latin typeface="Calibri"/>
               </a:rPr>
-              <a:t>  — lỗi tạm thời (timeout/connection) thử lại với backoff lũy thừa.</a:t>
+              <a:t>: các lỗi tạm thời (hết thời gian, mất kết nối) được thử lại với khoảng chờ tăng dần.</a:t>
             </a:r>
           </a:p>
           <a:p>
@@ -11755,7 +11633,7 @@
                 </a:solidFill>
                 <a:latin typeface="Calibri"/>
               </a:rPr>
-              <a:t>②  Fallback từng câu</a:t>
+              <a:t>2.  Dự phòng từng câu</a:t>
             </a:r>
             <a:r>
               <a:rPr sz="1250" b="0" i="0">
@@ -11764,7 +11642,7 @@
                 </a:solidFill>
                 <a:latin typeface="Calibri"/>
               </a:rPr>
-              <a:t>  — lỗi bất kỳ → đáp án heuristic tất định, không crash.</a:t>
+              <a:t>: mọi lỗi khác được thay bằng đáp án heuristic tất định, không gây dừng tiến trình.</a:t>
             </a:r>
           </a:p>
           <a:p>
@@ -11783,7 +11661,7 @@
                 </a:solidFill>
                 <a:latin typeface="Calibri"/>
               </a:rPr>
-              <a:t>③  Checkpoint + auto‑resume</a:t>
+              <a:t>3.  Checkpoint và khôi phục</a:t>
             </a:r>
             <a:r>
               <a:rPr sz="1250" b="0" i="0">
@@ -11792,7 +11670,7 @@
                 </a:solidFill>
                 <a:latin typeface="Calibri"/>
               </a:rPr>
-              <a:t>  — container restart → tiếp tục từ câu cuối, không tính lại (cứu cả Time).</a:t>
+              <a:t>: khi container khởi động lại, tiến trình tiếp tục từ câu cuối cùng, không tính toán lại.</a:t>
             </a:r>
           </a:p>
         </p:txBody>
@@ -11805,7 +11683,7 @@
         </p:nvSpPr>
         <p:spPr>
           <a:xfrm>
-            <a:off x="640080" y="5989320"/>
+            <a:off x="640080" y="6035040"/>
             <a:ext cx="10972800" cy="365760"/>
           </a:xfrm>
           <a:prstGeom prst="rect">
@@ -11834,7 +11712,7 @@
                 </a:solidFill>
                 <a:latin typeface="Calibri"/>
               </a:rPr>
-              <a:t>Đã smoke đúng entrypoint Docker trên GPU thật: pred.csv hợp lệ, contract 40/40 · 211 test đơn vị xanh.</a:t>
+              <a:t>Đã kiểm thử đúng entrypoint Docker trên GPU thực tế (pred.csv hợp lệ, hợp đồng 40/40); 211 ca kiểm thử đơn vị đạt.</a:t>
             </a:r>
           </a:p>
         </p:txBody>
@@ -12024,7 +11902,7 @@
                 </a:solidFill>
                 <a:latin typeface="Calibri"/>
               </a:rPr>
-              <a:t>07 · KỶ LUẬT</a:t>
+              <a:t>07 · Chống quá khớp</a:t>
             </a:r>
           </a:p>
         </p:txBody>
@@ -12060,13 +11938,13 @@
               </a:spcAft>
             </a:pPr>
             <a:r>
-              <a:rPr sz="2300" b="1" i="0">
+              <a:rPr sz="2200" b="1" i="0">
                 <a:solidFill>
                   <a:srgbClr val="1F2937"/>
                 </a:solidFill>
                 <a:latin typeface="Calibri"/>
               </a:rPr>
-              <a:t>Chúng tôi LOẠI nhiều đòn bẩy hơn là giữ — mỗi cái bị một phép ĐO giết.</a:t>
+              <a:t>Phần lớn kỹ thuật khảo sát bị loại bỏ dựa trên kết quả đo lường thực nghiệm.</a:t>
             </a:r>
           </a:p>
         </p:txBody>
@@ -12090,9 +11968,9 @@
                 <a:tableStyleId>{5C22544A-7EE6-4342-B048-85BDC9FD1C3A}</a:tableStyleId>
               </a:tblPr>
               <a:tblGrid>
-                <a:gridCol w="2834640"/>
-                <a:gridCol w="1783080"/>
-                <a:gridCol w="6355080"/>
+                <a:gridCol w="3108960"/>
+                <a:gridCol w="1828800"/>
+                <a:gridCol w="6035040"/>
               </a:tblGrid>
               <a:tr h="685800">
                 <a:tc>
@@ -12107,7 +11985,7 @@
                           </a:solidFill>
                           <a:latin typeface="Calibri"/>
                         </a:rPr>
-                        <a:t>Đòn bẩy đã thử</a:t>
+                        <a:t>Kỹ thuật đã khảo sát</a:t>
                       </a:r>
                     </a:p>
                   </a:txBody>
@@ -12151,7 +12029,7 @@
                           </a:solidFill>
                           <a:latin typeface="Calibri"/>
                         </a:rPr>
-                        <a:t>Vì sao loại</a:t>
+                        <a:t>Lý do loại bỏ</a:t>
                       </a:r>
                     </a:p>
                   </a:txBody>
@@ -12175,7 +12053,7 @@
                           </a:solidFill>
                           <a:latin typeface="Calibri"/>
                         </a:rPr>
-                        <a:t>RAG luật/hành chính</a:t>
+                        <a:t>RAG luật / hành chính</a:t>
                       </a:r>
                     </a:p>
                   </a:txBody>
@@ -12197,7 +12075,7 @@
                           </a:solidFill>
                           <a:latin typeface="Calibri"/>
                         </a:rPr>
-                        <a:t>ÂM</a:t>
+                        <a:t>âm</a:t>
                       </a:r>
                     </a:p>
                   </a:txBody>
@@ -12219,7 +12097,7 @@
                           </a:solidFill>
                           <a:latin typeface="Calibri"/>
                         </a:rPr>
-                        <a:t>civics −5pp, quant −7.5pp; trắc nghiệm đóng không có corpus để truy xuất.</a:t>
+                        <a:t>civics −5 điểm, định lượng −7,5 điểm; trắc nghiệm đóng không có ngữ liệu để truy hồi.</a:t>
                       </a:r>
                     </a:p>
                   </a:txBody>
@@ -12243,7 +12121,7 @@
                           </a:solidFill>
                           <a:latin typeface="Calibri"/>
                         </a:rPr>
-                        <a:t>maj@k voting (k=5)</a:t>
+                        <a:t>Bỏ phiếu đa dạng (k=5)</a:t>
                       </a:r>
                     </a:p>
                   </a:txBody>
@@ -12265,7 +12143,7 @@
                           </a:solidFill>
                           <a:latin typeface="Calibri"/>
                         </a:rPr>
-                        <a:t>HOÀ</a:t>
+                        <a:t>không đổi</a:t>
                       </a:r>
                     </a:p>
                   </a:txBody>
@@ -12287,7 +12165,7 @@
                           </a:solidFill>
                           <a:latin typeface="Calibri"/>
                         </a:rPr>
-                        <a:t>Lỗi Gemma hệ thống → các mẫu đa dạng cùng đồng thuận cái SAI.</a:t>
+                        <a:t>Sai số của mô hình mang tính hệ thống; các mẫu cùng đồng thuận một đáp án sai.</a:t>
                       </a:r>
                     </a:p>
                   </a:txBody>
@@ -12311,7 +12189,7 @@
                           </a:solidFill>
                           <a:latin typeface="Calibri"/>
                         </a:rPr>
-                        <a:t>Quant cao hơn (Q6/Q8)</a:t>
+                        <a:t>Lượng tử hóa cao hơn (Q6/Q8)</a:t>
                       </a:r>
                     </a:p>
                   </a:txBody>
@@ -12333,7 +12211,7 @@
                           </a:solidFill>
                           <a:latin typeface="Calibri"/>
                         </a:rPr>
-                        <a:t>HOÀ/kém</a:t>
+                        <a:t>không đổi / kém</a:t>
                       </a:r>
                     </a:p>
                   </a:txBody>
@@ -12355,7 +12233,7 @@
                           </a:solidFill>
                           <a:latin typeface="Calibri"/>
                         </a:rPr>
-                        <a:t>Q4 là QAT (tối ưu sẵn 4‑bit); Q6/Q8 không hơn, 2× thời gian + VRAM.</a:t>
+                        <a:t>Q4 là QAT (tối ưu sẵn cho 4‑bit); Q6/Q8 không cải thiện mà tốn gấp đôi thời gian và bộ nhớ.</a:t>
                       </a:r>
                     </a:p>
                   </a:txBody>
@@ -12401,7 +12279,7 @@
                           </a:solidFill>
                           <a:latin typeface="Calibri"/>
                         </a:rPr>
-                        <a:t>LOẠI: Time</a:t>
+                        <a:t>loại: thời gian</a:t>
                       </a:r>
                     </a:p>
                   </a:txBody>
@@ -12423,7 +12301,7 @@
                           </a:solidFill>
                           <a:latin typeface="Calibri"/>
                         </a:rPr>
-                        <a:t>~90s/câu → ~50h cho 2000 câu, mất trắng 10đ Time; chỉ hơn ~0.7pp.</a:t>
+                        <a:t>≈90 giây/câu, tương đương ~50 giờ cho 2000 câu; chỉ cao hơn ~0,7 điểm.</a:t>
                       </a:r>
                     </a:p>
                   </a:txBody>
@@ -12447,7 +12325,7 @@
                           </a:solidFill>
                           <a:latin typeface="Calibri"/>
                         </a:rPr>
-                        <a:t>Qwen3.5‑9B adjudicator</a:t>
+                        <a:t>Mô hình thẩm định Qwen3.5‑9B</a:t>
                       </a:r>
                     </a:p>
                   </a:txBody>
@@ -12469,7 +12347,7 @@
                           </a:solidFill>
                           <a:latin typeface="Calibri"/>
                         </a:rPr>
-                        <a:t>không nhận</a:t>
+                        <a:t>chưa chấp nhận</a:t>
                       </a:r>
                     </a:p>
                   </a:txBody>
@@ -12491,7 +12369,7 @@
                           </a:solidFill>
                           <a:latin typeface="Calibri"/>
                         </a:rPr>
-                        <a:t>Standalone kém hơn; vote chéo là tung đồng xu + rủi ro lật câu đang đúng.</a:t>
+                        <a:t>Bản độc lập kém hơn; thẩm định chéo không ổn định và có nguy cơ đảo đáp án đang đúng.</a:t>
                       </a:r>
                     </a:p>
                   </a:txBody>
@@ -12537,13 +12415,13 @@
               </a:spcAft>
             </a:pPr>
             <a:r>
-              <a:rPr sz="1250" b="1" i="1">
+              <a:rPr sz="1200" b="0" i="1">
                 <a:solidFill>
                   <a:srgbClr val="C2550B"/>
                 </a:solidFill>
                 <a:latin typeface="Calibri"/>
               </a:rPr>
-              <a:t>Kết quả âm cũng giá trị như kết quả dương — chúng ngăn ta ship tính năng có hại cho 2000 câu private.</a:t>
+              <a:t>Kết quả phủ định có giá trị ngang kết quả khẳng định: chúng ngăn việc triển khai các kỹ thuật bất lợi cho tập kiểm thử riêng.</a:t>
             </a:r>
           </a:p>
         </p:txBody>

</xml_diff>

<commit_message>
chore: sync working tree for GitHub push (guardrails + research notes + docs)
Captures the current green working tree (226 tests):
- Guardrails (Codex): run.py --allow-development-workflow gate keeps dev-only
  workflows/strategies out of the contest path; submission.py strict CSV
  validation (UTF-8 no-BOM, bare qid,answer rows) hardens the pred.csv contract.
- Research notes: contest-rules, public463 error audit, MTP resume, adjudicated
  candidate record (dev-only, NOT promoted), r3-r7 plans, webmax probes.
- Dev docs: CLAUDE.md + docs/claude-code/ operating guides.
- Submission method deck + minor script/config tweaks.

No answer files / model weights / outputs / secrets staged (gitignore verified).

Co-Authored-By: Claude Opus 4.8 (1M context) <noreply@anthropic.com>
</commit_message>
<xml_diff>
--- a/docs/Neko-Core-Thuyet-minh-phuong-phap.pptx
+++ b/docs/Neko-Core-Thuyet-minh-phuong-phap.pptx
@@ -5,21 +5,21 @@
     <p:sldMasterId id="2147483648" r:id="rId1"/>
   </p:sldMasterIdLst>
   <p:sldIdLst>
-    <p:sldId id="256" r:id="rId7"/>
-    <p:sldId id="257" r:id="rId8"/>
-    <p:sldId id="258" r:id="rId9"/>
-    <p:sldId id="259" r:id="rId10"/>
-    <p:sldId id="260" r:id="rId11"/>
-    <p:sldId id="261" r:id="rId12"/>
-    <p:sldId id="262" r:id="rId13"/>
-    <p:sldId id="263" r:id="rId14"/>
-    <p:sldId id="264" r:id="rId15"/>
-    <p:sldId id="265" r:id="rId16"/>
-    <p:sldId id="266" r:id="rId17"/>
-    <p:sldId id="267" r:id="rId18"/>
-    <p:sldId id="268" r:id="rId19"/>
+    <p:sldId id="256" r:id="rId2"/>
+    <p:sldId id="257" r:id="rId3"/>
+    <p:sldId id="258" r:id="rId4"/>
+    <p:sldId id="259" r:id="rId5"/>
+    <p:sldId id="260" r:id="rId6"/>
+    <p:sldId id="261" r:id="rId7"/>
+    <p:sldId id="262" r:id="rId8"/>
+    <p:sldId id="263" r:id="rId9"/>
+    <p:sldId id="264" r:id="rId10"/>
+    <p:sldId id="265" r:id="rId11"/>
+    <p:sldId id="266" r:id="rId12"/>
+    <p:sldId id="267" r:id="rId13"/>
+    <p:sldId id="268" r:id="rId14"/>
   </p:sldIdLst>
-  <p:sldSz cx="12191695" cy="6858000" type="screen4x3"/>
+  <p:sldSz cx="12192000" cy="6858000"/>
   <p:notesSz cx="6858000" cy="9144000"/>
   <p:defaultTextStyle>
     <a:defPPr>
@@ -116,6 +116,22 @@
       </a:defRPr>
     </a:lvl9pPr>
   </p:defaultTextStyle>
+  <p:extLst>
+    <p:ext uri="{EFAFB233-063F-42B5-8137-9DF3F51BA10A}">
+      <p15:sldGuideLst xmlns:p15="http://schemas.microsoft.com/office/powerpoint/2012/main">
+        <p15:guide id="1" orient="horz" pos="2160">
+          <p15:clr>
+            <a:srgbClr val="A4A3A4"/>
+          </p15:clr>
+        </p15:guide>
+        <p15:guide id="2" pos="2880">
+          <p15:clr>
+            <a:srgbClr val="A4A3A4"/>
+          </p15:clr>
+        </p15:guide>
+      </p15:sldGuideLst>
+    </p:ext>
+  </p:extLst>
 </p:presentation>
 </file>
 
@@ -157,10 +173,9 @@
           <a:lstStyle/>
           <a:p>
             <a:r>
-              <a:rPr lang="en-US" smtClean="0"/>
+              <a:rPr lang="en-US"/>
               <a:t>Click to edit Master title style</a:t>
             </a:r>
-            <a:endParaRPr lang="en-US"/>
           </a:p>
         </p:txBody>
       </p:sp>
@@ -276,10 +291,9 @@
           </a:lstStyle>
           <a:p>
             <a:r>
-              <a:rPr lang="en-US" smtClean="0"/>
+              <a:rPr lang="en-US"/>
               <a:t>Click to edit Master subtitle style</a:t>
             </a:r>
-            <a:endParaRPr lang="en-US"/>
           </a:p>
         </p:txBody>
       </p:sp>
@@ -300,7 +314,7 @@
           <a:p>
             <a:fld id="{5BCAD085-E8A6-8845-BD4E-CB4CCA059FC4}" type="datetimeFigureOut">
               <a:rPr lang="en-US" smtClean="0"/>
-              <a:t>1/27/13</a:t>
+              <a:t>6/13/2026</a:t>
             </a:fld>
             <a:endParaRPr lang="en-US"/>
           </a:p>
@@ -394,10 +408,9 @@
           <a:lstStyle/>
           <a:p>
             <a:r>
-              <a:rPr lang="en-US" smtClean="0"/>
+              <a:rPr lang="en-US"/>
               <a:t>Click to edit Master title style</a:t>
             </a:r>
-            <a:endParaRPr lang="en-US"/>
           </a:p>
         </p:txBody>
       </p:sp>
@@ -418,38 +431,37 @@
           <a:p>
             <a:pPr lvl="0"/>
             <a:r>
-              <a:rPr lang="en-US" smtClean="0"/>
+              <a:rPr lang="en-US"/>
               <a:t>Click to edit Master text styles</a:t>
             </a:r>
           </a:p>
           <a:p>
             <a:pPr lvl="1"/>
             <a:r>
-              <a:rPr lang="en-US" smtClean="0"/>
+              <a:rPr lang="en-US"/>
               <a:t>Second level</a:t>
             </a:r>
           </a:p>
           <a:p>
             <a:pPr lvl="2"/>
             <a:r>
-              <a:rPr lang="en-US" smtClean="0"/>
+              <a:rPr lang="en-US"/>
               <a:t>Third level</a:t>
             </a:r>
           </a:p>
           <a:p>
             <a:pPr lvl="3"/>
             <a:r>
-              <a:rPr lang="en-US" smtClean="0"/>
+              <a:rPr lang="en-US"/>
               <a:t>Fourth level</a:t>
             </a:r>
           </a:p>
           <a:p>
             <a:pPr lvl="4"/>
             <a:r>
-              <a:rPr lang="en-US" smtClean="0"/>
+              <a:rPr lang="en-US"/>
               <a:t>Fifth level</a:t>
             </a:r>
-            <a:endParaRPr lang="en-US"/>
           </a:p>
         </p:txBody>
       </p:sp>
@@ -470,7 +482,7 @@
           <a:p>
             <a:fld id="{5BCAD085-E8A6-8845-BD4E-CB4CCA059FC4}" type="datetimeFigureOut">
               <a:rPr lang="en-US" smtClean="0"/>
-              <a:t>1/27/13</a:t>
+              <a:t>6/13/2026</a:t>
             </a:fld>
             <a:endParaRPr lang="en-US"/>
           </a:p>
@@ -569,10 +581,9 @@
           <a:lstStyle/>
           <a:p>
             <a:r>
-              <a:rPr lang="en-US" smtClean="0"/>
+              <a:rPr lang="en-US"/>
               <a:t>Click to edit Master title style</a:t>
             </a:r>
-            <a:endParaRPr lang="en-US"/>
           </a:p>
         </p:txBody>
       </p:sp>
@@ -598,38 +609,37 @@
           <a:p>
             <a:pPr lvl="0"/>
             <a:r>
-              <a:rPr lang="en-US" smtClean="0"/>
+              <a:rPr lang="en-US"/>
               <a:t>Click to edit Master text styles</a:t>
             </a:r>
           </a:p>
           <a:p>
             <a:pPr lvl="1"/>
             <a:r>
-              <a:rPr lang="en-US" smtClean="0"/>
+              <a:rPr lang="en-US"/>
               <a:t>Second level</a:t>
             </a:r>
           </a:p>
           <a:p>
             <a:pPr lvl="2"/>
             <a:r>
-              <a:rPr lang="en-US" smtClean="0"/>
+              <a:rPr lang="en-US"/>
               <a:t>Third level</a:t>
             </a:r>
           </a:p>
           <a:p>
             <a:pPr lvl="3"/>
             <a:r>
-              <a:rPr lang="en-US" smtClean="0"/>
+              <a:rPr lang="en-US"/>
               <a:t>Fourth level</a:t>
             </a:r>
           </a:p>
           <a:p>
             <a:pPr lvl="4"/>
             <a:r>
-              <a:rPr lang="en-US" smtClean="0"/>
+              <a:rPr lang="en-US"/>
               <a:t>Fifth level</a:t>
             </a:r>
-            <a:endParaRPr lang="en-US"/>
           </a:p>
         </p:txBody>
       </p:sp>
@@ -650,7 +660,7 @@
           <a:p>
             <a:fld id="{5BCAD085-E8A6-8845-BD4E-CB4CCA059FC4}" type="datetimeFigureOut">
               <a:rPr lang="en-US" smtClean="0"/>
-              <a:t>1/27/13</a:t>
+              <a:t>6/13/2026</a:t>
             </a:fld>
             <a:endParaRPr lang="en-US"/>
           </a:p>
@@ -744,10 +754,9 @@
           <a:lstStyle/>
           <a:p>
             <a:r>
-              <a:rPr lang="en-US" smtClean="0"/>
+              <a:rPr lang="en-US"/>
               <a:t>Click to edit Master title style</a:t>
             </a:r>
-            <a:endParaRPr lang="en-US"/>
           </a:p>
         </p:txBody>
       </p:sp>
@@ -768,38 +777,37 @@
           <a:p>
             <a:pPr lvl="0"/>
             <a:r>
-              <a:rPr lang="en-US" smtClean="0"/>
+              <a:rPr lang="en-US"/>
               <a:t>Click to edit Master text styles</a:t>
             </a:r>
           </a:p>
           <a:p>
             <a:pPr lvl="1"/>
             <a:r>
-              <a:rPr lang="en-US" smtClean="0"/>
+              <a:rPr lang="en-US"/>
               <a:t>Second level</a:t>
             </a:r>
           </a:p>
           <a:p>
             <a:pPr lvl="2"/>
             <a:r>
-              <a:rPr lang="en-US" smtClean="0"/>
+              <a:rPr lang="en-US"/>
               <a:t>Third level</a:t>
             </a:r>
           </a:p>
           <a:p>
             <a:pPr lvl="3"/>
             <a:r>
-              <a:rPr lang="en-US" smtClean="0"/>
+              <a:rPr lang="en-US"/>
               <a:t>Fourth level</a:t>
             </a:r>
           </a:p>
           <a:p>
             <a:pPr lvl="4"/>
             <a:r>
-              <a:rPr lang="en-US" smtClean="0"/>
+              <a:rPr lang="en-US"/>
               <a:t>Fifth level</a:t>
             </a:r>
-            <a:endParaRPr lang="en-US"/>
           </a:p>
         </p:txBody>
       </p:sp>
@@ -820,7 +828,7 @@
           <a:p>
             <a:fld id="{5BCAD085-E8A6-8845-BD4E-CB4CCA059FC4}" type="datetimeFigureOut">
               <a:rPr lang="en-US" smtClean="0"/>
-              <a:t>1/27/13</a:t>
+              <a:t>6/13/2026</a:t>
             </a:fld>
             <a:endParaRPr lang="en-US"/>
           </a:p>
@@ -923,10 +931,9 @@
           </a:lstStyle>
           <a:p>
             <a:r>
-              <a:rPr lang="en-US" smtClean="0"/>
+              <a:rPr lang="en-US"/>
               <a:t>Click to edit Master title style</a:t>
             </a:r>
-            <a:endParaRPr lang="en-US"/>
           </a:p>
         </p:txBody>
       </p:sp>
@@ -1043,7 +1050,7 @@
           <a:p>
             <a:pPr lvl="0"/>
             <a:r>
-              <a:rPr lang="en-US" smtClean="0"/>
+              <a:rPr lang="en-US"/>
               <a:t>Click to edit Master text styles</a:t>
             </a:r>
           </a:p>
@@ -1066,7 +1073,7 @@
           <a:p>
             <a:fld id="{5BCAD085-E8A6-8845-BD4E-CB4CCA059FC4}" type="datetimeFigureOut">
               <a:rPr lang="en-US" smtClean="0"/>
-              <a:t>1/27/13</a:t>
+              <a:t>6/13/2026</a:t>
             </a:fld>
             <a:endParaRPr lang="en-US"/>
           </a:p>
@@ -1160,10 +1167,9 @@
           <a:lstStyle/>
           <a:p>
             <a:r>
-              <a:rPr lang="en-US" smtClean="0"/>
+              <a:rPr lang="en-US"/>
               <a:t>Click to edit Master title style</a:t>
             </a:r>
-            <a:endParaRPr lang="en-US"/>
           </a:p>
         </p:txBody>
       </p:sp>
@@ -1217,38 +1223,37 @@
           <a:p>
             <a:pPr lvl="0"/>
             <a:r>
-              <a:rPr lang="en-US" smtClean="0"/>
+              <a:rPr lang="en-US"/>
               <a:t>Click to edit Master text styles</a:t>
             </a:r>
           </a:p>
           <a:p>
             <a:pPr lvl="1"/>
             <a:r>
-              <a:rPr lang="en-US" smtClean="0"/>
+              <a:rPr lang="en-US"/>
               <a:t>Second level</a:t>
             </a:r>
           </a:p>
           <a:p>
             <a:pPr lvl="2"/>
             <a:r>
-              <a:rPr lang="en-US" smtClean="0"/>
+              <a:rPr lang="en-US"/>
               <a:t>Third level</a:t>
             </a:r>
           </a:p>
           <a:p>
             <a:pPr lvl="3"/>
             <a:r>
-              <a:rPr lang="en-US" smtClean="0"/>
+              <a:rPr lang="en-US"/>
               <a:t>Fourth level</a:t>
             </a:r>
           </a:p>
           <a:p>
             <a:pPr lvl="4"/>
             <a:r>
-              <a:rPr lang="en-US" smtClean="0"/>
+              <a:rPr lang="en-US"/>
               <a:t>Fifth level</a:t>
             </a:r>
-            <a:endParaRPr lang="en-US"/>
           </a:p>
         </p:txBody>
       </p:sp>
@@ -1302,38 +1307,37 @@
           <a:p>
             <a:pPr lvl="0"/>
             <a:r>
-              <a:rPr lang="en-US" smtClean="0"/>
+              <a:rPr lang="en-US"/>
               <a:t>Click to edit Master text styles</a:t>
             </a:r>
           </a:p>
           <a:p>
             <a:pPr lvl="1"/>
             <a:r>
-              <a:rPr lang="en-US" smtClean="0"/>
+              <a:rPr lang="en-US"/>
               <a:t>Second level</a:t>
             </a:r>
           </a:p>
           <a:p>
             <a:pPr lvl="2"/>
             <a:r>
-              <a:rPr lang="en-US" smtClean="0"/>
+              <a:rPr lang="en-US"/>
               <a:t>Third level</a:t>
             </a:r>
           </a:p>
           <a:p>
             <a:pPr lvl="3"/>
             <a:r>
-              <a:rPr lang="en-US" smtClean="0"/>
+              <a:rPr lang="en-US"/>
               <a:t>Fourth level</a:t>
             </a:r>
           </a:p>
           <a:p>
             <a:pPr lvl="4"/>
             <a:r>
-              <a:rPr lang="en-US" smtClean="0"/>
+              <a:rPr lang="en-US"/>
               <a:t>Fifth level</a:t>
             </a:r>
-            <a:endParaRPr lang="en-US"/>
           </a:p>
         </p:txBody>
       </p:sp>
@@ -1354,7 +1358,7 @@
           <a:p>
             <a:fld id="{5BCAD085-E8A6-8845-BD4E-CB4CCA059FC4}" type="datetimeFigureOut">
               <a:rPr lang="en-US" smtClean="0"/>
-              <a:t>1/27/13</a:t>
+              <a:t>6/13/2026</a:t>
             </a:fld>
             <a:endParaRPr lang="en-US"/>
           </a:p>
@@ -1452,10 +1456,9 @@
           </a:lstStyle>
           <a:p>
             <a:r>
-              <a:rPr lang="en-US" smtClean="0"/>
+              <a:rPr lang="en-US"/>
               <a:t>Click to edit Master title style</a:t>
             </a:r>
-            <a:endParaRPr lang="en-US"/>
           </a:p>
         </p:txBody>
       </p:sp>
@@ -1518,7 +1521,7 @@
           <a:p>
             <a:pPr lvl="0"/>
             <a:r>
-              <a:rPr lang="en-US" smtClean="0"/>
+              <a:rPr lang="en-US"/>
               <a:t>Click to edit Master text styles</a:t>
             </a:r>
           </a:p>
@@ -1574,38 +1577,37 @@
           <a:p>
             <a:pPr lvl="0"/>
             <a:r>
-              <a:rPr lang="en-US" smtClean="0"/>
+              <a:rPr lang="en-US"/>
               <a:t>Click to edit Master text styles</a:t>
             </a:r>
           </a:p>
           <a:p>
             <a:pPr lvl="1"/>
             <a:r>
-              <a:rPr lang="en-US" smtClean="0"/>
+              <a:rPr lang="en-US"/>
               <a:t>Second level</a:t>
             </a:r>
           </a:p>
           <a:p>
             <a:pPr lvl="2"/>
             <a:r>
-              <a:rPr lang="en-US" smtClean="0"/>
+              <a:rPr lang="en-US"/>
               <a:t>Third level</a:t>
             </a:r>
           </a:p>
           <a:p>
             <a:pPr lvl="3"/>
             <a:r>
-              <a:rPr lang="en-US" smtClean="0"/>
+              <a:rPr lang="en-US"/>
               <a:t>Fourth level</a:t>
             </a:r>
           </a:p>
           <a:p>
             <a:pPr lvl="4"/>
             <a:r>
-              <a:rPr lang="en-US" smtClean="0"/>
+              <a:rPr lang="en-US"/>
               <a:t>Fifth level</a:t>
             </a:r>
-            <a:endParaRPr lang="en-US"/>
           </a:p>
         </p:txBody>
       </p:sp>
@@ -1668,7 +1670,7 @@
           <a:p>
             <a:pPr lvl="0"/>
             <a:r>
-              <a:rPr lang="en-US" smtClean="0"/>
+              <a:rPr lang="en-US"/>
               <a:t>Click to edit Master text styles</a:t>
             </a:r>
           </a:p>
@@ -1724,38 +1726,37 @@
           <a:p>
             <a:pPr lvl="0"/>
             <a:r>
-              <a:rPr lang="en-US" smtClean="0"/>
+              <a:rPr lang="en-US"/>
               <a:t>Click to edit Master text styles</a:t>
             </a:r>
           </a:p>
           <a:p>
             <a:pPr lvl="1"/>
             <a:r>
-              <a:rPr lang="en-US" smtClean="0"/>
+              <a:rPr lang="en-US"/>
               <a:t>Second level</a:t>
             </a:r>
           </a:p>
           <a:p>
             <a:pPr lvl="2"/>
             <a:r>
-              <a:rPr lang="en-US" smtClean="0"/>
+              <a:rPr lang="en-US"/>
               <a:t>Third level</a:t>
             </a:r>
           </a:p>
           <a:p>
             <a:pPr lvl="3"/>
             <a:r>
-              <a:rPr lang="en-US" smtClean="0"/>
+              <a:rPr lang="en-US"/>
               <a:t>Fourth level</a:t>
             </a:r>
           </a:p>
           <a:p>
             <a:pPr lvl="4"/>
             <a:r>
-              <a:rPr lang="en-US" smtClean="0"/>
+              <a:rPr lang="en-US"/>
               <a:t>Fifth level</a:t>
             </a:r>
-            <a:endParaRPr lang="en-US"/>
           </a:p>
         </p:txBody>
       </p:sp>
@@ -1776,7 +1777,7 @@
           <a:p>
             <a:fld id="{5BCAD085-E8A6-8845-BD4E-CB4CCA059FC4}" type="datetimeFigureOut">
               <a:rPr lang="en-US" smtClean="0"/>
-              <a:t>1/27/13</a:t>
+              <a:t>6/13/2026</a:t>
             </a:fld>
             <a:endParaRPr lang="en-US"/>
           </a:p>
@@ -1870,10 +1871,9 @@
           <a:lstStyle/>
           <a:p>
             <a:r>
-              <a:rPr lang="en-US" smtClean="0"/>
+              <a:rPr lang="en-US"/>
               <a:t>Click to edit Master title style</a:t>
             </a:r>
-            <a:endParaRPr lang="en-US"/>
           </a:p>
         </p:txBody>
       </p:sp>
@@ -1894,7 +1894,7 @@
           <a:p>
             <a:fld id="{5BCAD085-E8A6-8845-BD4E-CB4CCA059FC4}" type="datetimeFigureOut">
               <a:rPr lang="en-US" smtClean="0"/>
-              <a:t>1/27/13</a:t>
+              <a:t>6/13/2026</a:t>
             </a:fld>
             <a:endParaRPr lang="en-US"/>
           </a:p>
@@ -1989,7 +1989,7 @@
           <a:p>
             <a:fld id="{5BCAD085-E8A6-8845-BD4E-CB4CCA059FC4}" type="datetimeFigureOut">
               <a:rPr lang="en-US" smtClean="0"/>
-              <a:t>1/27/13</a:t>
+              <a:t>6/13/2026</a:t>
             </a:fld>
             <a:endParaRPr lang="en-US"/>
           </a:p>
@@ -2092,10 +2092,9 @@
           </a:lstStyle>
           <a:p>
             <a:r>
-              <a:rPr lang="en-US" smtClean="0"/>
+              <a:rPr lang="en-US"/>
               <a:t>Click to edit Master title style</a:t>
             </a:r>
-            <a:endParaRPr lang="en-US"/>
           </a:p>
         </p:txBody>
       </p:sp>
@@ -2149,38 +2148,37 @@
           <a:p>
             <a:pPr lvl="0"/>
             <a:r>
-              <a:rPr lang="en-US" smtClean="0"/>
+              <a:rPr lang="en-US"/>
               <a:t>Click to edit Master text styles</a:t>
             </a:r>
           </a:p>
           <a:p>
             <a:pPr lvl="1"/>
             <a:r>
-              <a:rPr lang="en-US" smtClean="0"/>
+              <a:rPr lang="en-US"/>
               <a:t>Second level</a:t>
             </a:r>
           </a:p>
           <a:p>
             <a:pPr lvl="2"/>
             <a:r>
-              <a:rPr lang="en-US" smtClean="0"/>
+              <a:rPr lang="en-US"/>
               <a:t>Third level</a:t>
             </a:r>
           </a:p>
           <a:p>
             <a:pPr lvl="3"/>
             <a:r>
-              <a:rPr lang="en-US" smtClean="0"/>
+              <a:rPr lang="en-US"/>
               <a:t>Fourth level</a:t>
             </a:r>
           </a:p>
           <a:p>
             <a:pPr lvl="4"/>
             <a:r>
-              <a:rPr lang="en-US" smtClean="0"/>
+              <a:rPr lang="en-US"/>
               <a:t>Fifth level</a:t>
             </a:r>
-            <a:endParaRPr lang="en-US"/>
           </a:p>
         </p:txBody>
       </p:sp>
@@ -2243,7 +2241,7 @@
           <a:p>
             <a:pPr lvl="0"/>
             <a:r>
-              <a:rPr lang="en-US" smtClean="0"/>
+              <a:rPr lang="en-US"/>
               <a:t>Click to edit Master text styles</a:t>
             </a:r>
           </a:p>
@@ -2266,7 +2264,7 @@
           <a:p>
             <a:fld id="{5BCAD085-E8A6-8845-BD4E-CB4CCA059FC4}" type="datetimeFigureOut">
               <a:rPr lang="en-US" smtClean="0"/>
-              <a:t>1/27/13</a:t>
+              <a:t>6/13/2026</a:t>
             </a:fld>
             <a:endParaRPr lang="en-US"/>
           </a:p>
@@ -2369,10 +2367,9 @@
           </a:lstStyle>
           <a:p>
             <a:r>
-              <a:rPr lang="en-US" smtClean="0"/>
+              <a:rPr lang="en-US"/>
               <a:t>Click to edit Master title style</a:t>
             </a:r>
-            <a:endParaRPr lang="en-US"/>
           </a:p>
         </p:txBody>
       </p:sp>
@@ -2496,7 +2493,7 @@
           <a:p>
             <a:pPr lvl="0"/>
             <a:r>
-              <a:rPr lang="en-US" smtClean="0"/>
+              <a:rPr lang="en-US"/>
               <a:t>Click to edit Master text styles</a:t>
             </a:r>
           </a:p>
@@ -2519,7 +2516,7 @@
           <a:p>
             <a:fld id="{5BCAD085-E8A6-8845-BD4E-CB4CCA059FC4}" type="datetimeFigureOut">
               <a:rPr lang="en-US" smtClean="0"/>
-              <a:t>1/27/13</a:t>
+              <a:t>6/13/2026</a:t>
             </a:fld>
             <a:endParaRPr lang="en-US"/>
           </a:p>
@@ -2628,10 +2625,9 @@
           <a:lstStyle/>
           <a:p>
             <a:r>
-              <a:rPr lang="en-US" smtClean="0"/>
+              <a:rPr lang="en-US"/>
               <a:t>Click to edit Master title style</a:t>
             </a:r>
-            <a:endParaRPr lang="en-US"/>
           </a:p>
         </p:txBody>
       </p:sp>
@@ -2662,38 +2658,37 @@
           <a:p>
             <a:pPr lvl="0"/>
             <a:r>
-              <a:rPr lang="en-US" smtClean="0"/>
+              <a:rPr lang="en-US"/>
               <a:t>Click to edit Master text styles</a:t>
             </a:r>
           </a:p>
           <a:p>
             <a:pPr lvl="1"/>
             <a:r>
-              <a:rPr lang="en-US" smtClean="0"/>
+              <a:rPr lang="en-US"/>
               <a:t>Second level</a:t>
             </a:r>
           </a:p>
           <a:p>
             <a:pPr lvl="2"/>
             <a:r>
-              <a:rPr lang="en-US" smtClean="0"/>
+              <a:rPr lang="en-US"/>
               <a:t>Third level</a:t>
             </a:r>
           </a:p>
           <a:p>
             <a:pPr lvl="3"/>
             <a:r>
-              <a:rPr lang="en-US" smtClean="0"/>
+              <a:rPr lang="en-US"/>
               <a:t>Fourth level</a:t>
             </a:r>
           </a:p>
           <a:p>
             <a:pPr lvl="4"/>
             <a:r>
-              <a:rPr lang="en-US" smtClean="0"/>
+              <a:rPr lang="en-US"/>
               <a:t>Fifth level</a:t>
             </a:r>
-            <a:endParaRPr lang="en-US"/>
           </a:p>
         </p:txBody>
       </p:sp>
@@ -2732,7 +2727,7 @@
           <a:p>
             <a:fld id="{5BCAD085-E8A6-8845-BD4E-CB4CCA059FC4}" type="datetimeFigureOut">
               <a:rPr lang="en-US" smtClean="0"/>
-              <a:t>1/27/13</a:t>
+              <a:t>6/13/2026</a:t>
             </a:fld>
             <a:endParaRPr lang="en-US"/>
           </a:p>
@@ -3091,7 +3086,7 @@
 </file>
 
 <file path=ppt/slides/slide1.xml><?xml version="1.0" encoding="utf-8"?>
-<p:sld xmlns:a="http://schemas.openxmlformats.org/drawingml/2006/main" xmlns:p="http://schemas.openxmlformats.org/presentationml/2006/main" xmlns:r="http://schemas.openxmlformats.org/officeDocument/2006/relationships">
+<p:sld xmlns:a="http://schemas.openxmlformats.org/drawingml/2006/main" xmlns:r="http://schemas.openxmlformats.org/officeDocument/2006/relationships" xmlns:p="http://schemas.openxmlformats.org/presentationml/2006/main">
   <p:cSld>
     <p:spTree>
       <p:nvGrpSpPr>
@@ -3099,7 +3094,14 @@
         <p:cNvGrpSpPr/>
         <p:nvPr/>
       </p:nvGrpSpPr>
-      <p:grpSpPr/>
+      <p:grpSpPr>
+        <a:xfrm>
+          <a:off x="0" y="0"/>
+          <a:ext cx="0" cy="0"/>
+          <a:chOff x="0" y="0"/>
+          <a:chExt cx="0" cy="0"/>
+        </a:xfrm>
+      </p:grpSpPr>
       <p:sp>
         <p:nvSpPr>
           <p:cNvPr id="2" name="Rectangle 1"/>
@@ -3141,6 +3143,7 @@
           <a:lstStyle/>
           <a:p>
             <a:pPr algn="ctr"/>
+            <a:endParaRPr/>
           </a:p>
         </p:txBody>
       </p:sp>
@@ -3185,6 +3188,7 @@
           <a:lstStyle/>
           <a:p>
             <a:pPr algn="ctr"/>
+            <a:endParaRPr/>
           </a:p>
         </p:txBody>
       </p:sp>
@@ -3229,6 +3233,7 @@
           <a:lstStyle/>
           <a:p>
             <a:pPr algn="ctr"/>
+            <a:endParaRPr/>
           </a:p>
         </p:txBody>
       </p:sp>
@@ -3446,7 +3451,7 @@
 </file>
 
 <file path=ppt/slides/slide10.xml><?xml version="1.0" encoding="utf-8"?>
-<p:sld xmlns:a="http://schemas.openxmlformats.org/drawingml/2006/main" xmlns:p="http://schemas.openxmlformats.org/presentationml/2006/main" xmlns:r="http://schemas.openxmlformats.org/officeDocument/2006/relationships">
+<p:sld xmlns:a="http://schemas.openxmlformats.org/drawingml/2006/main" xmlns:r="http://schemas.openxmlformats.org/officeDocument/2006/relationships" xmlns:p="http://schemas.openxmlformats.org/presentationml/2006/main">
   <p:cSld>
     <p:spTree>
       <p:nvGrpSpPr>
@@ -3454,7 +3459,14 @@
         <p:cNvGrpSpPr/>
         <p:nvPr/>
       </p:nvGrpSpPr>
-      <p:grpSpPr/>
+      <p:grpSpPr>
+        <a:xfrm>
+          <a:off x="0" y="0"/>
+          <a:ext cx="0" cy="0"/>
+          <a:chOff x="0" y="0"/>
+          <a:chExt cx="0" cy="0"/>
+        </a:xfrm>
+      </p:grpSpPr>
       <p:sp>
         <p:nvSpPr>
           <p:cNvPr id="2" name="Rectangle 1"/>
@@ -3496,6 +3508,7 @@
           <a:lstStyle/>
           <a:p>
             <a:pPr algn="ctr"/>
+            <a:endParaRPr/>
           </a:p>
         </p:txBody>
       </p:sp>
@@ -3540,6 +3553,7 @@
           <a:lstStyle/>
           <a:p>
             <a:pPr algn="ctr"/>
+            <a:endParaRPr/>
           </a:p>
         </p:txBody>
       </p:sp>
@@ -3646,8 +3660,20 @@
                 <a:tableStyleId>{5C22544A-7EE6-4342-B048-85BDC9FD1C3A}</a:tableStyleId>
               </a:tblPr>
               <a:tblGrid>
-                <a:gridCol w="3566160"/>
-                <a:gridCol w="2286000"/>
+                <a:gridCol w="3566160">
+                  <a:extLst>
+                    <a:ext uri="{9D8B030D-6E8A-4147-A177-3AD203B41FA5}">
+                      <a16:colId xmlns:a16="http://schemas.microsoft.com/office/drawing/2014/main" val="20000"/>
+                    </a:ext>
+                  </a:extLst>
+                </a:gridCol>
+                <a:gridCol w="2286000">
+                  <a:extLst>
+                    <a:ext uri="{9D8B030D-6E8A-4147-A177-3AD203B41FA5}">
+                      <a16:colId xmlns:a16="http://schemas.microsoft.com/office/drawing/2014/main" val="20001"/>
+                    </a:ext>
+                  </a:extLst>
+                </a:gridCol>
               </a:tblGrid>
               <a:tr h="502920">
                 <a:tc>
@@ -3666,7 +3692,7 @@
                       </a:r>
                     </a:p>
                   </a:txBody>
-                  <a:tcPr marL="91440" marR="54864" marT="18288" marB="18288" anchor="ctr">
+                  <a:tcPr marR="54864" marT="18288" marB="18288" anchor="ctr">
                     <a:solidFill>
                       <a:srgbClr val="1F2937"/>
                     </a:solidFill>
@@ -3688,12 +3714,17 @@
                       </a:r>
                     </a:p>
                   </a:txBody>
-                  <a:tcPr marL="91440" marR="54864" marT="18288" marB="18288" anchor="ctr">
+                  <a:tcPr marR="54864" marT="18288" marB="18288" anchor="ctr">
                     <a:solidFill>
                       <a:srgbClr val="1F2937"/>
                     </a:solidFill>
                   </a:tcPr>
                 </a:tc>
+                <a:extLst>
+                  <a:ext uri="{0D108BD9-81ED-4DB2-BD59-A6C34878D82A}">
+                    <a16:rowId xmlns:a16="http://schemas.microsoft.com/office/drawing/2014/main" val="10000"/>
+                  </a:ext>
+                </a:extLst>
               </a:tr>
               <a:tr h="502920">
                 <a:tc>
@@ -3712,7 +3743,7 @@
                       </a:r>
                     </a:p>
                   </a:txBody>
-                  <a:tcPr marL="91440" marR="54864" marT="18288" marB="18288" anchor="ctr">
+                  <a:tcPr marR="54864" marT="18288" marB="18288" anchor="ctr">
                     <a:solidFill>
                       <a:srgbClr val="FFFFFF"/>
                     </a:solidFill>
@@ -3734,12 +3765,17 @@
                       </a:r>
                     </a:p>
                   </a:txBody>
-                  <a:tcPr marL="91440" marR="54864" marT="18288" marB="18288" anchor="ctr">
+                  <a:tcPr marR="54864" marT="18288" marB="18288" anchor="ctr">
                     <a:solidFill>
                       <a:srgbClr val="FFFFFF"/>
                     </a:solidFill>
                   </a:tcPr>
                 </a:tc>
+                <a:extLst>
+                  <a:ext uri="{0D108BD9-81ED-4DB2-BD59-A6C34878D82A}">
+                    <a16:rowId xmlns:a16="http://schemas.microsoft.com/office/drawing/2014/main" val="10001"/>
+                  </a:ext>
+                </a:extLst>
               </a:tr>
               <a:tr h="502920">
                 <a:tc>
@@ -3758,7 +3794,7 @@
                       </a:r>
                     </a:p>
                   </a:txBody>
-                  <a:tcPr marL="91440" marR="54864" marT="18288" marB="18288" anchor="ctr">
+                  <a:tcPr marR="54864" marT="18288" marB="18288" anchor="ctr">
                     <a:solidFill>
                       <a:srgbClr val="F3F4F6"/>
                     </a:solidFill>
@@ -3780,12 +3816,17 @@
                       </a:r>
                     </a:p>
                   </a:txBody>
-                  <a:tcPr marL="91440" marR="54864" marT="18288" marB="18288" anchor="ctr">
+                  <a:tcPr marR="54864" marT="18288" marB="18288" anchor="ctr">
                     <a:solidFill>
                       <a:srgbClr val="F3F4F6"/>
                     </a:solidFill>
                   </a:tcPr>
                 </a:tc>
+                <a:extLst>
+                  <a:ext uri="{0D108BD9-81ED-4DB2-BD59-A6C34878D82A}">
+                    <a16:rowId xmlns:a16="http://schemas.microsoft.com/office/drawing/2014/main" val="10002"/>
+                  </a:ext>
+                </a:extLst>
               </a:tr>
               <a:tr h="502920">
                 <a:tc>
@@ -3804,7 +3845,7 @@
                       </a:r>
                     </a:p>
                   </a:txBody>
-                  <a:tcPr marL="91440" marR="54864" marT="18288" marB="18288" anchor="ctr">
+                  <a:tcPr marR="54864" marT="18288" marB="18288" anchor="ctr">
                     <a:solidFill>
                       <a:srgbClr val="FFFFFF"/>
                     </a:solidFill>
@@ -3826,12 +3867,17 @@
                       </a:r>
                     </a:p>
                   </a:txBody>
-                  <a:tcPr marL="91440" marR="54864" marT="18288" marB="18288" anchor="ctr">
+                  <a:tcPr marR="54864" marT="18288" marB="18288" anchor="ctr">
                     <a:solidFill>
                       <a:srgbClr val="FFFFFF"/>
                     </a:solidFill>
                   </a:tcPr>
                 </a:tc>
+                <a:extLst>
+                  <a:ext uri="{0D108BD9-81ED-4DB2-BD59-A6C34878D82A}">
+                    <a16:rowId xmlns:a16="http://schemas.microsoft.com/office/drawing/2014/main" val="10003"/>
+                  </a:ext>
+                </a:extLst>
               </a:tr>
             </a:tbl>
           </a:graphicData>
@@ -3922,6 +3968,7 @@
           <a:lstStyle/>
           <a:p>
             <a:pPr algn="ctr"/>
+            <a:endParaRPr/>
           </a:p>
         </p:txBody>
       </p:sp>
@@ -4094,7 +4141,7 @@
 </file>
 
 <file path=ppt/slides/slide11.xml><?xml version="1.0" encoding="utf-8"?>
-<p:sld xmlns:a="http://schemas.openxmlformats.org/drawingml/2006/main" xmlns:p="http://schemas.openxmlformats.org/presentationml/2006/main" xmlns:r="http://schemas.openxmlformats.org/officeDocument/2006/relationships">
+<p:sld xmlns:a="http://schemas.openxmlformats.org/drawingml/2006/main" xmlns:r="http://schemas.openxmlformats.org/officeDocument/2006/relationships" xmlns:p="http://schemas.openxmlformats.org/presentationml/2006/main">
   <p:cSld>
     <p:spTree>
       <p:nvGrpSpPr>
@@ -4102,7 +4149,14 @@
         <p:cNvGrpSpPr/>
         <p:nvPr/>
       </p:nvGrpSpPr>
-      <p:grpSpPr/>
+      <p:grpSpPr>
+        <a:xfrm>
+          <a:off x="0" y="0"/>
+          <a:ext cx="0" cy="0"/>
+          <a:chOff x="0" y="0"/>
+          <a:chExt cx="0" cy="0"/>
+        </a:xfrm>
+      </p:grpSpPr>
       <p:sp>
         <p:nvSpPr>
           <p:cNvPr id="2" name="Rectangle 1"/>
@@ -4144,6 +4198,7 @@
           <a:lstStyle/>
           <a:p>
             <a:pPr algn="ctr"/>
+            <a:endParaRPr/>
           </a:p>
         </p:txBody>
       </p:sp>
@@ -4188,6 +4243,7 @@
           <a:lstStyle/>
           <a:p>
             <a:pPr algn="ctr"/>
+            <a:endParaRPr/>
           </a:p>
         </p:txBody>
       </p:sp>
@@ -4318,6 +4374,7 @@
           <a:lstStyle/>
           <a:p>
             <a:pPr algn="ctr"/>
+            <a:endParaRPr/>
           </a:p>
         </p:txBody>
       </p:sp>
@@ -4426,6 +4483,7 @@
           <a:lstStyle/>
           <a:p>
             <a:pPr algn="ctr"/>
+            <a:endParaRPr/>
           </a:p>
         </p:txBody>
       </p:sp>
@@ -4534,6 +4592,7 @@
           <a:lstStyle/>
           <a:p>
             <a:pPr algn="ctr"/>
+            <a:endParaRPr/>
           </a:p>
         </p:txBody>
       </p:sp>
@@ -4758,7 +4817,7 @@
 </file>
 
 <file path=ppt/slides/slide12.xml><?xml version="1.0" encoding="utf-8"?>
-<p:sld xmlns:a="http://schemas.openxmlformats.org/drawingml/2006/main" xmlns:p="http://schemas.openxmlformats.org/presentationml/2006/main" xmlns:r="http://schemas.openxmlformats.org/officeDocument/2006/relationships">
+<p:sld xmlns:a="http://schemas.openxmlformats.org/drawingml/2006/main" xmlns:r="http://schemas.openxmlformats.org/officeDocument/2006/relationships" xmlns:p="http://schemas.openxmlformats.org/presentationml/2006/main">
   <p:cSld>
     <p:spTree>
       <p:nvGrpSpPr>
@@ -4766,7 +4825,14 @@
         <p:cNvGrpSpPr/>
         <p:nvPr/>
       </p:nvGrpSpPr>
-      <p:grpSpPr/>
+      <p:grpSpPr>
+        <a:xfrm>
+          <a:off x="0" y="0"/>
+          <a:ext cx="0" cy="0"/>
+          <a:chOff x="0" y="0"/>
+          <a:chExt cx="0" cy="0"/>
+        </a:xfrm>
+      </p:grpSpPr>
       <p:sp>
         <p:nvSpPr>
           <p:cNvPr id="2" name="Rectangle 1"/>
@@ -4808,6 +4874,7 @@
           <a:lstStyle/>
           <a:p>
             <a:pPr algn="ctr"/>
+            <a:endParaRPr/>
           </a:p>
         </p:txBody>
       </p:sp>
@@ -4852,6 +4919,7 @@
           <a:lstStyle/>
           <a:p>
             <a:pPr algn="ctr"/>
+            <a:endParaRPr/>
           </a:p>
         </p:txBody>
       </p:sp>
@@ -4980,6 +5048,7 @@
           <a:lstStyle/>
           <a:p>
             <a:pPr algn="ctr"/>
+            <a:endParaRPr/>
           </a:p>
         </p:txBody>
       </p:sp>
@@ -5232,7 +5301,7 @@
 </file>
 
 <file path=ppt/slides/slide13.xml><?xml version="1.0" encoding="utf-8"?>
-<p:sld xmlns:a="http://schemas.openxmlformats.org/drawingml/2006/main" xmlns:p="http://schemas.openxmlformats.org/presentationml/2006/main" xmlns:r="http://schemas.openxmlformats.org/officeDocument/2006/relationships">
+<p:sld xmlns:a="http://schemas.openxmlformats.org/drawingml/2006/main" xmlns:r="http://schemas.openxmlformats.org/officeDocument/2006/relationships" xmlns:p="http://schemas.openxmlformats.org/presentationml/2006/main">
   <p:cSld>
     <p:spTree>
       <p:nvGrpSpPr>
@@ -5240,7 +5309,14 @@
         <p:cNvGrpSpPr/>
         <p:nvPr/>
       </p:nvGrpSpPr>
-      <p:grpSpPr/>
+      <p:grpSpPr>
+        <a:xfrm>
+          <a:off x="0" y="0"/>
+          <a:ext cx="0" cy="0"/>
+          <a:chOff x="0" y="0"/>
+          <a:chExt cx="0" cy="0"/>
+        </a:xfrm>
+      </p:grpSpPr>
       <p:sp>
         <p:nvSpPr>
           <p:cNvPr id="2" name="Rectangle 1"/>
@@ -5282,6 +5358,7 @@
           <a:lstStyle/>
           <a:p>
             <a:pPr algn="ctr"/>
+            <a:endParaRPr/>
           </a:p>
         </p:txBody>
       </p:sp>
@@ -5326,6 +5403,7 @@
           <a:lstStyle/>
           <a:p>
             <a:pPr algn="ctr"/>
+            <a:endParaRPr/>
           </a:p>
         </p:txBody>
       </p:sp>
@@ -5483,7 +5561,7 @@
 </file>
 
 <file path=ppt/slides/slide2.xml><?xml version="1.0" encoding="utf-8"?>
-<p:sld xmlns:a="http://schemas.openxmlformats.org/drawingml/2006/main" xmlns:p="http://schemas.openxmlformats.org/presentationml/2006/main" xmlns:r="http://schemas.openxmlformats.org/officeDocument/2006/relationships">
+<p:sld xmlns:a="http://schemas.openxmlformats.org/drawingml/2006/main" xmlns:r="http://schemas.openxmlformats.org/officeDocument/2006/relationships" xmlns:p="http://schemas.openxmlformats.org/presentationml/2006/main">
   <p:cSld>
     <p:spTree>
       <p:nvGrpSpPr>
@@ -5491,7 +5569,14 @@
         <p:cNvGrpSpPr/>
         <p:nvPr/>
       </p:nvGrpSpPr>
-      <p:grpSpPr/>
+      <p:grpSpPr>
+        <a:xfrm>
+          <a:off x="0" y="0"/>
+          <a:ext cx="0" cy="0"/>
+          <a:chOff x="0" y="0"/>
+          <a:chExt cx="0" cy="0"/>
+        </a:xfrm>
+      </p:grpSpPr>
       <p:sp>
         <p:nvSpPr>
           <p:cNvPr id="2" name="Rectangle 1"/>
@@ -5533,6 +5618,7 @@
           <a:lstStyle/>
           <a:p>
             <a:pPr algn="ctr"/>
+            <a:endParaRPr/>
           </a:p>
         </p:txBody>
       </p:sp>
@@ -5577,6 +5663,7 @@
           <a:lstStyle/>
           <a:p>
             <a:pPr algn="ctr"/>
+            <a:endParaRPr/>
           </a:p>
         </p:txBody>
       </p:sp>
@@ -5707,6 +5794,7 @@
           <a:lstStyle/>
           <a:p>
             <a:pPr algn="ctr"/>
+            <a:endParaRPr/>
           </a:p>
         </p:txBody>
       </p:sp>
@@ -5751,6 +5839,7 @@
           <a:lstStyle/>
           <a:p>
             <a:pPr algn="ctr"/>
+            <a:endParaRPr/>
           </a:p>
         </p:txBody>
       </p:sp>
@@ -5803,15 +5892,12 @@
                 <a:spcPts val="400"/>
               </a:spcAft>
             </a:pPr>
-            <a:r>
-              <a:rPr sz="900" b="0" i="0">
-                <a:solidFill>
-                  <a:srgbClr val="1F2937"/>
-                </a:solidFill>
-                <a:latin typeface="Calibri"/>
-              </a:rPr>
-              <a:t/>
-            </a:r>
+            <a:endParaRPr sz="1600" b="1" i="0">
+              <a:solidFill>
+                <a:srgbClr val="F97316"/>
+              </a:solidFill>
+              <a:latin typeface="Calibri"/>
+            </a:endParaRPr>
           </a:p>
           <a:p>
             <a:pPr algn="l">
@@ -5877,6 +5963,7 @@
           <a:lstStyle/>
           <a:p>
             <a:pPr algn="ctr"/>
+            <a:endParaRPr/>
           </a:p>
         </p:txBody>
       </p:sp>
@@ -5921,6 +6008,7 @@
           <a:lstStyle/>
           <a:p>
             <a:pPr algn="ctr"/>
+            <a:endParaRPr/>
           </a:p>
         </p:txBody>
       </p:sp>
@@ -5973,15 +6061,12 @@
                 <a:spcPts val="400"/>
               </a:spcAft>
             </a:pPr>
-            <a:r>
-              <a:rPr sz="900" b="0" i="0">
-                <a:solidFill>
-                  <a:srgbClr val="1F2937"/>
-                </a:solidFill>
-                <a:latin typeface="Calibri"/>
-              </a:rPr>
-              <a:t/>
-            </a:r>
+            <a:endParaRPr sz="1600" b="1" i="0">
+              <a:solidFill>
+                <a:srgbClr val="15803D"/>
+              </a:solidFill>
+              <a:latin typeface="Calibri"/>
+            </a:endParaRPr>
           </a:p>
           <a:p>
             <a:pPr algn="l">
@@ -6047,6 +6132,7 @@
           <a:lstStyle/>
           <a:p>
             <a:pPr algn="ctr"/>
+            <a:endParaRPr/>
           </a:p>
         </p:txBody>
       </p:sp>
@@ -6091,6 +6177,7 @@
           <a:lstStyle/>
           <a:p>
             <a:pPr algn="ctr"/>
+            <a:endParaRPr/>
           </a:p>
         </p:txBody>
       </p:sp>
@@ -6143,15 +6230,12 @@
                 <a:spcPts val="400"/>
               </a:spcAft>
             </a:pPr>
-            <a:r>
-              <a:rPr sz="900" b="0" i="0">
-                <a:solidFill>
-                  <a:srgbClr val="1F2937"/>
-                </a:solidFill>
-                <a:latin typeface="Calibri"/>
-              </a:rPr>
-              <a:t/>
-            </a:r>
+            <a:endParaRPr sz="1600" b="1" i="0">
+              <a:solidFill>
+                <a:srgbClr val="C2550B"/>
+              </a:solidFill>
+              <a:latin typeface="Calibri"/>
+            </a:endParaRPr>
           </a:p>
           <a:p>
             <a:pPr algn="l">
@@ -6267,7 +6351,7 @@
 </file>
 
 <file path=ppt/slides/slide3.xml><?xml version="1.0" encoding="utf-8"?>
-<p:sld xmlns:a="http://schemas.openxmlformats.org/drawingml/2006/main" xmlns:p="http://schemas.openxmlformats.org/presentationml/2006/main" xmlns:r="http://schemas.openxmlformats.org/officeDocument/2006/relationships">
+<p:sld xmlns:a="http://schemas.openxmlformats.org/drawingml/2006/main" xmlns:r="http://schemas.openxmlformats.org/officeDocument/2006/relationships" xmlns:p="http://schemas.openxmlformats.org/presentationml/2006/main">
   <p:cSld>
     <p:spTree>
       <p:nvGrpSpPr>
@@ -6275,7 +6359,14 @@
         <p:cNvGrpSpPr/>
         <p:nvPr/>
       </p:nvGrpSpPr>
-      <p:grpSpPr/>
+      <p:grpSpPr>
+        <a:xfrm>
+          <a:off x="0" y="0"/>
+          <a:ext cx="0" cy="0"/>
+          <a:chOff x="0" y="0"/>
+          <a:chExt cx="0" cy="0"/>
+        </a:xfrm>
+      </p:grpSpPr>
       <p:sp>
         <p:nvSpPr>
           <p:cNvPr id="2" name="Rectangle 1"/>
@@ -6317,6 +6408,7 @@
           <a:lstStyle/>
           <a:p>
             <a:pPr algn="ctr"/>
+            <a:endParaRPr/>
           </a:p>
         </p:txBody>
       </p:sp>
@@ -6361,6 +6453,7 @@
           <a:lstStyle/>
           <a:p>
             <a:pPr algn="ctr"/>
+            <a:endParaRPr/>
           </a:p>
         </p:txBody>
       </p:sp>
@@ -6551,15 +6644,12 @@
                 <a:spcPts val="300"/>
               </a:spcAft>
             </a:pPr>
-            <a:r>
-              <a:rPr sz="800" b="0" i="0">
-                <a:solidFill>
-                  <a:srgbClr val="1F2937"/>
-                </a:solidFill>
-                <a:latin typeface="Calibri"/>
-              </a:rPr>
-              <a:t/>
-            </a:r>
+            <a:endParaRPr sz="1400" b="0" i="0">
+              <a:solidFill>
+                <a:srgbClr val="1F2937"/>
+              </a:solidFill>
+              <a:latin typeface="Calibri"/>
+            </a:endParaRPr>
           </a:p>
           <a:p>
             <a:pPr algn="l">
@@ -6601,8 +6691,20 @@
                 <a:tableStyleId>{5C22544A-7EE6-4342-B048-85BDC9FD1C3A}</a:tableStyleId>
               </a:tblPr>
               <a:tblGrid>
-                <a:gridCol w="2834640"/>
-                <a:gridCol w="1188720"/>
+                <a:gridCol w="2834640">
+                  <a:extLst>
+                    <a:ext uri="{9D8B030D-6E8A-4147-A177-3AD203B41FA5}">
+                      <a16:colId xmlns:a16="http://schemas.microsoft.com/office/drawing/2014/main" val="20000"/>
+                    </a:ext>
+                  </a:extLst>
+                </a:gridCol>
+                <a:gridCol w="1188720">
+                  <a:extLst>
+                    <a:ext uri="{9D8B030D-6E8A-4147-A177-3AD203B41FA5}">
+                      <a16:colId xmlns:a16="http://schemas.microsoft.com/office/drawing/2014/main" val="20001"/>
+                    </a:ext>
+                  </a:extLst>
+                </a:gridCol>
               </a:tblGrid>
               <a:tr h="548640">
                 <a:tc>
@@ -6621,7 +6723,7 @@
                       </a:r>
                     </a:p>
                   </a:txBody>
-                  <a:tcPr marL="91440" marR="54864" marT="18288" marB="18288" anchor="ctr">
+                  <a:tcPr marR="54864" marT="18288" marB="18288" anchor="ctr">
                     <a:solidFill>
                       <a:srgbClr val="1F2937"/>
                     </a:solidFill>
@@ -6643,12 +6745,17 @@
                       </a:r>
                     </a:p>
                   </a:txBody>
-                  <a:tcPr marL="91440" marR="54864" marT="18288" marB="18288" anchor="ctr">
+                  <a:tcPr marR="54864" marT="18288" marB="18288" anchor="ctr">
                     <a:solidFill>
                       <a:srgbClr val="1F2937"/>
                     </a:solidFill>
                   </a:tcPr>
                 </a:tc>
+                <a:extLst>
+                  <a:ext uri="{0D108BD9-81ED-4DB2-BD59-A6C34878D82A}">
+                    <a16:rowId xmlns:a16="http://schemas.microsoft.com/office/drawing/2014/main" val="10000"/>
+                  </a:ext>
+                </a:extLst>
               </a:tr>
               <a:tr h="548640">
                 <a:tc>
@@ -6667,7 +6774,7 @@
                       </a:r>
                     </a:p>
                   </a:txBody>
-                  <a:tcPr marL="91440" marR="54864" marT="18288" marB="18288" anchor="ctr">
+                  <a:tcPr marR="54864" marT="18288" marB="18288" anchor="ctr">
                     <a:solidFill>
                       <a:srgbClr val="FFFFFF"/>
                     </a:solidFill>
@@ -6689,12 +6796,17 @@
                       </a:r>
                     </a:p>
                   </a:txBody>
-                  <a:tcPr marL="91440" marR="54864" marT="18288" marB="18288" anchor="ctr">
+                  <a:tcPr marR="54864" marT="18288" marB="18288" anchor="ctr">
                     <a:solidFill>
                       <a:srgbClr val="FFFFFF"/>
                     </a:solidFill>
                   </a:tcPr>
                 </a:tc>
+                <a:extLst>
+                  <a:ext uri="{0D108BD9-81ED-4DB2-BD59-A6C34878D82A}">
+                    <a16:rowId xmlns:a16="http://schemas.microsoft.com/office/drawing/2014/main" val="10001"/>
+                  </a:ext>
+                </a:extLst>
               </a:tr>
               <a:tr h="548640">
                 <a:tc>
@@ -6713,7 +6825,7 @@
                       </a:r>
                     </a:p>
                   </a:txBody>
-                  <a:tcPr marL="91440" marR="54864" marT="18288" marB="18288" anchor="ctr">
+                  <a:tcPr marR="54864" marT="18288" marB="18288" anchor="ctr">
                     <a:solidFill>
                       <a:srgbClr val="F3F4F6"/>
                     </a:solidFill>
@@ -6735,12 +6847,17 @@
                       </a:r>
                     </a:p>
                   </a:txBody>
-                  <a:tcPr marL="91440" marR="54864" marT="18288" marB="18288" anchor="ctr">
+                  <a:tcPr marR="54864" marT="18288" marB="18288" anchor="ctr">
                     <a:solidFill>
                       <a:srgbClr val="F3F4F6"/>
                     </a:solidFill>
                   </a:tcPr>
                 </a:tc>
+                <a:extLst>
+                  <a:ext uri="{0D108BD9-81ED-4DB2-BD59-A6C34878D82A}">
+                    <a16:rowId xmlns:a16="http://schemas.microsoft.com/office/drawing/2014/main" val="10002"/>
+                  </a:ext>
+                </a:extLst>
               </a:tr>
               <a:tr h="548640">
                 <a:tc>
@@ -6759,7 +6876,7 @@
                       </a:r>
                     </a:p>
                   </a:txBody>
-                  <a:tcPr marL="91440" marR="54864" marT="18288" marB="18288" anchor="ctr">
+                  <a:tcPr marR="54864" marT="18288" marB="18288" anchor="ctr">
                     <a:solidFill>
                       <a:srgbClr val="FFFFFF"/>
                     </a:solidFill>
@@ -6781,12 +6898,17 @@
                       </a:r>
                     </a:p>
                   </a:txBody>
-                  <a:tcPr marL="91440" marR="54864" marT="18288" marB="18288" anchor="ctr">
+                  <a:tcPr marR="54864" marT="18288" marB="18288" anchor="ctr">
                     <a:solidFill>
                       <a:srgbClr val="FFFFFF"/>
                     </a:solidFill>
                   </a:tcPr>
                 </a:tc>
+                <a:extLst>
+                  <a:ext uri="{0D108BD9-81ED-4DB2-BD59-A6C34878D82A}">
+                    <a16:rowId xmlns:a16="http://schemas.microsoft.com/office/drawing/2014/main" val="10003"/>
+                  </a:ext>
+                </a:extLst>
               </a:tr>
             </a:tbl>
           </a:graphicData>
@@ -6885,7 +7007,7 @@
 </file>
 
 <file path=ppt/slides/slide4.xml><?xml version="1.0" encoding="utf-8"?>
-<p:sld xmlns:a="http://schemas.openxmlformats.org/drawingml/2006/main" xmlns:p="http://schemas.openxmlformats.org/presentationml/2006/main" xmlns:r="http://schemas.openxmlformats.org/officeDocument/2006/relationships">
+<p:sld xmlns:a="http://schemas.openxmlformats.org/drawingml/2006/main" xmlns:r="http://schemas.openxmlformats.org/officeDocument/2006/relationships" xmlns:p="http://schemas.openxmlformats.org/presentationml/2006/main">
   <p:cSld>
     <p:spTree>
       <p:nvGrpSpPr>
@@ -6893,7 +7015,14 @@
         <p:cNvGrpSpPr/>
         <p:nvPr/>
       </p:nvGrpSpPr>
-      <p:grpSpPr/>
+      <p:grpSpPr>
+        <a:xfrm>
+          <a:off x="0" y="0"/>
+          <a:ext cx="0" cy="0"/>
+          <a:chOff x="0" y="0"/>
+          <a:chExt cx="0" cy="0"/>
+        </a:xfrm>
+      </p:grpSpPr>
       <p:sp>
         <p:nvSpPr>
           <p:cNvPr id="2" name="Rectangle 1"/>
@@ -6935,6 +7064,7 @@
           <a:lstStyle/>
           <a:p>
             <a:pPr algn="ctr"/>
+            <a:endParaRPr/>
           </a:p>
         </p:txBody>
       </p:sp>
@@ -6979,6 +7109,7 @@
           <a:lstStyle/>
           <a:p>
             <a:pPr algn="ctr"/>
+            <a:endParaRPr/>
           </a:p>
         </p:txBody>
       </p:sp>
@@ -7107,6 +7238,7 @@
           <a:lstStyle/>
           <a:p>
             <a:pPr algn="ctr"/>
+            <a:endParaRPr/>
           </a:p>
         </p:txBody>
       </p:sp>
@@ -7151,6 +7283,7 @@
           <a:lstStyle/>
           <a:p>
             <a:pPr algn="ctr"/>
+            <a:endParaRPr/>
           </a:p>
         </p:txBody>
       </p:sp>
@@ -7203,15 +7336,12 @@
                 <a:spcPts val="400"/>
               </a:spcAft>
             </a:pPr>
-            <a:r>
-              <a:rPr sz="600" b="0" i="0">
-                <a:solidFill>
-                  <a:srgbClr val="1F2937"/>
-                </a:solidFill>
-                <a:latin typeface="Calibri"/>
-              </a:rPr>
-              <a:t/>
-            </a:r>
+            <a:endParaRPr sz="1500" b="1" i="0">
+              <a:solidFill>
+                <a:srgbClr val="C2550B"/>
+              </a:solidFill>
+              <a:latin typeface="Calibri"/>
+            </a:endParaRPr>
           </a:p>
           <a:p>
             <a:pPr algn="l">
@@ -7275,6 +7405,7 @@
           <a:lstStyle/>
           <a:p>
             <a:pPr algn="ctr"/>
+            <a:endParaRPr/>
           </a:p>
         </p:txBody>
       </p:sp>
@@ -7319,6 +7450,7 @@
           <a:lstStyle/>
           <a:p>
             <a:pPr algn="ctr"/>
+            <a:endParaRPr/>
           </a:p>
         </p:txBody>
       </p:sp>
@@ -7371,15 +7503,12 @@
                 <a:spcPts val="400"/>
               </a:spcAft>
             </a:pPr>
-            <a:r>
-              <a:rPr sz="600" b="0" i="0">
-                <a:solidFill>
-                  <a:srgbClr val="1F2937"/>
-                </a:solidFill>
-                <a:latin typeface="Calibri"/>
-              </a:rPr>
-              <a:t/>
-            </a:r>
+            <a:endParaRPr sz="1500" b="1" i="0">
+              <a:solidFill>
+                <a:srgbClr val="C2550B"/>
+              </a:solidFill>
+              <a:latin typeface="Calibri"/>
+            </a:endParaRPr>
           </a:p>
           <a:p>
             <a:pPr algn="l">
@@ -7443,6 +7572,7 @@
           <a:lstStyle/>
           <a:p>
             <a:pPr algn="ctr"/>
+            <a:endParaRPr/>
           </a:p>
         </p:txBody>
       </p:sp>
@@ -7487,6 +7617,7 @@
           <a:lstStyle/>
           <a:p>
             <a:pPr algn="ctr"/>
+            <a:endParaRPr/>
           </a:p>
         </p:txBody>
       </p:sp>
@@ -7539,15 +7670,12 @@
                 <a:spcPts val="400"/>
               </a:spcAft>
             </a:pPr>
-            <a:r>
-              <a:rPr sz="600" b="0" i="0">
-                <a:solidFill>
-                  <a:srgbClr val="1F2937"/>
-                </a:solidFill>
-                <a:latin typeface="Calibri"/>
-              </a:rPr>
-              <a:t/>
-            </a:r>
+            <a:endParaRPr sz="1500" b="1" i="0">
+              <a:solidFill>
+                <a:srgbClr val="C2550B"/>
+              </a:solidFill>
+              <a:latin typeface="Calibri"/>
+            </a:endParaRPr>
           </a:p>
           <a:p>
             <a:pPr algn="l">
@@ -7611,6 +7739,7 @@
           <a:lstStyle/>
           <a:p>
             <a:pPr algn="ctr"/>
+            <a:endParaRPr/>
           </a:p>
         </p:txBody>
       </p:sp>
@@ -7655,6 +7784,7 @@
           <a:lstStyle/>
           <a:p>
             <a:pPr algn="ctr"/>
+            <a:endParaRPr/>
           </a:p>
         </p:txBody>
       </p:sp>
@@ -7707,15 +7837,12 @@
                 <a:spcPts val="400"/>
               </a:spcAft>
             </a:pPr>
-            <a:r>
-              <a:rPr sz="600" b="0" i="0">
-                <a:solidFill>
-                  <a:srgbClr val="1F2937"/>
-                </a:solidFill>
-                <a:latin typeface="Calibri"/>
-              </a:rPr>
-              <a:t/>
-            </a:r>
+            <a:endParaRPr sz="1500" b="1" i="0">
+              <a:solidFill>
+                <a:srgbClr val="C2550B"/>
+              </a:solidFill>
+              <a:latin typeface="Calibri"/>
+            </a:endParaRPr>
           </a:p>
           <a:p>
             <a:pPr algn="l">
@@ -7789,7 +7916,7 @@
 </file>
 
 <file path=ppt/slides/slide5.xml><?xml version="1.0" encoding="utf-8"?>
-<p:sld xmlns:a="http://schemas.openxmlformats.org/drawingml/2006/main" xmlns:p="http://schemas.openxmlformats.org/presentationml/2006/main" xmlns:r="http://schemas.openxmlformats.org/officeDocument/2006/relationships">
+<p:sld xmlns:a="http://schemas.openxmlformats.org/drawingml/2006/main" xmlns:r="http://schemas.openxmlformats.org/officeDocument/2006/relationships" xmlns:p="http://schemas.openxmlformats.org/presentationml/2006/main">
   <p:cSld>
     <p:spTree>
       <p:nvGrpSpPr>
@@ -7797,7 +7924,14 @@
         <p:cNvGrpSpPr/>
         <p:nvPr/>
       </p:nvGrpSpPr>
-      <p:grpSpPr/>
+      <p:grpSpPr>
+        <a:xfrm>
+          <a:off x="0" y="0"/>
+          <a:ext cx="0" cy="0"/>
+          <a:chOff x="0" y="0"/>
+          <a:chExt cx="0" cy="0"/>
+        </a:xfrm>
+      </p:grpSpPr>
       <p:sp>
         <p:nvSpPr>
           <p:cNvPr id="2" name="Rectangle 1"/>
@@ -7839,6 +7973,7 @@
           <a:lstStyle/>
           <a:p>
             <a:pPr algn="ctr"/>
+            <a:endParaRPr/>
           </a:p>
         </p:txBody>
       </p:sp>
@@ -7883,6 +8018,7 @@
           <a:lstStyle/>
           <a:p>
             <a:pPr algn="ctr"/>
+            <a:endParaRPr/>
           </a:p>
         </p:txBody>
       </p:sp>
@@ -8011,6 +8147,7 @@
           <a:lstStyle/>
           <a:p>
             <a:pPr algn="ctr"/>
+            <a:endParaRPr/>
           </a:p>
         </p:txBody>
       </p:sp>
@@ -8139,6 +8276,7 @@
           <a:lstStyle/>
           <a:p>
             <a:pPr algn="ctr"/>
+            <a:endParaRPr/>
           </a:p>
         </p:txBody>
       </p:sp>
@@ -8267,6 +8405,7 @@
           <a:lstStyle/>
           <a:p>
             <a:pPr algn="ctr"/>
+            <a:endParaRPr/>
           </a:p>
         </p:txBody>
       </p:sp>
@@ -8395,6 +8534,7 @@
           <a:lstStyle/>
           <a:p>
             <a:pPr algn="ctr"/>
+            <a:endParaRPr/>
           </a:p>
         </p:txBody>
       </p:sp>
@@ -8523,6 +8663,7 @@
           <a:lstStyle/>
           <a:p>
             <a:pPr algn="ctr"/>
+            <a:endParaRPr/>
           </a:p>
         </p:txBody>
       </p:sp>
@@ -8651,6 +8792,7 @@
           <a:lstStyle/>
           <a:p>
             <a:pPr algn="ctr"/>
+            <a:endParaRPr/>
           </a:p>
         </p:txBody>
       </p:sp>
@@ -8779,6 +8921,7 @@
           <a:lstStyle/>
           <a:p>
             <a:pPr algn="ctr"/>
+            <a:endParaRPr/>
           </a:p>
         </p:txBody>
       </p:sp>
@@ -8865,6 +9008,7 @@
           <a:lstStyle/>
           <a:p>
             <a:pPr algn="ctr"/>
+            <a:endParaRPr/>
           </a:p>
         </p:txBody>
       </p:sp>
@@ -8909,6 +9053,7 @@
           <a:lstStyle/>
           <a:p>
             <a:pPr algn="ctr"/>
+            <a:endParaRPr/>
           </a:p>
         </p:txBody>
       </p:sp>
@@ -9062,7 +9207,7 @@
 </file>
 
 <file path=ppt/slides/slide6.xml><?xml version="1.0" encoding="utf-8"?>
-<p:sld xmlns:a="http://schemas.openxmlformats.org/drawingml/2006/main" xmlns:p="http://schemas.openxmlformats.org/presentationml/2006/main" xmlns:r="http://schemas.openxmlformats.org/officeDocument/2006/relationships">
+<p:sld xmlns:a="http://schemas.openxmlformats.org/drawingml/2006/main" xmlns:r="http://schemas.openxmlformats.org/officeDocument/2006/relationships" xmlns:p="http://schemas.openxmlformats.org/presentationml/2006/main">
   <p:cSld>
     <p:spTree>
       <p:nvGrpSpPr>
@@ -9070,7 +9215,14 @@
         <p:cNvGrpSpPr/>
         <p:nvPr/>
       </p:nvGrpSpPr>
-      <p:grpSpPr/>
+      <p:grpSpPr>
+        <a:xfrm>
+          <a:off x="0" y="0"/>
+          <a:ext cx="0" cy="0"/>
+          <a:chOff x="0" y="0"/>
+          <a:chExt cx="0" cy="0"/>
+        </a:xfrm>
+      </p:grpSpPr>
       <p:sp>
         <p:nvSpPr>
           <p:cNvPr id="2" name="Rectangle 1"/>
@@ -9112,6 +9264,7 @@
           <a:lstStyle/>
           <a:p>
             <a:pPr algn="ctr"/>
+            <a:endParaRPr/>
           </a:p>
         </p:txBody>
       </p:sp>
@@ -9156,6 +9309,7 @@
           <a:lstStyle/>
           <a:p>
             <a:pPr algn="ctr"/>
+            <a:endParaRPr/>
           </a:p>
         </p:txBody>
       </p:sp>
@@ -9284,6 +9438,7 @@
           <a:lstStyle/>
           <a:p>
             <a:pPr algn="ctr"/>
+            <a:endParaRPr/>
           </a:p>
         </p:txBody>
       </p:sp>
@@ -9413,6 +9568,7 @@
           <a:lstStyle/>
           <a:p>
             <a:pPr algn="ctr"/>
+            <a:endParaRPr/>
           </a:p>
         </p:txBody>
       </p:sp>
@@ -9542,6 +9698,7 @@
           <a:lstStyle/>
           <a:p>
             <a:pPr algn="ctr"/>
+            <a:endParaRPr/>
           </a:p>
         </p:txBody>
       </p:sp>
@@ -9698,15 +9855,12 @@
                 <a:spcPts val="300"/>
               </a:spcAft>
             </a:pPr>
-            <a:r>
-              <a:rPr sz="1000" b="0" i="0">
-                <a:solidFill>
-                  <a:srgbClr val="1F2937"/>
-                </a:solidFill>
-                <a:latin typeface="Calibri"/>
-              </a:rPr>
-              <a:t/>
-            </a:r>
+            <a:endParaRPr sz="1200" b="0" i="0">
+              <a:solidFill>
+                <a:srgbClr val="6B7280"/>
+              </a:solidFill>
+              <a:latin typeface="Calibri"/>
+            </a:endParaRPr>
           </a:p>
           <a:p>
             <a:pPr algn="l">
@@ -9841,7 +9995,7 @@
 </file>
 
 <file path=ppt/slides/slide7.xml><?xml version="1.0" encoding="utf-8"?>
-<p:sld xmlns:a="http://schemas.openxmlformats.org/drawingml/2006/main" xmlns:p="http://schemas.openxmlformats.org/presentationml/2006/main" xmlns:r="http://schemas.openxmlformats.org/officeDocument/2006/relationships">
+<p:sld xmlns:a="http://schemas.openxmlformats.org/drawingml/2006/main" xmlns:r="http://schemas.openxmlformats.org/officeDocument/2006/relationships" xmlns:p="http://schemas.openxmlformats.org/presentationml/2006/main">
   <p:cSld>
     <p:spTree>
       <p:nvGrpSpPr>
@@ -9849,7 +10003,14 @@
         <p:cNvGrpSpPr/>
         <p:nvPr/>
       </p:nvGrpSpPr>
-      <p:grpSpPr/>
+      <p:grpSpPr>
+        <a:xfrm>
+          <a:off x="0" y="0"/>
+          <a:ext cx="0" cy="0"/>
+          <a:chOff x="0" y="0"/>
+          <a:chExt cx="0" cy="0"/>
+        </a:xfrm>
+      </p:grpSpPr>
       <p:sp>
         <p:nvSpPr>
           <p:cNvPr id="2" name="Rectangle 1"/>
@@ -9891,6 +10052,7 @@
           <a:lstStyle/>
           <a:p>
             <a:pPr algn="ctr"/>
+            <a:endParaRPr/>
           </a:p>
         </p:txBody>
       </p:sp>
@@ -9935,6 +10097,7 @@
           <a:lstStyle/>
           <a:p>
             <a:pPr algn="ctr"/>
+            <a:endParaRPr/>
           </a:p>
         </p:txBody>
       </p:sp>
@@ -10065,6 +10228,7 @@
           <a:lstStyle/>
           <a:p>
             <a:pPr algn="ctr"/>
+            <a:endParaRPr/>
           </a:p>
         </p:txBody>
       </p:sp>
@@ -10109,6 +10273,7 @@
           <a:lstStyle/>
           <a:p>
             <a:pPr algn="ctr"/>
+            <a:endParaRPr/>
           </a:p>
         </p:txBody>
       </p:sp>
@@ -10161,15 +10326,12 @@
                 <a:spcPts val="400"/>
               </a:spcAft>
             </a:pPr>
-            <a:r>
-              <a:rPr sz="600" b="0" i="0">
-                <a:solidFill>
-                  <a:srgbClr val="1F2937"/>
-                </a:solidFill>
-                <a:latin typeface="Calibri"/>
-              </a:rPr>
-              <a:t/>
-            </a:r>
+            <a:endParaRPr sz="1400" b="1" i="0">
+              <a:solidFill>
+                <a:srgbClr val="C2550B"/>
+              </a:solidFill>
+              <a:latin typeface="Calibri"/>
+            </a:endParaRPr>
           </a:p>
           <a:p>
             <a:pPr algn="l">
@@ -10235,6 +10397,7 @@
           <a:lstStyle/>
           <a:p>
             <a:pPr algn="ctr"/>
+            <a:endParaRPr/>
           </a:p>
         </p:txBody>
       </p:sp>
@@ -10279,6 +10442,7 @@
           <a:lstStyle/>
           <a:p>
             <a:pPr algn="ctr"/>
+            <a:endParaRPr/>
           </a:p>
         </p:txBody>
       </p:sp>
@@ -10331,15 +10495,12 @@
                 <a:spcPts val="400"/>
               </a:spcAft>
             </a:pPr>
-            <a:r>
-              <a:rPr sz="600" b="0" i="0">
-                <a:solidFill>
-                  <a:srgbClr val="1F2937"/>
-                </a:solidFill>
-                <a:latin typeface="Calibri"/>
-              </a:rPr>
-              <a:t/>
-            </a:r>
+            <a:endParaRPr sz="1400" b="1" i="0">
+              <a:solidFill>
+                <a:srgbClr val="C2550B"/>
+              </a:solidFill>
+              <a:latin typeface="Calibri"/>
+            </a:endParaRPr>
           </a:p>
           <a:p>
             <a:pPr algn="l">
@@ -10405,6 +10566,7 @@
           <a:lstStyle/>
           <a:p>
             <a:pPr algn="ctr"/>
+            <a:endParaRPr/>
           </a:p>
         </p:txBody>
       </p:sp>
@@ -10449,6 +10611,7 @@
           <a:lstStyle/>
           <a:p>
             <a:pPr algn="ctr"/>
+            <a:endParaRPr/>
           </a:p>
         </p:txBody>
       </p:sp>
@@ -10501,15 +10664,12 @@
                 <a:spcPts val="400"/>
               </a:spcAft>
             </a:pPr>
-            <a:r>
-              <a:rPr sz="600" b="0" i="0">
-                <a:solidFill>
-                  <a:srgbClr val="1F2937"/>
-                </a:solidFill>
-                <a:latin typeface="Calibri"/>
-              </a:rPr>
-              <a:t/>
-            </a:r>
+            <a:endParaRPr sz="1400" b="1" i="0">
+              <a:solidFill>
+                <a:srgbClr val="C2550B"/>
+              </a:solidFill>
+              <a:latin typeface="Calibri"/>
+            </a:endParaRPr>
           </a:p>
           <a:p>
             <a:pPr algn="l">
@@ -10575,6 +10735,7 @@
           <a:lstStyle/>
           <a:p>
             <a:pPr algn="ctr"/>
+            <a:endParaRPr/>
           </a:p>
         </p:txBody>
       </p:sp>
@@ -10619,6 +10780,7 @@
           <a:lstStyle/>
           <a:p>
             <a:pPr algn="ctr"/>
+            <a:endParaRPr/>
           </a:p>
         </p:txBody>
       </p:sp>
@@ -10671,15 +10833,12 @@
                 <a:spcPts val="400"/>
               </a:spcAft>
             </a:pPr>
-            <a:r>
-              <a:rPr sz="600" b="0" i="0">
-                <a:solidFill>
-                  <a:srgbClr val="1F2937"/>
-                </a:solidFill>
-                <a:latin typeface="Calibri"/>
-              </a:rPr>
-              <a:t/>
-            </a:r>
+            <a:endParaRPr sz="1400" b="1" i="0">
+              <a:solidFill>
+                <a:srgbClr val="C2550B"/>
+              </a:solidFill>
+              <a:latin typeface="Calibri"/>
+            </a:endParaRPr>
           </a:p>
           <a:p>
             <a:pPr algn="l">
@@ -10745,6 +10904,7 @@
           <a:lstStyle/>
           <a:p>
             <a:pPr algn="ctr"/>
+            <a:endParaRPr/>
           </a:p>
         </p:txBody>
       </p:sp>
@@ -10789,6 +10949,7 @@
           <a:lstStyle/>
           <a:p>
             <a:pPr algn="ctr"/>
+            <a:endParaRPr/>
           </a:p>
         </p:txBody>
       </p:sp>
@@ -10841,15 +11002,12 @@
                 <a:spcPts val="400"/>
               </a:spcAft>
             </a:pPr>
-            <a:r>
-              <a:rPr sz="600" b="0" i="0">
-                <a:solidFill>
-                  <a:srgbClr val="1F2937"/>
-                </a:solidFill>
-                <a:latin typeface="Calibri"/>
-              </a:rPr>
-              <a:t/>
-            </a:r>
+            <a:endParaRPr sz="1400" b="1" i="0">
+              <a:solidFill>
+                <a:srgbClr val="C2550B"/>
+              </a:solidFill>
+              <a:latin typeface="Calibri"/>
+            </a:endParaRPr>
           </a:p>
           <a:p>
             <a:pPr algn="l">
@@ -10915,6 +11073,7 @@
           <a:lstStyle/>
           <a:p>
             <a:pPr algn="ctr"/>
+            <a:endParaRPr/>
           </a:p>
         </p:txBody>
       </p:sp>
@@ -10959,6 +11118,7 @@
           <a:lstStyle/>
           <a:p>
             <a:pPr algn="ctr"/>
+            <a:endParaRPr/>
           </a:p>
         </p:txBody>
       </p:sp>
@@ -11011,15 +11171,12 @@
                 <a:spcPts val="400"/>
               </a:spcAft>
             </a:pPr>
-            <a:r>
-              <a:rPr sz="600" b="0" i="0">
-                <a:solidFill>
-                  <a:srgbClr val="1F2937"/>
-                </a:solidFill>
-                <a:latin typeface="Calibri"/>
-              </a:rPr>
-              <a:t/>
-            </a:r>
+            <a:endParaRPr sz="1400" b="1" i="0">
+              <a:solidFill>
+                <a:srgbClr val="C2550B"/>
+              </a:solidFill>
+              <a:latin typeface="Calibri"/>
+            </a:endParaRPr>
           </a:p>
           <a:p>
             <a:pPr algn="l">
@@ -11093,7 +11250,7 @@
 </file>
 
 <file path=ppt/slides/slide8.xml><?xml version="1.0" encoding="utf-8"?>
-<p:sld xmlns:a="http://schemas.openxmlformats.org/drawingml/2006/main" xmlns:p="http://schemas.openxmlformats.org/presentationml/2006/main" xmlns:r="http://schemas.openxmlformats.org/officeDocument/2006/relationships">
+<p:sld xmlns:a="http://schemas.openxmlformats.org/drawingml/2006/main" xmlns:r="http://schemas.openxmlformats.org/officeDocument/2006/relationships" xmlns:p="http://schemas.openxmlformats.org/presentationml/2006/main">
   <p:cSld>
     <p:spTree>
       <p:nvGrpSpPr>
@@ -11101,7 +11258,14 @@
         <p:cNvGrpSpPr/>
         <p:nvPr/>
       </p:nvGrpSpPr>
-      <p:grpSpPr/>
+      <p:grpSpPr>
+        <a:xfrm>
+          <a:off x="0" y="0"/>
+          <a:ext cx="0" cy="0"/>
+          <a:chOff x="0" y="0"/>
+          <a:chExt cx="0" cy="0"/>
+        </a:xfrm>
+      </p:grpSpPr>
       <p:sp>
         <p:nvSpPr>
           <p:cNvPr id="2" name="Rectangle 1"/>
@@ -11143,6 +11307,7 @@
           <a:lstStyle/>
           <a:p>
             <a:pPr algn="ctr"/>
+            <a:endParaRPr/>
           </a:p>
         </p:txBody>
       </p:sp>
@@ -11187,6 +11352,7 @@
           <a:lstStyle/>
           <a:p>
             <a:pPr algn="ctr"/>
+            <a:endParaRPr/>
           </a:p>
         </p:txBody>
       </p:sp>
@@ -11317,6 +11483,7 @@
           <a:lstStyle/>
           <a:p>
             <a:pPr algn="ctr"/>
+            <a:endParaRPr/>
           </a:p>
         </p:txBody>
       </p:sp>
@@ -11369,15 +11536,12 @@
                 <a:spcPts val="400"/>
               </a:spcAft>
             </a:pPr>
-            <a:r>
-              <a:rPr sz="600" b="0" i="0">
-                <a:solidFill>
-                  <a:srgbClr val="1F2937"/>
-                </a:solidFill>
-                <a:latin typeface="Calibri"/>
-              </a:rPr>
-              <a:t/>
-            </a:r>
+            <a:endParaRPr sz="1500" b="1" i="0">
+              <a:solidFill>
+                <a:srgbClr val="15803D"/>
+              </a:solidFill>
+              <a:latin typeface="Calibri"/>
+            </a:endParaRPr>
           </a:p>
           <a:p>
             <a:pPr algn="l">
@@ -11443,6 +11607,7 @@
           <a:lstStyle/>
           <a:p>
             <a:pPr algn="ctr"/>
+            <a:endParaRPr/>
           </a:p>
         </p:txBody>
       </p:sp>
@@ -11495,15 +11660,12 @@
                 <a:spcPts val="400"/>
               </a:spcAft>
             </a:pPr>
-            <a:r>
-              <a:rPr sz="600" b="0" i="0">
-                <a:solidFill>
-                  <a:srgbClr val="1F2937"/>
-                </a:solidFill>
-                <a:latin typeface="Calibri"/>
-              </a:rPr>
-              <a:t/>
-            </a:r>
+            <a:endParaRPr sz="1500" b="1" i="0">
+              <a:solidFill>
+                <a:srgbClr val="15803D"/>
+              </a:solidFill>
+              <a:latin typeface="Calibri"/>
+            </a:endParaRPr>
           </a:p>
           <a:p>
             <a:pPr algn="l">
@@ -11768,7 +11930,7 @@
 </file>
 
 <file path=ppt/slides/slide9.xml><?xml version="1.0" encoding="utf-8"?>
-<p:sld xmlns:a="http://schemas.openxmlformats.org/drawingml/2006/main" xmlns:p="http://schemas.openxmlformats.org/presentationml/2006/main" xmlns:r="http://schemas.openxmlformats.org/officeDocument/2006/relationships">
+<p:sld xmlns:a="http://schemas.openxmlformats.org/drawingml/2006/main" xmlns:r="http://schemas.openxmlformats.org/officeDocument/2006/relationships" xmlns:p="http://schemas.openxmlformats.org/presentationml/2006/main">
   <p:cSld>
     <p:spTree>
       <p:nvGrpSpPr>
@@ -11776,7 +11938,14 @@
         <p:cNvGrpSpPr/>
         <p:nvPr/>
       </p:nvGrpSpPr>
-      <p:grpSpPr/>
+      <p:grpSpPr>
+        <a:xfrm>
+          <a:off x="0" y="0"/>
+          <a:ext cx="0" cy="0"/>
+          <a:chOff x="0" y="0"/>
+          <a:chExt cx="0" cy="0"/>
+        </a:xfrm>
+      </p:grpSpPr>
       <p:sp>
         <p:nvSpPr>
           <p:cNvPr id="2" name="Rectangle 1"/>
@@ -11818,6 +11987,7 @@
           <a:lstStyle/>
           <a:p>
             <a:pPr algn="ctr"/>
+            <a:endParaRPr/>
           </a:p>
         </p:txBody>
       </p:sp>
@@ -11862,6 +12032,7 @@
           <a:lstStyle/>
           <a:p>
             <a:pPr algn="ctr"/>
+            <a:endParaRPr/>
           </a:p>
         </p:txBody>
       </p:sp>
@@ -11968,9 +12139,27 @@
                 <a:tableStyleId>{5C22544A-7EE6-4342-B048-85BDC9FD1C3A}</a:tableStyleId>
               </a:tblPr>
               <a:tblGrid>
-                <a:gridCol w="3108960"/>
-                <a:gridCol w="1828800"/>
-                <a:gridCol w="6035040"/>
+                <a:gridCol w="3108960">
+                  <a:extLst>
+                    <a:ext uri="{9D8B030D-6E8A-4147-A177-3AD203B41FA5}">
+                      <a16:colId xmlns:a16="http://schemas.microsoft.com/office/drawing/2014/main" val="20000"/>
+                    </a:ext>
+                  </a:extLst>
+                </a:gridCol>
+                <a:gridCol w="1828800">
+                  <a:extLst>
+                    <a:ext uri="{9D8B030D-6E8A-4147-A177-3AD203B41FA5}">
+                      <a16:colId xmlns:a16="http://schemas.microsoft.com/office/drawing/2014/main" val="20001"/>
+                    </a:ext>
+                  </a:extLst>
+                </a:gridCol>
+                <a:gridCol w="6035040">
+                  <a:extLst>
+                    <a:ext uri="{9D8B030D-6E8A-4147-A177-3AD203B41FA5}">
+                      <a16:colId xmlns:a16="http://schemas.microsoft.com/office/drawing/2014/main" val="20002"/>
+                    </a:ext>
+                  </a:extLst>
+                </a:gridCol>
               </a:tblGrid>
               <a:tr h="685800">
                 <a:tc>
@@ -11989,7 +12178,7 @@
                       </a:r>
                     </a:p>
                   </a:txBody>
-                  <a:tcPr marL="91440" marR="54864" marT="18288" marB="18288" anchor="ctr">
+                  <a:tcPr marR="54864" marT="18288" marB="18288" anchor="ctr">
                     <a:solidFill>
                       <a:srgbClr val="1F2937"/>
                     </a:solidFill>
@@ -12011,7 +12200,7 @@
                       </a:r>
                     </a:p>
                   </a:txBody>
-                  <a:tcPr marL="91440" marR="54864" marT="18288" marB="18288" anchor="ctr">
+                  <a:tcPr marR="54864" marT="18288" marB="18288" anchor="ctr">
                     <a:solidFill>
                       <a:srgbClr val="1F2937"/>
                     </a:solidFill>
@@ -12033,12 +12222,17 @@
                       </a:r>
                     </a:p>
                   </a:txBody>
-                  <a:tcPr marL="91440" marR="54864" marT="18288" marB="18288" anchor="ctr">
+                  <a:tcPr marR="54864" marT="18288" marB="18288" anchor="ctr">
                     <a:solidFill>
                       <a:srgbClr val="1F2937"/>
                     </a:solidFill>
                   </a:tcPr>
                 </a:tc>
+                <a:extLst>
+                  <a:ext uri="{0D108BD9-81ED-4DB2-BD59-A6C34878D82A}">
+                    <a16:rowId xmlns:a16="http://schemas.microsoft.com/office/drawing/2014/main" val="10000"/>
+                  </a:ext>
+                </a:extLst>
               </a:tr>
               <a:tr h="685800">
                 <a:tc>
@@ -12057,7 +12251,7 @@
                       </a:r>
                     </a:p>
                   </a:txBody>
-                  <a:tcPr marL="91440" marR="54864" marT="18288" marB="18288" anchor="ctr">
+                  <a:tcPr marR="54864" marT="18288" marB="18288" anchor="ctr">
                     <a:solidFill>
                       <a:srgbClr val="FFFFFF"/>
                     </a:solidFill>
@@ -12079,7 +12273,7 @@
                       </a:r>
                     </a:p>
                   </a:txBody>
-                  <a:tcPr marL="91440" marR="54864" marT="18288" marB="18288" anchor="ctr">
+                  <a:tcPr marR="54864" marT="18288" marB="18288" anchor="ctr">
                     <a:solidFill>
                       <a:srgbClr val="FFFFFF"/>
                     </a:solidFill>
@@ -12101,12 +12295,17 @@
                       </a:r>
                     </a:p>
                   </a:txBody>
-                  <a:tcPr marL="91440" marR="54864" marT="18288" marB="18288" anchor="ctr">
+                  <a:tcPr marR="54864" marT="18288" marB="18288" anchor="ctr">
                     <a:solidFill>
                       <a:srgbClr val="FFFFFF"/>
                     </a:solidFill>
                   </a:tcPr>
                 </a:tc>
+                <a:extLst>
+                  <a:ext uri="{0D108BD9-81ED-4DB2-BD59-A6C34878D82A}">
+                    <a16:rowId xmlns:a16="http://schemas.microsoft.com/office/drawing/2014/main" val="10001"/>
+                  </a:ext>
+                </a:extLst>
               </a:tr>
               <a:tr h="685800">
                 <a:tc>
@@ -12125,7 +12324,7 @@
                       </a:r>
                     </a:p>
                   </a:txBody>
-                  <a:tcPr marL="91440" marR="54864" marT="18288" marB="18288" anchor="ctr">
+                  <a:tcPr marR="54864" marT="18288" marB="18288" anchor="ctr">
                     <a:solidFill>
                       <a:srgbClr val="F3F4F6"/>
                     </a:solidFill>
@@ -12147,7 +12346,7 @@
                       </a:r>
                     </a:p>
                   </a:txBody>
-                  <a:tcPr marL="91440" marR="54864" marT="18288" marB="18288" anchor="ctr">
+                  <a:tcPr marR="54864" marT="18288" marB="18288" anchor="ctr">
                     <a:solidFill>
                       <a:srgbClr val="F3F4F6"/>
                     </a:solidFill>
@@ -12169,12 +12368,17 @@
                       </a:r>
                     </a:p>
                   </a:txBody>
-                  <a:tcPr marL="91440" marR="54864" marT="18288" marB="18288" anchor="ctr">
+                  <a:tcPr marR="54864" marT="18288" marB="18288" anchor="ctr">
                     <a:solidFill>
                       <a:srgbClr val="F3F4F6"/>
                     </a:solidFill>
                   </a:tcPr>
                 </a:tc>
+                <a:extLst>
+                  <a:ext uri="{0D108BD9-81ED-4DB2-BD59-A6C34878D82A}">
+                    <a16:rowId xmlns:a16="http://schemas.microsoft.com/office/drawing/2014/main" val="10002"/>
+                  </a:ext>
+                </a:extLst>
               </a:tr>
               <a:tr h="685800">
                 <a:tc>
@@ -12193,7 +12397,7 @@
                       </a:r>
                     </a:p>
                   </a:txBody>
-                  <a:tcPr marL="91440" marR="54864" marT="18288" marB="18288" anchor="ctr">
+                  <a:tcPr marR="54864" marT="18288" marB="18288" anchor="ctr">
                     <a:solidFill>
                       <a:srgbClr val="FFFFFF"/>
                     </a:solidFill>
@@ -12215,7 +12419,7 @@
                       </a:r>
                     </a:p>
                   </a:txBody>
-                  <a:tcPr marL="91440" marR="54864" marT="18288" marB="18288" anchor="ctr">
+                  <a:tcPr marR="54864" marT="18288" marB="18288" anchor="ctr">
                     <a:solidFill>
                       <a:srgbClr val="FFFFFF"/>
                     </a:solidFill>
@@ -12237,12 +12441,17 @@
                       </a:r>
                     </a:p>
                   </a:txBody>
-                  <a:tcPr marL="91440" marR="54864" marT="18288" marB="18288" anchor="ctr">
+                  <a:tcPr marR="54864" marT="18288" marB="18288" anchor="ctr">
                     <a:solidFill>
                       <a:srgbClr val="FFFFFF"/>
                     </a:solidFill>
                   </a:tcPr>
                 </a:tc>
+                <a:extLst>
+                  <a:ext uri="{0D108BD9-81ED-4DB2-BD59-A6C34878D82A}">
+                    <a16:rowId xmlns:a16="http://schemas.microsoft.com/office/drawing/2014/main" val="10003"/>
+                  </a:ext>
+                </a:extLst>
               </a:tr>
               <a:tr h="685800">
                 <a:tc>
@@ -12261,7 +12470,7 @@
                       </a:r>
                     </a:p>
                   </a:txBody>
-                  <a:tcPr marL="91440" marR="54864" marT="18288" marB="18288" anchor="ctr">
+                  <a:tcPr marR="54864" marT="18288" marB="18288" anchor="ctr">
                     <a:solidFill>
                       <a:srgbClr val="F3F4F6"/>
                     </a:solidFill>
@@ -12283,7 +12492,7 @@
                       </a:r>
                     </a:p>
                   </a:txBody>
-                  <a:tcPr marL="91440" marR="54864" marT="18288" marB="18288" anchor="ctr">
+                  <a:tcPr marR="54864" marT="18288" marB="18288" anchor="ctr">
                     <a:solidFill>
                       <a:srgbClr val="F3F4F6"/>
                     </a:solidFill>
@@ -12305,12 +12514,17 @@
                       </a:r>
                     </a:p>
                   </a:txBody>
-                  <a:tcPr marL="91440" marR="54864" marT="18288" marB="18288" anchor="ctr">
+                  <a:tcPr marR="54864" marT="18288" marB="18288" anchor="ctr">
                     <a:solidFill>
                       <a:srgbClr val="F3F4F6"/>
                     </a:solidFill>
                   </a:tcPr>
                 </a:tc>
+                <a:extLst>
+                  <a:ext uri="{0D108BD9-81ED-4DB2-BD59-A6C34878D82A}">
+                    <a16:rowId xmlns:a16="http://schemas.microsoft.com/office/drawing/2014/main" val="10004"/>
+                  </a:ext>
+                </a:extLst>
               </a:tr>
               <a:tr h="685800">
                 <a:tc>
@@ -12329,7 +12543,7 @@
                       </a:r>
                     </a:p>
                   </a:txBody>
-                  <a:tcPr marL="91440" marR="54864" marT="18288" marB="18288" anchor="ctr">
+                  <a:tcPr marR="54864" marT="18288" marB="18288" anchor="ctr">
                     <a:solidFill>
                       <a:srgbClr val="FFFFFF"/>
                     </a:solidFill>
@@ -12351,7 +12565,7 @@
                       </a:r>
                     </a:p>
                   </a:txBody>
-                  <a:tcPr marL="91440" marR="54864" marT="18288" marB="18288" anchor="ctr">
+                  <a:tcPr marR="54864" marT="18288" marB="18288" anchor="ctr">
                     <a:solidFill>
                       <a:srgbClr val="FFFFFF"/>
                     </a:solidFill>
@@ -12373,12 +12587,17 @@
                       </a:r>
                     </a:p>
                   </a:txBody>
-                  <a:tcPr marL="91440" marR="54864" marT="18288" marB="18288" anchor="ctr">
+                  <a:tcPr marR="54864" marT="18288" marB="18288" anchor="ctr">
                     <a:solidFill>
                       <a:srgbClr val="FFFFFF"/>
                     </a:solidFill>
                   </a:tcPr>
                 </a:tc>
+                <a:extLst>
+                  <a:ext uri="{0D108BD9-81ED-4DB2-BD59-A6C34878D82A}">
+                    <a16:rowId xmlns:a16="http://schemas.microsoft.com/office/drawing/2014/main" val="10005"/>
+                  </a:ext>
+                </a:extLst>
               </a:tr>
             </a:tbl>
           </a:graphicData>

</xml_diff>